<commit_message>
docs: rewrite chatbot deck for executive committee and budget
Co-authored-by: deboraq <deboraq@users.noreply.github.com>
</commit_message>
<xml_diff>
--- a/docs/Presentacion_Chatbot_RRHH_Bacar.pptx
+++ b/docs/Presentacion_Chatbot_RRHH_Bacar.pptx
@@ -14,6 +14,7 @@
     <p:sldId id="262" r:id="rId13"/>
     <p:sldId id="263" r:id="rId14"/>
     <p:sldId id="264" r:id="rId15"/>
+    <p:sldId id="265" r:id="rId16"/>
   </p:sldIdLst>
   <p:sldSz cx="12191695" cy="6858000" type="screen4x3"/>
   <p:notesSz cx="6858000" cy="9144000"/>
@@ -3092,7 +3093,7 @@
     <p:bg>
       <p:bgPr>
         <a:solidFill>
-          <a:srgbClr val="F4F7FD"/>
+          <a:srgbClr val="F5F8FE"/>
         </a:solidFill>
         <a:effectLst/>
       </p:bgPr>
@@ -3113,13 +3114,13 @@
         <p:spPr>
           <a:xfrm>
             <a:off x="0" y="0"/>
-            <a:ext cx="12191695" cy="658368"/>
+            <a:ext cx="12191695" cy="640080"/>
           </a:xfrm>
           <a:prstGeom prst="rect">
             <a:avLst/>
           </a:prstGeom>
           <a:solidFill>
-            <a:srgbClr val="112D66"/>
+            <a:srgbClr val="143475"/>
           </a:solidFill>
           <a:ln>
             <a:noFill/>
@@ -3155,8 +3156,8 @@
         </p:nvSpPr>
         <p:spPr>
           <a:xfrm>
-            <a:off x="411480" y="109728"/>
-            <a:ext cx="6858000" cy="365760"/>
+            <a:off x="457200" y="109728"/>
+            <a:ext cx="6858000" cy="320040"/>
           </a:xfrm>
           <a:prstGeom prst="rect">
             <a:avLst/>
@@ -3170,7 +3171,7 @@
           <a:lstStyle/>
           <a:p>
             <a:pPr algn="l">
-              <a:defRPr sz="1600" b="1">
+              <a:defRPr sz="1600" b="1" u="none">
                 <a:solidFill>
                   <a:srgbClr val="FFFFFF"/>
                 </a:solidFill>
@@ -3191,8 +3192,8 @@
         </p:nvSpPr>
         <p:spPr>
           <a:xfrm>
-            <a:off x="731520" y="1371600"/>
-            <a:ext cx="10789920" cy="1645920"/>
+            <a:off x="731520" y="1325880"/>
+            <a:ext cx="10789920" cy="1280160"/>
           </a:xfrm>
           <a:prstGeom prst="rect">
             <a:avLst/>
@@ -3200,15 +3201,15 @@
           <a:noFill/>
         </p:spPr>
         <p:txBody>
-          <a:bodyPr wrap="none">
+          <a:bodyPr wrap="square">
             <a:spAutoFit/>
           </a:bodyPr>
           <a:lstStyle/>
           <a:p>
             <a:pPr algn="l">
-              <a:defRPr sz="4400" b="1">
-                <a:solidFill>
-                  <a:srgbClr val="112D66"/>
+              <a:defRPr sz="3400" b="1" u="none">
+                <a:solidFill>
+                  <a:srgbClr val="143475"/>
                 </a:solidFill>
                 <a:latin typeface="Calibri"/>
               </a:defRPr>
@@ -3219,15 +3220,15 @@
           </a:p>
           <a:p>
             <a:pPr algn="l">
-              <a:defRPr sz="2800" b="1">
-                <a:solidFill>
-                  <a:srgbClr val="275DD2"/>
-                </a:solidFill>
-                <a:latin typeface="Calibri"/>
-              </a:defRPr>
-            </a:pPr>
-            <a:r>
-              <a:t>EL CIRCUITO DE ATENCIÓN INTELIGENTE</a:t>
+              <a:defRPr sz="1800" b="0" u="none">
+                <a:solidFill>
+                  <a:srgbClr val="566177"/>
+                </a:solidFill>
+                <a:latin typeface="Calibri"/>
+              </a:defRPr>
+            </a:pPr>
+            <a:r>
+              <a:t>Propuesta ejecutiva para mejorar servicio al colaborador y eficiencia operativa</a:t>
             </a:r>
           </a:p>
         </p:txBody>
@@ -3240,8 +3241,8 @@
         </p:nvSpPr>
         <p:spPr>
           <a:xfrm>
-            <a:off x="822960" y="3200400"/>
-            <a:ext cx="10241280" cy="1371600"/>
+            <a:off x="822960" y="2514600"/>
+            <a:ext cx="10515600" cy="1463040"/>
           </a:xfrm>
           <a:prstGeom prst="rect">
             <a:avLst/>
@@ -3249,21 +3250,47 @@
           <a:noFill/>
         </p:spPr>
         <p:txBody>
-          <a:bodyPr wrap="none">
+          <a:bodyPr wrap="square">
             <a:spAutoFit/>
           </a:bodyPr>
           <a:lstStyle/>
           <a:p>
             <a:pPr algn="l">
-              <a:defRPr sz="2000" b="0">
-                <a:solidFill>
-                  <a:srgbClr val="505C70"/>
-                </a:solidFill>
-                <a:latin typeface="Calibri"/>
-              </a:defRPr>
-            </a:pPr>
-            <a:r>
-              <a:t>Una solución omnicanal para responder consultas de colaboradores, derivar a RRHH en tiempo real y escalar a múltiples empresas/sucursales.</a:t>
+              <a:defRPr sz="1900" b="0" u="none">
+                <a:solidFill>
+                  <a:srgbClr val="16213A"/>
+                </a:solidFill>
+                <a:latin typeface="Calibri"/>
+              </a:defRPr>
+            </a:pPr>
+            <a:r>
+              <a:t>• Atención rápida y consistente para consultas frecuentes</a:t>
+            </a:r>
+          </a:p>
+          <a:p>
+            <a:pPr algn="l">
+              <a:defRPr sz="1900" b="0" u="none">
+                <a:solidFill>
+                  <a:srgbClr val="16213A"/>
+                </a:solidFill>
+                <a:latin typeface="Calibri"/>
+              </a:defRPr>
+            </a:pPr>
+            <a:r>
+              <a:t>• Escalamiento directo a RRHH cuando la consulta requiere intervención humana</a:t>
+            </a:r>
+          </a:p>
+          <a:p>
+            <a:pPr algn="l">
+              <a:defRPr sz="1900" b="0" u="none">
+                <a:solidFill>
+                  <a:srgbClr val="16213A"/>
+                </a:solidFill>
+                <a:latin typeface="Calibri"/>
+              </a:defRPr>
+            </a:pPr>
+            <a:r>
+              <a:t>• Operación por empresa/sucursal con trazabilidad completa</a:t>
             </a:r>
           </a:p>
         </p:txBody>
@@ -3276,14 +3303,14 @@
         </p:nvSpPr>
         <p:spPr>
           <a:xfrm>
-            <a:off x="822960" y="4983480"/>
-            <a:ext cx="3749039" cy="548640"/>
+            <a:off x="822960" y="4754880"/>
+            <a:ext cx="4754880" cy="566928"/>
           </a:xfrm>
           <a:prstGeom prst="roundRect">
             <a:avLst/>
           </a:prstGeom>
           <a:solidFill>
-            <a:srgbClr val="148F68"/>
+            <a:srgbClr val="15946E"/>
           </a:solidFill>
           <a:ln>
             <a:noFill/>
@@ -3304,11 +3331,116 @@
           </a:fontRef>
         </p:style>
         <p:txBody>
+          <a:bodyPr rtlCol="0" anchor="ctr" wrap="square"/>
+          <a:lstStyle/>
+          <a:p>
+            <a:pPr algn="ctr">
+              <a:defRPr sz="1500" b="1" u="none">
+                <a:solidFill>
+                  <a:srgbClr val="FFFFFF"/>
+                </a:solidFill>
+                <a:latin typeface="Calibri"/>
+              </a:defRPr>
+            </a:pPr>
+            <a:r>
+              <a:t>Objetivo: aprobar implementación productiva</a:t>
+            </a:r>
+          </a:p>
+        </p:txBody>
+      </p:sp>
+    </p:spTree>
+  </p:cSld>
+  <p:clrMapOvr>
+    <a:masterClrMapping/>
+  </p:clrMapOvr>
+</p:sld>
+</file>
+
+<file path=ppt/slides/slide10.xml><?xml version="1.0" encoding="utf-8"?>
+<p:sld xmlns:a="http://schemas.openxmlformats.org/drawingml/2006/main" xmlns:p="http://schemas.openxmlformats.org/presentationml/2006/main" xmlns:r="http://schemas.openxmlformats.org/officeDocument/2006/relationships">
+  <p:cSld>
+    <p:bg>
+      <p:bgPr>
+        <a:solidFill>
+          <a:srgbClr val="F5F8FE"/>
+        </a:solidFill>
+        <a:effectLst/>
+      </p:bgPr>
+    </p:bg>
+    <p:spTree>
+      <p:nvGrpSpPr>
+        <p:cNvPr id="1" name=""/>
+        <p:cNvGrpSpPr/>
+        <p:nvPr/>
+      </p:nvGrpSpPr>
+      <p:grpSpPr/>
+      <p:sp>
+        <p:nvSpPr>
+          <p:cNvPr id="2" name="Rectangle 1"/>
+          <p:cNvSpPr/>
+          <p:nvPr/>
+        </p:nvSpPr>
+        <p:spPr>
+          <a:xfrm>
+            <a:off x="0" y="0"/>
+            <a:ext cx="12191695" cy="640080"/>
+          </a:xfrm>
+          <a:prstGeom prst="rect">
+            <a:avLst/>
+          </a:prstGeom>
+          <a:solidFill>
+            <a:srgbClr val="143475"/>
+          </a:solidFill>
+          <a:ln>
+            <a:noFill/>
+          </a:ln>
+        </p:spPr>
+        <p:style>
+          <a:lnRef idx="1">
+            <a:schemeClr val="accent1"/>
+          </a:lnRef>
+          <a:fillRef idx="3">
+            <a:schemeClr val="accent1"/>
+          </a:fillRef>
+          <a:effectRef idx="2">
+            <a:schemeClr val="accent1"/>
+          </a:effectRef>
+          <a:fontRef idx="minor">
+            <a:schemeClr val="lt1"/>
+          </a:fontRef>
+        </p:style>
+        <p:txBody>
           <a:bodyPr rtlCol="0" anchor="ctr"/>
           <a:lstStyle/>
           <a:p>
-            <a:pPr algn="ctr">
-              <a:defRPr sz="1600" b="1">
+            <a:pPr algn="ctr"/>
+          </a:p>
+        </p:txBody>
+      </p:sp>
+      <p:sp>
+        <p:nvSpPr>
+          <p:cNvPr id="3" name="TextBox 2"/>
+          <p:cNvSpPr txBox="1"/>
+          <p:nvPr/>
+        </p:nvSpPr>
+        <p:spPr>
+          <a:xfrm>
+            <a:off x="457200" y="109728"/>
+            <a:ext cx="6858000" cy="320040"/>
+          </a:xfrm>
+          <a:prstGeom prst="rect">
+            <a:avLst/>
+          </a:prstGeom>
+          <a:noFill/>
+        </p:spPr>
+        <p:txBody>
+          <a:bodyPr wrap="none">
+            <a:spAutoFit/>
+          </a:bodyPr>
+          <a:lstStyle/>
+          <a:p>
+            <a:pPr algn="l">
+              <a:defRPr sz="1600" b="1" u="none">
                 <a:solidFill>
                   <a:srgbClr val="FFFFFF"/>
                 </a:solidFill>
@@ -3316,7 +3448,257 @@
               </a:defRPr>
             </a:pPr>
             <a:r>
-              <a:t>Estado actual: MVP operativo</a:t>
+              <a:t>BacarIT  |  Chatbot RRHH</a:t>
+            </a:r>
+          </a:p>
+        </p:txBody>
+      </p:sp>
+      <p:sp>
+        <p:nvSpPr>
+          <p:cNvPr id="4" name="TextBox 3"/>
+          <p:cNvSpPr txBox="1"/>
+          <p:nvPr/>
+        </p:nvSpPr>
+        <p:spPr>
+          <a:xfrm>
+            <a:off x="731520" y="914400"/>
+            <a:ext cx="10789920" cy="1280160"/>
+          </a:xfrm>
+          <a:prstGeom prst="rect">
+            <a:avLst/>
+          </a:prstGeom>
+          <a:noFill/>
+        </p:spPr>
+        <p:txBody>
+          <a:bodyPr wrap="square">
+            <a:spAutoFit/>
+          </a:bodyPr>
+          <a:lstStyle/>
+          <a:p>
+            <a:pPr algn="l">
+              <a:defRPr sz="3400" b="1" u="none">
+                <a:solidFill>
+                  <a:srgbClr val="143475"/>
+                </a:solidFill>
+                <a:latin typeface="Calibri"/>
+              </a:defRPr>
+            </a:pPr>
+            <a:r>
+              <a:t>Decisión solicitada al Comité Ejecutivo</a:t>
+            </a:r>
+          </a:p>
+        </p:txBody>
+      </p:sp>
+      <p:sp>
+        <p:nvSpPr>
+          <p:cNvPr id="5" name="Rounded Rectangle 4"/>
+          <p:cNvSpPr/>
+          <p:nvPr/>
+        </p:nvSpPr>
+        <p:spPr>
+          <a:xfrm>
+            <a:off x="731520" y="1965960"/>
+            <a:ext cx="5303520" cy="3840480"/>
+          </a:xfrm>
+          <a:prstGeom prst="roundRect">
+            <a:avLst/>
+          </a:prstGeom>
+          <a:solidFill>
+            <a:srgbClr val="FFFFFF"/>
+          </a:solidFill>
+          <a:ln>
+            <a:solidFill>
+              <a:srgbClr val="D8E2F3"/>
+            </a:solidFill>
+          </a:ln>
+        </p:spPr>
+        <p:style>
+          <a:lnRef idx="1">
+            <a:schemeClr val="accent1"/>
+          </a:lnRef>
+          <a:fillRef idx="3">
+            <a:schemeClr val="accent1"/>
+          </a:fillRef>
+          <a:effectRef idx="2">
+            <a:schemeClr val="accent1"/>
+          </a:effectRef>
+          <a:fontRef idx="minor">
+            <a:schemeClr val="lt1"/>
+          </a:fontRef>
+        </p:style>
+        <p:txBody>
+          <a:bodyPr rtlCol="0" anchor="ctr" wrap="square"/>
+          <a:lstStyle/>
+          <a:p>
+            <a:pPr algn="l">
+              <a:defRPr sz="2000" b="1" u="none">
+                <a:solidFill>
+                  <a:srgbClr val="E8931F"/>
+                </a:solidFill>
+                <a:latin typeface="Calibri"/>
+              </a:defRPr>
+            </a:pPr>
+            <a:r>
+              <a:t>Aprobaciones requeridas</a:t>
+            </a:r>
+          </a:p>
+          <a:p>
+            <a:pPr algn="l">
+              <a:defRPr sz="1600" b="0" u="none">
+                <a:solidFill>
+                  <a:srgbClr val="16213A"/>
+                </a:solidFill>
+                <a:latin typeface="Calibri"/>
+              </a:defRPr>
+            </a:pPr>
+            <a:r>
+              <a:t>• Presupuesto mensual inicial para operación.</a:t>
+            </a:r>
+          </a:p>
+          <a:p>
+            <a:pPr algn="l">
+              <a:defRPr sz="1600" b="0" u="none">
+                <a:solidFill>
+                  <a:srgbClr val="16213A"/>
+                </a:solidFill>
+                <a:latin typeface="Calibri"/>
+              </a:defRPr>
+            </a:pPr>
+            <a:r>
+              <a:t>• Habilitación de infraestructura Google y IA.</a:t>
+            </a:r>
+          </a:p>
+          <a:p>
+            <a:pPr algn="l">
+              <a:defRPr sz="1600" b="0" u="none">
+                <a:solidFill>
+                  <a:srgbClr val="16213A"/>
+                </a:solidFill>
+                <a:latin typeface="Calibri"/>
+              </a:defRPr>
+            </a:pPr>
+            <a:r>
+              <a:t>• Habilitación del canal WhatsApp Business.</a:t>
+            </a:r>
+          </a:p>
+          <a:p>
+            <a:pPr algn="l">
+              <a:defRPr sz="1600" b="0" u="none">
+                <a:solidFill>
+                  <a:srgbClr val="16213A"/>
+                </a:solidFill>
+                <a:latin typeface="Calibri"/>
+              </a:defRPr>
+            </a:pPr>
+            <a:r>
+              <a:t>• Sponsor de negocio para seguimiento trimestral.</a:t>
+            </a:r>
+          </a:p>
+        </p:txBody>
+      </p:sp>
+      <p:sp>
+        <p:nvSpPr>
+          <p:cNvPr id="6" name="Rounded Rectangle 5"/>
+          <p:cNvSpPr/>
+          <p:nvPr/>
+        </p:nvSpPr>
+        <p:spPr>
+          <a:xfrm>
+            <a:off x="6172200" y="1965960"/>
+            <a:ext cx="5257800" cy="3840480"/>
+          </a:xfrm>
+          <a:prstGeom prst="roundRect">
+            <a:avLst/>
+          </a:prstGeom>
+          <a:solidFill>
+            <a:srgbClr val="FFFFFF"/>
+          </a:solidFill>
+          <a:ln>
+            <a:solidFill>
+              <a:srgbClr val="D8E2F3"/>
+            </a:solidFill>
+          </a:ln>
+        </p:spPr>
+        <p:style>
+          <a:lnRef idx="1">
+            <a:schemeClr val="accent1"/>
+          </a:lnRef>
+          <a:fillRef idx="3">
+            <a:schemeClr val="accent1"/>
+          </a:fillRef>
+          <a:effectRef idx="2">
+            <a:schemeClr val="accent1"/>
+          </a:effectRef>
+          <a:fontRef idx="minor">
+            <a:schemeClr val="lt1"/>
+          </a:fontRef>
+        </p:style>
+        <p:txBody>
+          <a:bodyPr rtlCol="0" anchor="ctr" wrap="square"/>
+          <a:lstStyle/>
+          <a:p>
+            <a:pPr algn="l">
+              <a:defRPr sz="2000" b="1" u="none">
+                <a:solidFill>
+                  <a:srgbClr val="15946E"/>
+                </a:solidFill>
+                <a:latin typeface="Calibri"/>
+              </a:defRPr>
+            </a:pPr>
+            <a:r>
+              <a:t>Resultado esperado</a:t>
+            </a:r>
+          </a:p>
+          <a:p>
+            <a:pPr algn="l">
+              <a:defRPr sz="1600" b="0" u="none">
+                <a:solidFill>
+                  <a:srgbClr val="16213A"/>
+                </a:solidFill>
+                <a:latin typeface="Calibri"/>
+              </a:defRPr>
+            </a:pPr>
+            <a:r>
+              <a:t>• Mejor experiencia del colaborador.</a:t>
+            </a:r>
+          </a:p>
+          <a:p>
+            <a:pPr algn="l">
+              <a:defRPr sz="1600" b="0" u="none">
+                <a:solidFill>
+                  <a:srgbClr val="16213A"/>
+                </a:solidFill>
+                <a:latin typeface="Calibri"/>
+              </a:defRPr>
+            </a:pPr>
+            <a:r>
+              <a:t>• Menor carga operativa del equipo RRHH.</a:t>
+            </a:r>
+          </a:p>
+          <a:p>
+            <a:pPr algn="l">
+              <a:defRPr sz="1600" b="0" u="none">
+                <a:solidFill>
+                  <a:srgbClr val="16213A"/>
+                </a:solidFill>
+                <a:latin typeface="Calibri"/>
+              </a:defRPr>
+            </a:pPr>
+            <a:r>
+              <a:t>• Mayor trazabilidad y control de gestión.</a:t>
+            </a:r>
+          </a:p>
+          <a:p>
+            <a:pPr algn="l">
+              <a:defRPr sz="1600" b="0" u="none">
+                <a:solidFill>
+                  <a:srgbClr val="16213A"/>
+                </a:solidFill>
+                <a:latin typeface="Calibri"/>
+              </a:defRPr>
+            </a:pPr>
+            <a:r>
+              <a:t>• Base escalable para nuevas unidades del grupo.</a:t>
             </a:r>
           </a:p>
         </p:txBody>
@@ -3335,7 +3717,7 @@
     <p:bg>
       <p:bgPr>
         <a:solidFill>
-          <a:srgbClr val="F4F7FD"/>
+          <a:srgbClr val="F5F8FE"/>
         </a:solidFill>
         <a:effectLst/>
       </p:bgPr>
@@ -3356,13 +3738,13 @@
         <p:spPr>
           <a:xfrm>
             <a:off x="0" y="0"/>
-            <a:ext cx="12191695" cy="658368"/>
+            <a:ext cx="12191695" cy="640080"/>
           </a:xfrm>
           <a:prstGeom prst="rect">
             <a:avLst/>
           </a:prstGeom>
           <a:solidFill>
-            <a:srgbClr val="112D66"/>
+            <a:srgbClr val="143475"/>
           </a:solidFill>
           <a:ln>
             <a:noFill/>
@@ -3398,8 +3780,8 @@
         </p:nvSpPr>
         <p:spPr>
           <a:xfrm>
-            <a:off x="411480" y="109728"/>
-            <a:ext cx="6858000" cy="365760"/>
+            <a:off x="457200" y="109728"/>
+            <a:ext cx="6858000" cy="320040"/>
           </a:xfrm>
           <a:prstGeom prst="rect">
             <a:avLst/>
@@ -3413,7 +3795,7 @@
           <a:lstStyle/>
           <a:p>
             <a:pPr algn="l">
-              <a:defRPr sz="1600" b="1">
+              <a:defRPr sz="1600" b="1" u="none">
                 <a:solidFill>
                   <a:srgbClr val="FFFFFF"/>
                 </a:solidFill>
@@ -3428,67 +3810,14 @@
       </p:sp>
       <p:sp>
         <p:nvSpPr>
-          <p:cNvPr id="4" name="Rounded Rectangle 3"/>
-          <p:cNvSpPr/>
-          <p:nvPr/>
-        </p:nvSpPr>
-        <p:spPr>
-          <a:xfrm>
-            <a:off x="731520" y="914400"/>
-            <a:ext cx="1737360" cy="502920"/>
-          </a:xfrm>
-          <a:prstGeom prst="roundRect">
-            <a:avLst/>
-          </a:prstGeom>
-          <a:solidFill>
-            <a:srgbClr val="275DD2"/>
-          </a:solidFill>
-          <a:ln>
-            <a:noFill/>
-          </a:ln>
-        </p:spPr>
-        <p:style>
-          <a:lnRef idx="1">
-            <a:schemeClr val="accent1"/>
-          </a:lnRef>
-          <a:fillRef idx="3">
-            <a:schemeClr val="accent1"/>
-          </a:fillRef>
-          <a:effectRef idx="2">
-            <a:schemeClr val="accent1"/>
-          </a:effectRef>
-          <a:fontRef idx="minor">
-            <a:schemeClr val="lt1"/>
-          </a:fontRef>
-        </p:style>
-        <p:txBody>
-          <a:bodyPr rtlCol="0" anchor="ctr"/>
-          <a:lstStyle/>
-          <a:p>
-            <a:pPr algn="ctr">
-              <a:defRPr sz="1500" b="1">
-                <a:solidFill>
-                  <a:srgbClr val="FFFFFF"/>
-                </a:solidFill>
-                <a:latin typeface="Calibri"/>
-              </a:defRPr>
-            </a:pPr>
-            <a:r>
-              <a:t>Paso 1</a:t>
-            </a:r>
-          </a:p>
-        </p:txBody>
-      </p:sp>
-      <p:sp>
-        <p:nvSpPr>
-          <p:cNvPr id="5" name="TextBox 4"/>
+          <p:cNvPr id="4" name="TextBox 3"/>
           <p:cNvSpPr txBox="1"/>
           <p:nvPr/>
         </p:nvSpPr>
         <p:spPr>
           <a:xfrm>
-            <a:off x="731520" y="1600200"/>
-            <a:ext cx="10789920" cy="822960"/>
+            <a:off x="731520" y="914400"/>
+            <a:ext cx="10789920" cy="1280160"/>
           </a:xfrm>
           <a:prstGeom prst="rect">
             <a:avLst/>
@@ -3496,71 +3825,48 @@
           <a:noFill/>
         </p:spPr>
         <p:txBody>
-          <a:bodyPr wrap="none">
+          <a:bodyPr wrap="square">
             <a:spAutoFit/>
           </a:bodyPr>
           <a:lstStyle/>
           <a:p>
             <a:pPr algn="l">
-              <a:defRPr sz="3300" b="1">
-                <a:solidFill>
-                  <a:srgbClr val="112D66"/>
-                </a:solidFill>
-                <a:latin typeface="Calibri"/>
-              </a:defRPr>
-            </a:pPr>
-            <a:r>
-              <a:t>Recepción Inteligente de Consultas</a:t>
-            </a:r>
-          </a:p>
-        </p:txBody>
-      </p:sp>
-      <p:sp>
-        <p:nvSpPr>
-          <p:cNvPr id="6" name="TextBox 5"/>
-          <p:cNvSpPr txBox="1"/>
-          <p:nvPr/>
-        </p:nvSpPr>
-        <p:spPr>
-          <a:xfrm>
-            <a:off x="731520" y="2468880"/>
-            <a:ext cx="10698480" cy="914400"/>
-          </a:xfrm>
-          <a:prstGeom prst="rect">
-            <a:avLst/>
-          </a:prstGeom>
-          <a:noFill/>
-        </p:spPr>
-        <p:txBody>
-          <a:bodyPr wrap="none">
-            <a:spAutoFit/>
-          </a:bodyPr>
-          <a:lstStyle/>
-          <a:p>
-            <a:pPr algn="l">
-              <a:defRPr sz="1800" b="0">
-                <a:solidFill>
-                  <a:srgbClr val="505C70"/>
-                </a:solidFill>
-                <a:latin typeface="Calibri"/>
-              </a:defRPr>
-            </a:pPr>
-            <a:r>
-              <a:t>El asistente recibe consultas por web y organiza cada interacción en tiempo real.</a:t>
-            </a:r>
-          </a:p>
-        </p:txBody>
-      </p:sp>
-      <p:sp>
-        <p:nvSpPr>
-          <p:cNvPr id="7" name="Rounded Rectangle 6"/>
+              <a:defRPr sz="3400" b="1" u="none">
+                <a:solidFill>
+                  <a:srgbClr val="143475"/>
+                </a:solidFill>
+                <a:latin typeface="Calibri"/>
+              </a:defRPr>
+            </a:pPr>
+            <a:r>
+              <a:t>Situación actual</a:t>
+            </a:r>
+          </a:p>
+          <a:p>
+            <a:pPr algn="l">
+              <a:defRPr sz="1800" b="0" u="none">
+                <a:solidFill>
+                  <a:srgbClr val="566177"/>
+                </a:solidFill>
+                <a:latin typeface="Calibri"/>
+              </a:defRPr>
+            </a:pPr>
+            <a:r>
+              <a:t>Hoy RRHH enfrenta demanda creciente con procesos que pueden ser más ágiles.</a:t>
+            </a:r>
+          </a:p>
+        </p:txBody>
+      </p:sp>
+      <p:sp>
+        <p:nvSpPr>
+          <p:cNvPr id="5" name="Rounded Rectangle 4"/>
           <p:cNvSpPr/>
           <p:nvPr/>
         </p:nvSpPr>
         <p:spPr>
           <a:xfrm>
-            <a:off x="731520" y="3566160"/>
-            <a:ext cx="10698480" cy="2286000"/>
+            <a:off x="731520" y="2011680"/>
+            <a:ext cx="5394960" cy="3657600"/>
           </a:xfrm>
           <a:prstGeom prst="roundRect">
             <a:avLst/>
@@ -3570,7 +3876,7 @@
           </a:solidFill>
           <a:ln>
             <a:solidFill>
-              <a:srgbClr val="DCE4F1"/>
+              <a:srgbClr val="D8E2F3"/>
             </a:solidFill>
           </a:ln>
         </p:spPr>
@@ -3589,81 +3895,178 @@
           </a:fontRef>
         </p:style>
         <p:txBody>
-          <a:bodyPr rtlCol="0" anchor="ctr"/>
-          <a:lstStyle/>
-          <a:p>
-            <a:pPr algn="l">
-              <a:defRPr sz="1800" b="0">
-                <a:solidFill>
-                  <a:srgbClr val="172135"/>
-                </a:solidFill>
-                <a:latin typeface="Calibri"/>
-              </a:defRPr>
-            </a:pPr>
-            <a:r>
-              <a:t>• Ingreso de consultas frecuentes de colaboradores de forma automática.</a:t>
-            </a:r>
-          </a:p>
-          <a:p>
-            <a:pPr algn="l">
-              <a:defRPr sz="1800" b="0">
-                <a:solidFill>
-                  <a:srgbClr val="172135"/>
-                </a:solidFill>
-                <a:latin typeface="Calibri"/>
-              </a:defRPr>
-            </a:pPr>
-            <a:r>
-              <a:t>• Inicio de conversación con branding dinámico por empresa.</a:t>
-            </a:r>
-          </a:p>
-          <a:p>
-            <a:pPr algn="l">
-              <a:defRPr sz="1800" b="0">
-                <a:solidFill>
-                  <a:srgbClr val="172135"/>
-                </a:solidFill>
-                <a:latin typeface="Calibri"/>
-              </a:defRPr>
-            </a:pPr>
-            <a:r>
-              <a:t>• Registro estructurado de sesiones para seguimiento y analítica.</a:t>
-            </a:r>
-          </a:p>
-        </p:txBody>
-      </p:sp>
-      <p:sp>
-        <p:nvSpPr>
-          <p:cNvPr id="8" name="TextBox 7"/>
-          <p:cNvSpPr txBox="1"/>
+          <a:bodyPr rtlCol="0" anchor="ctr" wrap="square"/>
+          <a:lstStyle/>
+          <a:p>
+            <a:pPr algn="l">
+              <a:defRPr sz="2000" b="1" u="none">
+                <a:solidFill>
+                  <a:srgbClr val="E8931F"/>
+                </a:solidFill>
+                <a:latin typeface="Calibri"/>
+              </a:defRPr>
+            </a:pPr>
+            <a:r>
+              <a:t>Dolores principales</a:t>
+            </a:r>
+          </a:p>
+          <a:p>
+            <a:pPr algn="l">
+              <a:defRPr sz="1600" b="0" u="none">
+                <a:solidFill>
+                  <a:srgbClr val="16213A"/>
+                </a:solidFill>
+                <a:latin typeface="Calibri"/>
+              </a:defRPr>
+            </a:pPr>
+            <a:r>
+              <a:t>• Consultas repetitivas consumen tiempo operativo.</a:t>
+            </a:r>
+          </a:p>
+          <a:p>
+            <a:pPr algn="l">
+              <a:defRPr sz="1600" b="0" u="none">
+                <a:solidFill>
+                  <a:srgbClr val="16213A"/>
+                </a:solidFill>
+                <a:latin typeface="Calibri"/>
+              </a:defRPr>
+            </a:pPr>
+            <a:r>
+              <a:t>• Respuesta desigual según horario o disponibilidad.</a:t>
+            </a:r>
+          </a:p>
+          <a:p>
+            <a:pPr algn="l">
+              <a:defRPr sz="1600" b="0" u="none">
+                <a:solidFill>
+                  <a:srgbClr val="16213A"/>
+                </a:solidFill>
+                <a:latin typeface="Calibri"/>
+              </a:defRPr>
+            </a:pPr>
+            <a:r>
+              <a:t>• Derivaciones manuales sin un circuito unificado.</a:t>
+            </a:r>
+          </a:p>
+          <a:p>
+            <a:pPr algn="l">
+              <a:defRPr sz="1600" b="0" u="none">
+                <a:solidFill>
+                  <a:srgbClr val="16213A"/>
+                </a:solidFill>
+                <a:latin typeface="Calibri"/>
+              </a:defRPr>
+            </a:pPr>
+            <a:r>
+              <a:t>• Menor tiempo para tareas estratégicas de RRHH.</a:t>
+            </a:r>
+          </a:p>
+        </p:txBody>
+      </p:sp>
+      <p:sp>
+        <p:nvSpPr>
+          <p:cNvPr id="6" name="Rounded Rectangle 5"/>
+          <p:cNvSpPr/>
           <p:nvPr/>
         </p:nvSpPr>
         <p:spPr>
           <a:xfrm>
-            <a:off x="822960" y="5989320"/>
-            <a:ext cx="10515600" cy="320040"/>
-          </a:xfrm>
-          <a:prstGeom prst="rect">
+            <a:off x="6126480" y="2011680"/>
+            <a:ext cx="5303520" cy="3657600"/>
+          </a:xfrm>
+          <a:prstGeom prst="roundRect">
             <a:avLst/>
           </a:prstGeom>
-          <a:noFill/>
-        </p:spPr>
-        <p:txBody>
-          <a:bodyPr wrap="none">
-            <a:spAutoFit/>
-          </a:bodyPr>
-          <a:lstStyle/>
-          <a:p>
-            <a:pPr algn="l">
-              <a:defRPr sz="1400" b="1">
-                <a:solidFill>
-                  <a:srgbClr val="148F68"/>
-                </a:solidFill>
-                <a:latin typeface="Calibri"/>
-              </a:defRPr>
-            </a:pPr>
-            <a:r>
-              <a:t>Tecnología principal: Flask API + lógica conversacional (Python)</a:t>
+          <a:solidFill>
+            <a:srgbClr val="FFFFFF"/>
+          </a:solidFill>
+          <a:ln>
+            <a:solidFill>
+              <a:srgbClr val="D8E2F3"/>
+            </a:solidFill>
+          </a:ln>
+        </p:spPr>
+        <p:style>
+          <a:lnRef idx="1">
+            <a:schemeClr val="accent1"/>
+          </a:lnRef>
+          <a:fillRef idx="3">
+            <a:schemeClr val="accent1"/>
+          </a:fillRef>
+          <a:effectRef idx="2">
+            <a:schemeClr val="accent1"/>
+          </a:effectRef>
+          <a:fontRef idx="minor">
+            <a:schemeClr val="lt1"/>
+          </a:fontRef>
+        </p:style>
+        <p:txBody>
+          <a:bodyPr rtlCol="0" anchor="ctr" wrap="square"/>
+          <a:lstStyle/>
+          <a:p>
+            <a:pPr algn="l">
+              <a:defRPr sz="2000" b="1" u="none">
+                <a:solidFill>
+                  <a:srgbClr val="15946E"/>
+                </a:solidFill>
+                <a:latin typeface="Calibri"/>
+              </a:defRPr>
+            </a:pPr>
+            <a:r>
+              <a:t>Oportunidad de mejora</a:t>
+            </a:r>
+          </a:p>
+          <a:p>
+            <a:pPr algn="l">
+              <a:defRPr sz="1600" b="0" u="none">
+                <a:solidFill>
+                  <a:srgbClr val="16213A"/>
+                </a:solidFill>
+                <a:latin typeface="Calibri"/>
+              </a:defRPr>
+            </a:pPr>
+            <a:r>
+              <a:t>• Automatizar primera respuesta y clasificación.</a:t>
+            </a:r>
+          </a:p>
+          <a:p>
+            <a:pPr algn="l">
+              <a:defRPr sz="1600" b="0" u="none">
+                <a:solidFill>
+                  <a:srgbClr val="16213A"/>
+                </a:solidFill>
+                <a:latin typeface="Calibri"/>
+              </a:defRPr>
+            </a:pPr>
+            <a:r>
+              <a:t>• Derivar solo casos que realmente necesitan intervención humana.</a:t>
+            </a:r>
+          </a:p>
+          <a:p>
+            <a:pPr algn="l">
+              <a:defRPr sz="1600" b="0" u="none">
+                <a:solidFill>
+                  <a:srgbClr val="16213A"/>
+                </a:solidFill>
+                <a:latin typeface="Calibri"/>
+              </a:defRPr>
+            </a:pPr>
+            <a:r>
+              <a:t>• Medir tiempos, volumen y satisfacción en una sola vista.</a:t>
+            </a:r>
+          </a:p>
+          <a:p>
+            <a:pPr algn="l">
+              <a:defRPr sz="1600" b="0" u="none">
+                <a:solidFill>
+                  <a:srgbClr val="16213A"/>
+                </a:solidFill>
+                <a:latin typeface="Calibri"/>
+              </a:defRPr>
+            </a:pPr>
+            <a:r>
+              <a:t>• Escalar el servicio sin crecer linealmente en costos.</a:t>
             </a:r>
           </a:p>
         </p:txBody>
@@ -3682,7 +4085,7 @@
     <p:bg>
       <p:bgPr>
         <a:solidFill>
-          <a:srgbClr val="F4F7FD"/>
+          <a:srgbClr val="F5F8FE"/>
         </a:solidFill>
         <a:effectLst/>
       </p:bgPr>
@@ -3703,13 +4106,13 @@
         <p:spPr>
           <a:xfrm>
             <a:off x="0" y="0"/>
-            <a:ext cx="12191695" cy="658368"/>
+            <a:ext cx="12191695" cy="640080"/>
           </a:xfrm>
           <a:prstGeom prst="rect">
             <a:avLst/>
           </a:prstGeom>
           <a:solidFill>
-            <a:srgbClr val="112D66"/>
+            <a:srgbClr val="143475"/>
           </a:solidFill>
           <a:ln>
             <a:noFill/>
@@ -3745,8 +4148,8 @@
         </p:nvSpPr>
         <p:spPr>
           <a:xfrm>
-            <a:off x="411480" y="109728"/>
-            <a:ext cx="6858000" cy="365760"/>
+            <a:off x="457200" y="109728"/>
+            <a:ext cx="6858000" cy="320040"/>
           </a:xfrm>
           <a:prstGeom prst="rect">
             <a:avLst/>
@@ -3760,7 +4163,7 @@
           <a:lstStyle/>
           <a:p>
             <a:pPr algn="l">
-              <a:defRPr sz="1600" b="1">
+              <a:defRPr sz="1600" b="1" u="none">
                 <a:solidFill>
                   <a:srgbClr val="FFFFFF"/>
                 </a:solidFill>
@@ -3775,67 +4178,14 @@
       </p:sp>
       <p:sp>
         <p:nvSpPr>
-          <p:cNvPr id="4" name="Rounded Rectangle 3"/>
-          <p:cNvSpPr/>
-          <p:nvPr/>
-        </p:nvSpPr>
-        <p:spPr>
-          <a:xfrm>
-            <a:off x="731520" y="914400"/>
-            <a:ext cx="1737360" cy="502920"/>
-          </a:xfrm>
-          <a:prstGeom prst="roundRect">
-            <a:avLst/>
-          </a:prstGeom>
-          <a:solidFill>
-            <a:srgbClr val="275DD2"/>
-          </a:solidFill>
-          <a:ln>
-            <a:noFill/>
-          </a:ln>
-        </p:spPr>
-        <p:style>
-          <a:lnRef idx="1">
-            <a:schemeClr val="accent1"/>
-          </a:lnRef>
-          <a:fillRef idx="3">
-            <a:schemeClr val="accent1"/>
-          </a:fillRef>
-          <a:effectRef idx="2">
-            <a:schemeClr val="accent1"/>
-          </a:effectRef>
-          <a:fontRef idx="minor">
-            <a:schemeClr val="lt1"/>
-          </a:fontRef>
-        </p:style>
-        <p:txBody>
-          <a:bodyPr rtlCol="0" anchor="ctr"/>
-          <a:lstStyle/>
-          <a:p>
-            <a:pPr algn="ctr">
-              <a:defRPr sz="1500" b="1">
-                <a:solidFill>
-                  <a:srgbClr val="FFFFFF"/>
-                </a:solidFill>
-                <a:latin typeface="Calibri"/>
-              </a:defRPr>
-            </a:pPr>
-            <a:r>
-              <a:t>Paso 2</a:t>
-            </a:r>
-          </a:p>
-        </p:txBody>
-      </p:sp>
-      <p:sp>
-        <p:nvSpPr>
-          <p:cNvPr id="5" name="TextBox 4"/>
+          <p:cNvPr id="4" name="TextBox 3"/>
           <p:cNvSpPr txBox="1"/>
           <p:nvPr/>
         </p:nvSpPr>
         <p:spPr>
           <a:xfrm>
-            <a:off x="731520" y="1600200"/>
-            <a:ext cx="10789920" cy="822960"/>
+            <a:off x="731520" y="914400"/>
+            <a:ext cx="10789920" cy="1280160"/>
           </a:xfrm>
           <a:prstGeom prst="rect">
             <a:avLst/>
@@ -3843,71 +4193,48 @@
           <a:noFill/>
         </p:spPr>
         <p:txBody>
-          <a:bodyPr wrap="none">
+          <a:bodyPr wrap="square">
             <a:spAutoFit/>
           </a:bodyPr>
           <a:lstStyle/>
           <a:p>
             <a:pPr algn="l">
-              <a:defRPr sz="3300" b="1">
-                <a:solidFill>
-                  <a:srgbClr val="112D66"/>
-                </a:solidFill>
-                <a:latin typeface="Calibri"/>
-              </a:defRPr>
-            </a:pPr>
-            <a:r>
-              <a:t>Comprensión y Respuesta Automática</a:t>
-            </a:r>
-          </a:p>
-        </p:txBody>
-      </p:sp>
-      <p:sp>
-        <p:nvSpPr>
-          <p:cNvPr id="6" name="TextBox 5"/>
-          <p:cNvSpPr txBox="1"/>
-          <p:nvPr/>
-        </p:nvSpPr>
-        <p:spPr>
-          <a:xfrm>
-            <a:off x="731520" y="2468880"/>
-            <a:ext cx="10698480" cy="914400"/>
-          </a:xfrm>
-          <a:prstGeom prst="rect">
-            <a:avLst/>
-          </a:prstGeom>
-          <a:noFill/>
-        </p:spPr>
-        <p:txBody>
-          <a:bodyPr wrap="none">
-            <a:spAutoFit/>
-          </a:bodyPr>
-          <a:lstStyle/>
-          <a:p>
-            <a:pPr algn="l">
-              <a:defRPr sz="1800" b="0">
-                <a:solidFill>
-                  <a:srgbClr val="505C70"/>
-                </a:solidFill>
-                <a:latin typeface="Calibri"/>
-              </a:defRPr>
-            </a:pPr>
-            <a:r>
-              <a:t>El motor del chatbot interpreta intención, responde FAQs y solicita feedback.</a:t>
-            </a:r>
-          </a:p>
-        </p:txBody>
-      </p:sp>
-      <p:sp>
-        <p:nvSpPr>
-          <p:cNvPr id="7" name="Rounded Rectangle 6"/>
+              <a:defRPr sz="3400" b="1" u="none">
+                <a:solidFill>
+                  <a:srgbClr val="143475"/>
+                </a:solidFill>
+                <a:latin typeface="Calibri"/>
+              </a:defRPr>
+            </a:pPr>
+            <a:r>
+              <a:t>La propuesta</a:t>
+            </a:r>
+          </a:p>
+          <a:p>
+            <a:pPr algn="l">
+              <a:defRPr sz="1800" b="0" u="none">
+                <a:solidFill>
+                  <a:srgbClr val="566177"/>
+                </a:solidFill>
+                <a:latin typeface="Calibri"/>
+              </a:defRPr>
+            </a:pPr>
+            <a:r>
+              <a:t>Un asistente de RRHH con atención automática + atención humana integrada.</a:t>
+            </a:r>
+          </a:p>
+        </p:txBody>
+      </p:sp>
+      <p:sp>
+        <p:nvSpPr>
+          <p:cNvPr id="5" name="Rounded Rectangle 4"/>
           <p:cNvSpPr/>
           <p:nvPr/>
         </p:nvSpPr>
         <p:spPr>
           <a:xfrm>
-            <a:off x="731520" y="3566160"/>
-            <a:ext cx="10698480" cy="2286000"/>
+            <a:off x="731520" y="1965960"/>
+            <a:ext cx="10698480" cy="1554480"/>
           </a:xfrm>
           <a:prstGeom prst="roundRect">
             <a:avLst/>
@@ -3917,7 +4244,7 @@
           </a:solidFill>
           <a:ln>
             <a:solidFill>
-              <a:srgbClr val="DCE4F1"/>
+              <a:srgbClr val="D8E2F3"/>
             </a:solidFill>
           </a:ln>
         </p:spPr>
@@ -3936,81 +4263,327 @@
           </a:fontRef>
         </p:style>
         <p:txBody>
-          <a:bodyPr rtlCol="0" anchor="ctr"/>
-          <a:lstStyle/>
-          <a:p>
-            <a:pPr algn="l">
-              <a:defRPr sz="1800" b="0">
-                <a:solidFill>
-                  <a:srgbClr val="172135"/>
-                </a:solidFill>
-                <a:latin typeface="Calibri"/>
-              </a:defRPr>
-            </a:pPr>
-            <a:r>
-              <a:t>• Búsqueda semántica/fuzzy sobre base de preguntas frecuentes.</a:t>
-            </a:r>
-          </a:p>
-          <a:p>
-            <a:pPr algn="l">
-              <a:defRPr sz="1800" b="0">
-                <a:solidFill>
-                  <a:srgbClr val="172135"/>
-                </a:solidFill>
-                <a:latin typeface="Calibri"/>
-              </a:defRPr>
-            </a:pPr>
-            <a:r>
-              <a:t>• Manejo de sinónimos y normalización para consultas en lenguaje natural.</a:t>
-            </a:r>
-          </a:p>
-          <a:p>
-            <a:pPr algn="l">
-              <a:defRPr sz="1800" b="0">
-                <a:solidFill>
-                  <a:srgbClr val="172135"/>
-                </a:solidFill>
-                <a:latin typeface="Calibri"/>
-              </a:defRPr>
-            </a:pPr>
-            <a:r>
-              <a:t>• Cierre asistido con validación de utilidad de la respuesta.</a:t>
-            </a:r>
-          </a:p>
-        </p:txBody>
-      </p:sp>
-      <p:sp>
-        <p:nvSpPr>
-          <p:cNvPr id="8" name="TextBox 7"/>
-          <p:cNvSpPr txBox="1"/>
+          <a:bodyPr rtlCol="0" anchor="ctr" wrap="square"/>
+          <a:lstStyle/>
+          <a:p>
+            <a:pPr algn="l">
+              <a:defRPr sz="2000" b="1" u="none">
+                <a:solidFill>
+                  <a:srgbClr val="2D63D6"/>
+                </a:solidFill>
+                <a:latin typeface="Calibri"/>
+              </a:defRPr>
+            </a:pPr>
+            <a:r>
+              <a:t>¿Qué hace el chatbot?</a:t>
+            </a:r>
+          </a:p>
+          <a:p>
+            <a:pPr algn="l">
+              <a:defRPr sz="1600" b="0" u="none">
+                <a:solidFill>
+                  <a:srgbClr val="16213A"/>
+                </a:solidFill>
+                <a:latin typeface="Calibri"/>
+              </a:defRPr>
+            </a:pPr>
+            <a:r>
+              <a:t>• Responde preguntas frecuentes al instante y guía al colaborador.</a:t>
+            </a:r>
+          </a:p>
+          <a:p>
+            <a:pPr algn="l">
+              <a:defRPr sz="1600" b="0" u="none">
+                <a:solidFill>
+                  <a:srgbClr val="16213A"/>
+                </a:solidFill>
+                <a:latin typeface="Calibri"/>
+              </a:defRPr>
+            </a:pPr>
+            <a:r>
+              <a:t>• Si hace falta, deriva la conversación al equipo de RRHH en vivo.</a:t>
+            </a:r>
+          </a:p>
+        </p:txBody>
+      </p:sp>
+      <p:sp>
+        <p:nvSpPr>
+          <p:cNvPr id="6" name="Rounded Rectangle 5"/>
+          <p:cNvSpPr/>
           <p:nvPr/>
         </p:nvSpPr>
         <p:spPr>
           <a:xfrm>
-            <a:off x="822960" y="5989320"/>
-            <a:ext cx="10515600" cy="320040"/>
-          </a:xfrm>
-          <a:prstGeom prst="rect">
+            <a:off x="731520" y="3657600"/>
+            <a:ext cx="3429000" cy="2011680"/>
+          </a:xfrm>
+          <a:prstGeom prst="roundRect">
             <a:avLst/>
           </a:prstGeom>
-          <a:noFill/>
-        </p:spPr>
-        <p:txBody>
-          <a:bodyPr wrap="none">
-            <a:spAutoFit/>
-          </a:bodyPr>
-          <a:lstStyle/>
-          <a:p>
-            <a:pPr algn="l">
-              <a:defRPr sz="1400" b="1">
-                <a:solidFill>
-                  <a:srgbClr val="148F68"/>
-                </a:solidFill>
-                <a:latin typeface="Calibri"/>
-              </a:defRPr>
-            </a:pPr>
-            <a:r>
-              <a:t>Tecnología principal: Módulo chatbot + reglas de lenguaje + Firestore</a:t>
+          <a:solidFill>
+            <a:srgbClr val="FFFFFF"/>
+          </a:solidFill>
+          <a:ln>
+            <a:solidFill>
+              <a:srgbClr val="D8E2F3"/>
+            </a:solidFill>
+          </a:ln>
+        </p:spPr>
+        <p:style>
+          <a:lnRef idx="1">
+            <a:schemeClr val="accent1"/>
+          </a:lnRef>
+          <a:fillRef idx="3">
+            <a:schemeClr val="accent1"/>
+          </a:fillRef>
+          <a:effectRef idx="2">
+            <a:schemeClr val="accent1"/>
+          </a:effectRef>
+          <a:fontRef idx="minor">
+            <a:schemeClr val="lt1"/>
+          </a:fontRef>
+        </p:style>
+        <p:txBody>
+          <a:bodyPr rtlCol="0" anchor="ctr" wrap="square"/>
+          <a:lstStyle/>
+          <a:p>
+            <a:pPr algn="l">
+              <a:defRPr sz="2000" b="1" u="none">
+                <a:solidFill>
+                  <a:srgbClr val="2D63D6"/>
+                </a:solidFill>
+                <a:latin typeface="Calibri"/>
+              </a:defRPr>
+            </a:pPr>
+            <a:r>
+              <a:t>Para colaboradores</a:t>
+            </a:r>
+          </a:p>
+          <a:p>
+            <a:pPr algn="l">
+              <a:defRPr sz="1600" b="0" u="none">
+                <a:solidFill>
+                  <a:srgbClr val="16213A"/>
+                </a:solidFill>
+                <a:latin typeface="Calibri"/>
+              </a:defRPr>
+            </a:pPr>
+            <a:r>
+              <a:t>• Canal claro y rápido.</a:t>
+            </a:r>
+          </a:p>
+          <a:p>
+            <a:pPr algn="l">
+              <a:defRPr sz="1600" b="0" u="none">
+                <a:solidFill>
+                  <a:srgbClr val="16213A"/>
+                </a:solidFill>
+                <a:latin typeface="Calibri"/>
+              </a:defRPr>
+            </a:pPr>
+            <a:r>
+              <a:t>• Menos espera.</a:t>
+            </a:r>
+          </a:p>
+          <a:p>
+            <a:pPr algn="l">
+              <a:defRPr sz="1600" b="0" u="none">
+                <a:solidFill>
+                  <a:srgbClr val="16213A"/>
+                </a:solidFill>
+                <a:latin typeface="Calibri"/>
+              </a:defRPr>
+            </a:pPr>
+            <a:r>
+              <a:t>• Mejor experiencia.</a:t>
+            </a:r>
+          </a:p>
+        </p:txBody>
+      </p:sp>
+      <p:sp>
+        <p:nvSpPr>
+          <p:cNvPr id="7" name="Rounded Rectangle 6"/>
+          <p:cNvSpPr/>
+          <p:nvPr/>
+        </p:nvSpPr>
+        <p:spPr>
+          <a:xfrm>
+            <a:off x="4389120" y="3657600"/>
+            <a:ext cx="3429000" cy="2011680"/>
+          </a:xfrm>
+          <a:prstGeom prst="roundRect">
+            <a:avLst/>
+          </a:prstGeom>
+          <a:solidFill>
+            <a:srgbClr val="FFFFFF"/>
+          </a:solidFill>
+          <a:ln>
+            <a:solidFill>
+              <a:srgbClr val="D8E2F3"/>
+            </a:solidFill>
+          </a:ln>
+        </p:spPr>
+        <p:style>
+          <a:lnRef idx="1">
+            <a:schemeClr val="accent1"/>
+          </a:lnRef>
+          <a:fillRef idx="3">
+            <a:schemeClr val="accent1"/>
+          </a:fillRef>
+          <a:effectRef idx="2">
+            <a:schemeClr val="accent1"/>
+          </a:effectRef>
+          <a:fontRef idx="minor">
+            <a:schemeClr val="lt1"/>
+          </a:fontRef>
+        </p:style>
+        <p:txBody>
+          <a:bodyPr rtlCol="0" anchor="ctr" wrap="square"/>
+          <a:lstStyle/>
+          <a:p>
+            <a:pPr algn="l">
+              <a:defRPr sz="2000" b="1" u="none">
+                <a:solidFill>
+                  <a:srgbClr val="2D63D6"/>
+                </a:solidFill>
+                <a:latin typeface="Calibri"/>
+              </a:defRPr>
+            </a:pPr>
+            <a:r>
+              <a:t>Para RRHH</a:t>
+            </a:r>
+          </a:p>
+          <a:p>
+            <a:pPr algn="l">
+              <a:defRPr sz="1600" b="0" u="none">
+                <a:solidFill>
+                  <a:srgbClr val="16213A"/>
+                </a:solidFill>
+                <a:latin typeface="Calibri"/>
+              </a:defRPr>
+            </a:pPr>
+            <a:r>
+              <a:t>• Menos carga repetitiva.</a:t>
+            </a:r>
+          </a:p>
+          <a:p>
+            <a:pPr algn="l">
+              <a:defRPr sz="1600" b="0" u="none">
+                <a:solidFill>
+                  <a:srgbClr val="16213A"/>
+                </a:solidFill>
+                <a:latin typeface="Calibri"/>
+              </a:defRPr>
+            </a:pPr>
+            <a:r>
+              <a:t>• Más foco en casos críticos.</a:t>
+            </a:r>
+          </a:p>
+          <a:p>
+            <a:pPr algn="l">
+              <a:defRPr sz="1600" b="0" u="none">
+                <a:solidFill>
+                  <a:srgbClr val="16213A"/>
+                </a:solidFill>
+                <a:latin typeface="Calibri"/>
+              </a:defRPr>
+            </a:pPr>
+            <a:r>
+              <a:t>• Bandeja única de atención.</a:t>
+            </a:r>
+          </a:p>
+        </p:txBody>
+      </p:sp>
+      <p:sp>
+        <p:nvSpPr>
+          <p:cNvPr id="8" name="Rounded Rectangle 7"/>
+          <p:cNvSpPr/>
+          <p:nvPr/>
+        </p:nvSpPr>
+        <p:spPr>
+          <a:xfrm>
+            <a:off x="8001000" y="3657600"/>
+            <a:ext cx="3429000" cy="2011680"/>
+          </a:xfrm>
+          <a:prstGeom prst="roundRect">
+            <a:avLst/>
+          </a:prstGeom>
+          <a:solidFill>
+            <a:srgbClr val="FFFFFF"/>
+          </a:solidFill>
+          <a:ln>
+            <a:solidFill>
+              <a:srgbClr val="D8E2F3"/>
+            </a:solidFill>
+          </a:ln>
+        </p:spPr>
+        <p:style>
+          <a:lnRef idx="1">
+            <a:schemeClr val="accent1"/>
+          </a:lnRef>
+          <a:fillRef idx="3">
+            <a:schemeClr val="accent1"/>
+          </a:fillRef>
+          <a:effectRef idx="2">
+            <a:schemeClr val="accent1"/>
+          </a:effectRef>
+          <a:fontRef idx="minor">
+            <a:schemeClr val="lt1"/>
+          </a:fontRef>
+        </p:style>
+        <p:txBody>
+          <a:bodyPr rtlCol="0" anchor="ctr" wrap="square"/>
+          <a:lstStyle/>
+          <a:p>
+            <a:pPr algn="l">
+              <a:defRPr sz="2000" b="1" u="none">
+                <a:solidFill>
+                  <a:srgbClr val="2D63D6"/>
+                </a:solidFill>
+                <a:latin typeface="Calibri"/>
+              </a:defRPr>
+            </a:pPr>
+            <a:r>
+              <a:t>Para dirección</a:t>
+            </a:r>
+          </a:p>
+          <a:p>
+            <a:pPr algn="l">
+              <a:defRPr sz="1600" b="0" u="none">
+                <a:solidFill>
+                  <a:srgbClr val="16213A"/>
+                </a:solidFill>
+                <a:latin typeface="Calibri"/>
+              </a:defRPr>
+            </a:pPr>
+            <a:r>
+              <a:t>• Visibilidad de métricas.</a:t>
+            </a:r>
+          </a:p>
+          <a:p>
+            <a:pPr algn="l">
+              <a:defRPr sz="1600" b="0" u="none">
+                <a:solidFill>
+                  <a:srgbClr val="16213A"/>
+                </a:solidFill>
+                <a:latin typeface="Calibri"/>
+              </a:defRPr>
+            </a:pPr>
+            <a:r>
+              <a:t>• Escalabilidad controlada.</a:t>
+            </a:r>
+          </a:p>
+          <a:p>
+            <a:pPr algn="l">
+              <a:defRPr sz="1600" b="0" u="none">
+                <a:solidFill>
+                  <a:srgbClr val="16213A"/>
+                </a:solidFill>
+                <a:latin typeface="Calibri"/>
+              </a:defRPr>
+            </a:pPr>
+            <a:r>
+              <a:t>• Mejor productividad global.</a:t>
             </a:r>
           </a:p>
         </p:txBody>
@@ -4029,7 +4602,7 @@
     <p:bg>
       <p:bgPr>
         <a:solidFill>
-          <a:srgbClr val="F4F7FD"/>
+          <a:srgbClr val="F5F8FE"/>
         </a:solidFill>
         <a:effectLst/>
       </p:bgPr>
@@ -4050,13 +4623,13 @@
         <p:spPr>
           <a:xfrm>
             <a:off x="0" y="0"/>
-            <a:ext cx="12191695" cy="658368"/>
+            <a:ext cx="12191695" cy="640080"/>
           </a:xfrm>
           <a:prstGeom prst="rect">
             <a:avLst/>
           </a:prstGeom>
           <a:solidFill>
-            <a:srgbClr val="112D66"/>
+            <a:srgbClr val="143475"/>
           </a:solidFill>
           <a:ln>
             <a:noFill/>
@@ -4092,8 +4665,8 @@
         </p:nvSpPr>
         <p:spPr>
           <a:xfrm>
-            <a:off x="411480" y="109728"/>
-            <a:ext cx="6858000" cy="365760"/>
+            <a:off x="457200" y="109728"/>
+            <a:ext cx="6858000" cy="320040"/>
           </a:xfrm>
           <a:prstGeom prst="rect">
             <a:avLst/>
@@ -4107,7 +4680,7 @@
           <a:lstStyle/>
           <a:p>
             <a:pPr algn="l">
-              <a:defRPr sz="1600" b="1">
+              <a:defRPr sz="1600" b="1" u="none">
                 <a:solidFill>
                   <a:srgbClr val="FFFFFF"/>
                 </a:solidFill>
@@ -4122,67 +4695,14 @@
       </p:sp>
       <p:sp>
         <p:nvSpPr>
-          <p:cNvPr id="4" name="Rounded Rectangle 3"/>
-          <p:cNvSpPr/>
-          <p:nvPr/>
-        </p:nvSpPr>
-        <p:spPr>
-          <a:xfrm>
-            <a:off x="731520" y="914400"/>
-            <a:ext cx="1737360" cy="502920"/>
-          </a:xfrm>
-          <a:prstGeom prst="roundRect">
-            <a:avLst/>
-          </a:prstGeom>
-          <a:solidFill>
-            <a:srgbClr val="275DD2"/>
-          </a:solidFill>
-          <a:ln>
-            <a:noFill/>
-          </a:ln>
-        </p:spPr>
-        <p:style>
-          <a:lnRef idx="1">
-            <a:schemeClr val="accent1"/>
-          </a:lnRef>
-          <a:fillRef idx="3">
-            <a:schemeClr val="accent1"/>
-          </a:fillRef>
-          <a:effectRef idx="2">
-            <a:schemeClr val="accent1"/>
-          </a:effectRef>
-          <a:fontRef idx="minor">
-            <a:schemeClr val="lt1"/>
-          </a:fontRef>
-        </p:style>
-        <p:txBody>
-          <a:bodyPr rtlCol="0" anchor="ctr"/>
-          <a:lstStyle/>
-          <a:p>
-            <a:pPr algn="ctr">
-              <a:defRPr sz="1500" b="1">
-                <a:solidFill>
-                  <a:srgbClr val="FFFFFF"/>
-                </a:solidFill>
-                <a:latin typeface="Calibri"/>
-              </a:defRPr>
-            </a:pPr>
-            <a:r>
-              <a:t>Paso 3</a:t>
-            </a:r>
-          </a:p>
-        </p:txBody>
-      </p:sp>
-      <p:sp>
-        <p:nvSpPr>
-          <p:cNvPr id="5" name="TextBox 4"/>
+          <p:cNvPr id="4" name="TextBox 3"/>
           <p:cNvSpPr txBox="1"/>
           <p:nvPr/>
         </p:nvSpPr>
         <p:spPr>
           <a:xfrm>
-            <a:off x="731520" y="1600200"/>
-            <a:ext cx="10789920" cy="822960"/>
+            <a:off x="731520" y="914400"/>
+            <a:ext cx="10789920" cy="1280160"/>
           </a:xfrm>
           <a:prstGeom prst="rect">
             <a:avLst/>
@@ -4190,71 +4710,48 @@
           <a:noFill/>
         </p:spPr>
         <p:txBody>
-          <a:bodyPr wrap="none">
+          <a:bodyPr wrap="square">
             <a:spAutoFit/>
           </a:bodyPr>
           <a:lstStyle/>
           <a:p>
             <a:pPr algn="l">
-              <a:defRPr sz="3300" b="1">
-                <a:solidFill>
-                  <a:srgbClr val="112D66"/>
-                </a:solidFill>
-                <a:latin typeface="Calibri"/>
-              </a:defRPr>
-            </a:pPr>
-            <a:r>
-              <a:t>Derivación Humana en Vivo (Handoff RRHH)</a:t>
-            </a:r>
-          </a:p>
-        </p:txBody>
-      </p:sp>
-      <p:sp>
-        <p:nvSpPr>
-          <p:cNvPr id="6" name="TextBox 5"/>
-          <p:cNvSpPr txBox="1"/>
-          <p:nvPr/>
-        </p:nvSpPr>
-        <p:spPr>
-          <a:xfrm>
-            <a:off x="731520" y="2468880"/>
-            <a:ext cx="10698480" cy="914400"/>
-          </a:xfrm>
-          <a:prstGeom prst="rect">
-            <a:avLst/>
-          </a:prstGeom>
-          <a:noFill/>
-        </p:spPr>
-        <p:txBody>
-          <a:bodyPr wrap="none">
-            <a:spAutoFit/>
-          </a:bodyPr>
-          <a:lstStyle/>
-          <a:p>
-            <a:pPr algn="l">
-              <a:defRPr sz="1800" b="0">
-                <a:solidFill>
-                  <a:srgbClr val="505C70"/>
-                </a:solidFill>
-                <a:latin typeface="Calibri"/>
-              </a:defRPr>
-            </a:pPr>
-            <a:r>
-              <a:t>Cuando el bot no alcanza, escala la conversación a agentes RRHH activos.</a:t>
-            </a:r>
-          </a:p>
-        </p:txBody>
-      </p:sp>
-      <p:sp>
-        <p:nvSpPr>
-          <p:cNvPr id="7" name="Rounded Rectangle 6"/>
+              <a:defRPr sz="3400" b="1" u="none">
+                <a:solidFill>
+                  <a:srgbClr val="143475"/>
+                </a:solidFill>
+                <a:latin typeface="Calibri"/>
+              </a:defRPr>
+            </a:pPr>
+            <a:r>
+              <a:t>Experiencia del colaborador</a:t>
+            </a:r>
+          </a:p>
+          <a:p>
+            <a:pPr algn="l">
+              <a:defRPr sz="1800" b="0" u="none">
+                <a:solidFill>
+                  <a:srgbClr val="566177"/>
+                </a:solidFill>
+                <a:latin typeface="Calibri"/>
+              </a:defRPr>
+            </a:pPr>
+            <a:r>
+              <a:t>Recorrido simple en 4 momentos.</a:t>
+            </a:r>
+          </a:p>
+        </p:txBody>
+      </p:sp>
+      <p:sp>
+        <p:nvSpPr>
+          <p:cNvPr id="5" name="Rounded Rectangle 4"/>
           <p:cNvSpPr/>
           <p:nvPr/>
         </p:nvSpPr>
         <p:spPr>
           <a:xfrm>
-            <a:off x="731520" y="3566160"/>
-            <a:ext cx="10698480" cy="2286000"/>
+            <a:off x="777240" y="2148840"/>
+            <a:ext cx="2834640" cy="3200400"/>
           </a:xfrm>
           <a:prstGeom prst="roundRect">
             <a:avLst/>
@@ -4264,7 +4761,7 @@
           </a:solidFill>
           <a:ln>
             <a:solidFill>
-              <a:srgbClr val="DCE4F1"/>
+              <a:srgbClr val="D8E2F3"/>
             </a:solidFill>
           </a:ln>
         </p:spPr>
@@ -4283,81 +4780,236 @@
           </a:fontRef>
         </p:style>
         <p:txBody>
-          <a:bodyPr rtlCol="0" anchor="ctr"/>
-          <a:lstStyle/>
-          <a:p>
-            <a:pPr algn="l">
-              <a:defRPr sz="1800" b="0">
-                <a:solidFill>
-                  <a:srgbClr val="172135"/>
-                </a:solidFill>
-                <a:latin typeface="Calibri"/>
-              </a:defRPr>
-            </a:pPr>
-            <a:r>
-              <a:t>• Asignación automática por carga entre agentes conectados.</a:t>
-            </a:r>
-          </a:p>
-          <a:p>
-            <a:pPr algn="l">
-              <a:defRPr sz="1800" b="0">
-                <a:solidFill>
-                  <a:srgbClr val="172135"/>
-                </a:solidFill>
-                <a:latin typeface="Calibri"/>
-              </a:defRPr>
-            </a:pPr>
-            <a:r>
-              <a:t>• Toma manual y reasignación con trazabilidad de quién intervino.</a:t>
-            </a:r>
-          </a:p>
-          <a:p>
-            <a:pPr algn="l">
-              <a:defRPr sz="1800" b="0">
-                <a:solidFill>
-                  <a:srgbClr val="172135"/>
-                </a:solidFill>
-                <a:latin typeface="Calibri"/>
-              </a:defRPr>
-            </a:pPr>
-            <a:r>
-              <a:t>• Mensajería en tiempo real entre colaborador y RRHH.</a:t>
-            </a:r>
-          </a:p>
-        </p:txBody>
-      </p:sp>
-      <p:sp>
-        <p:nvSpPr>
-          <p:cNvPr id="8" name="TextBox 7"/>
-          <p:cNvSpPr txBox="1"/>
+          <a:bodyPr rtlCol="0" anchor="ctr" wrap="square"/>
+          <a:lstStyle/>
+          <a:p>
+            <a:pPr algn="ctr">
+              <a:defRPr sz="1700" b="1" u="none">
+                <a:solidFill>
+                  <a:srgbClr val="2D63D6"/>
+                </a:solidFill>
+                <a:latin typeface="Calibri"/>
+              </a:defRPr>
+            </a:pPr>
+            <a:r>
+              <a:t>1) Consulta inicial</a:t>
+            </a:r>
+          </a:p>
+          <a:p>
+            <a:pPr algn="ctr">
+              <a:defRPr sz="1400" b="0" u="none">
+                <a:solidFill>
+                  <a:srgbClr val="16213A"/>
+                </a:solidFill>
+                <a:latin typeface="Calibri"/>
+              </a:defRPr>
+            </a:pPr>
+            <a:r>
+              <a:t>El colaborador escribe su consulta en lenguaje natural.</a:t>
+            </a:r>
+          </a:p>
+        </p:txBody>
+      </p:sp>
+      <p:sp>
+        <p:nvSpPr>
+          <p:cNvPr id="6" name="Rounded Rectangle 5"/>
+          <p:cNvSpPr/>
           <p:nvPr/>
         </p:nvSpPr>
         <p:spPr>
           <a:xfrm>
-            <a:off x="822960" y="5989320"/>
-            <a:ext cx="10515600" cy="320040"/>
-          </a:xfrm>
-          <a:prstGeom prst="rect">
+            <a:off x="3703320" y="2148840"/>
+            <a:ext cx="2834640" cy="3200400"/>
+          </a:xfrm>
+          <a:prstGeom prst="roundRect">
             <a:avLst/>
           </a:prstGeom>
-          <a:noFill/>
-        </p:spPr>
-        <p:txBody>
-          <a:bodyPr wrap="none">
-            <a:spAutoFit/>
-          </a:bodyPr>
-          <a:lstStyle/>
-          <a:p>
-            <a:pPr algn="l">
-              <a:defRPr sz="1400" b="1">
-                <a:solidFill>
-                  <a:srgbClr val="148F68"/>
-                </a:solidFill>
-                <a:latin typeface="Calibri"/>
-              </a:defRPr>
-            </a:pPr>
-            <a:r>
-              <a:t>Tecnología principal: Panel RRHH + cola de handoff + heartbeat de agentes</a:t>
+          <a:solidFill>
+            <a:srgbClr val="FFFFFF"/>
+          </a:solidFill>
+          <a:ln>
+            <a:solidFill>
+              <a:srgbClr val="D8E2F3"/>
+            </a:solidFill>
+          </a:ln>
+        </p:spPr>
+        <p:style>
+          <a:lnRef idx="1">
+            <a:schemeClr val="accent1"/>
+          </a:lnRef>
+          <a:fillRef idx="3">
+            <a:schemeClr val="accent1"/>
+          </a:fillRef>
+          <a:effectRef idx="2">
+            <a:schemeClr val="accent1"/>
+          </a:effectRef>
+          <a:fontRef idx="minor">
+            <a:schemeClr val="lt1"/>
+          </a:fontRef>
+        </p:style>
+        <p:txBody>
+          <a:bodyPr rtlCol="0" anchor="ctr" wrap="square"/>
+          <a:lstStyle/>
+          <a:p>
+            <a:pPr algn="ctr">
+              <a:defRPr sz="1700" b="1" u="none">
+                <a:solidFill>
+                  <a:srgbClr val="2D63D6"/>
+                </a:solidFill>
+                <a:latin typeface="Calibri"/>
+              </a:defRPr>
+            </a:pPr>
+            <a:r>
+              <a:t>2) Respuesta inmediata</a:t>
+            </a:r>
+          </a:p>
+          <a:p>
+            <a:pPr algn="ctr">
+              <a:defRPr sz="1400" b="0" u="none">
+                <a:solidFill>
+                  <a:srgbClr val="16213A"/>
+                </a:solidFill>
+                <a:latin typeface="Calibri"/>
+              </a:defRPr>
+            </a:pPr>
+            <a:r>
+              <a:t>El asistente responde con información clara y accionable.</a:t>
+            </a:r>
+          </a:p>
+        </p:txBody>
+      </p:sp>
+      <p:sp>
+        <p:nvSpPr>
+          <p:cNvPr id="7" name="Rounded Rectangle 6"/>
+          <p:cNvSpPr/>
+          <p:nvPr/>
+        </p:nvSpPr>
+        <p:spPr>
+          <a:xfrm>
+            <a:off x="6629400" y="2148840"/>
+            <a:ext cx="2834640" cy="3200400"/>
+          </a:xfrm>
+          <a:prstGeom prst="roundRect">
+            <a:avLst/>
+          </a:prstGeom>
+          <a:solidFill>
+            <a:srgbClr val="FFFFFF"/>
+          </a:solidFill>
+          <a:ln>
+            <a:solidFill>
+              <a:srgbClr val="D8E2F3"/>
+            </a:solidFill>
+          </a:ln>
+        </p:spPr>
+        <p:style>
+          <a:lnRef idx="1">
+            <a:schemeClr val="accent1"/>
+          </a:lnRef>
+          <a:fillRef idx="3">
+            <a:schemeClr val="accent1"/>
+          </a:fillRef>
+          <a:effectRef idx="2">
+            <a:schemeClr val="accent1"/>
+          </a:effectRef>
+          <a:fontRef idx="minor">
+            <a:schemeClr val="lt1"/>
+          </a:fontRef>
+        </p:style>
+        <p:txBody>
+          <a:bodyPr rtlCol="0" anchor="ctr" wrap="square"/>
+          <a:lstStyle/>
+          <a:p>
+            <a:pPr algn="ctr">
+              <a:defRPr sz="1700" b="1" u="none">
+                <a:solidFill>
+                  <a:srgbClr val="2D63D6"/>
+                </a:solidFill>
+                <a:latin typeface="Calibri"/>
+              </a:defRPr>
+            </a:pPr>
+            <a:r>
+              <a:t>3) Si aplica: pase a RRHH</a:t>
+            </a:r>
+          </a:p>
+          <a:p>
+            <a:pPr algn="ctr">
+              <a:defRPr sz="1400" b="0" u="none">
+                <a:solidFill>
+                  <a:srgbClr val="16213A"/>
+                </a:solidFill>
+                <a:latin typeface="Calibri"/>
+              </a:defRPr>
+            </a:pPr>
+            <a:r>
+              <a:t>Cuando el caso lo requiere, un agente humano toma la conversación.</a:t>
+            </a:r>
+          </a:p>
+        </p:txBody>
+      </p:sp>
+      <p:sp>
+        <p:nvSpPr>
+          <p:cNvPr id="8" name="Rounded Rectangle 7"/>
+          <p:cNvSpPr/>
+          <p:nvPr/>
+        </p:nvSpPr>
+        <p:spPr>
+          <a:xfrm>
+            <a:off x="9555480" y="2148840"/>
+            <a:ext cx="2834640" cy="3200400"/>
+          </a:xfrm>
+          <a:prstGeom prst="roundRect">
+            <a:avLst/>
+          </a:prstGeom>
+          <a:solidFill>
+            <a:srgbClr val="FFFFFF"/>
+          </a:solidFill>
+          <a:ln>
+            <a:solidFill>
+              <a:srgbClr val="D8E2F3"/>
+            </a:solidFill>
+          </a:ln>
+        </p:spPr>
+        <p:style>
+          <a:lnRef idx="1">
+            <a:schemeClr val="accent1"/>
+          </a:lnRef>
+          <a:fillRef idx="3">
+            <a:schemeClr val="accent1"/>
+          </a:fillRef>
+          <a:effectRef idx="2">
+            <a:schemeClr val="accent1"/>
+          </a:effectRef>
+          <a:fontRef idx="minor">
+            <a:schemeClr val="lt1"/>
+          </a:fontRef>
+        </p:style>
+        <p:txBody>
+          <a:bodyPr rtlCol="0" anchor="ctr" wrap="square"/>
+          <a:lstStyle/>
+          <a:p>
+            <a:pPr algn="ctr">
+              <a:defRPr sz="1700" b="1" u="none">
+                <a:solidFill>
+                  <a:srgbClr val="2D63D6"/>
+                </a:solidFill>
+                <a:latin typeface="Calibri"/>
+              </a:defRPr>
+            </a:pPr>
+            <a:r>
+              <a:t>4) Resolución y cierre</a:t>
+            </a:r>
+          </a:p>
+          <a:p>
+            <a:pPr algn="ctr">
+              <a:defRPr sz="1400" b="0" u="none">
+                <a:solidFill>
+                  <a:srgbClr val="16213A"/>
+                </a:solidFill>
+                <a:latin typeface="Calibri"/>
+              </a:defRPr>
+            </a:pPr>
+            <a:r>
+              <a:t>Queda registro de la gestión para seguimiento y mejora.</a:t>
             </a:r>
           </a:p>
         </p:txBody>
@@ -4376,7 +5028,7 @@
     <p:bg>
       <p:bgPr>
         <a:solidFill>
-          <a:srgbClr val="F4F7FD"/>
+          <a:srgbClr val="F5F8FE"/>
         </a:solidFill>
         <a:effectLst/>
       </p:bgPr>
@@ -4397,13 +5049,13 @@
         <p:spPr>
           <a:xfrm>
             <a:off x="0" y="0"/>
-            <a:ext cx="12191695" cy="658368"/>
+            <a:ext cx="12191695" cy="640080"/>
           </a:xfrm>
           <a:prstGeom prst="rect">
             <a:avLst/>
           </a:prstGeom>
           <a:solidFill>
-            <a:srgbClr val="112D66"/>
+            <a:srgbClr val="143475"/>
           </a:solidFill>
           <a:ln>
             <a:noFill/>
@@ -4439,8 +5091,8 @@
         </p:nvSpPr>
         <p:spPr>
           <a:xfrm>
-            <a:off x="411480" y="109728"/>
-            <a:ext cx="6858000" cy="365760"/>
+            <a:off x="457200" y="109728"/>
+            <a:ext cx="6858000" cy="320040"/>
           </a:xfrm>
           <a:prstGeom prst="rect">
             <a:avLst/>
@@ -4454,7 +5106,7 @@
           <a:lstStyle/>
           <a:p>
             <a:pPr algn="l">
-              <a:defRPr sz="1600" b="1">
+              <a:defRPr sz="1600" b="1" u="none">
                 <a:solidFill>
                   <a:srgbClr val="FFFFFF"/>
                 </a:solidFill>
@@ -4469,67 +5121,14 @@
       </p:sp>
       <p:sp>
         <p:nvSpPr>
-          <p:cNvPr id="4" name="Rounded Rectangle 3"/>
-          <p:cNvSpPr/>
-          <p:nvPr/>
-        </p:nvSpPr>
-        <p:spPr>
-          <a:xfrm>
-            <a:off x="731520" y="914400"/>
-            <a:ext cx="1737360" cy="502920"/>
-          </a:xfrm>
-          <a:prstGeom prst="roundRect">
-            <a:avLst/>
-          </a:prstGeom>
-          <a:solidFill>
-            <a:srgbClr val="275DD2"/>
-          </a:solidFill>
-          <a:ln>
-            <a:noFill/>
-          </a:ln>
-        </p:spPr>
-        <p:style>
-          <a:lnRef idx="1">
-            <a:schemeClr val="accent1"/>
-          </a:lnRef>
-          <a:fillRef idx="3">
-            <a:schemeClr val="accent1"/>
-          </a:fillRef>
-          <a:effectRef idx="2">
-            <a:schemeClr val="accent1"/>
-          </a:effectRef>
-          <a:fontRef idx="minor">
-            <a:schemeClr val="lt1"/>
-          </a:fontRef>
-        </p:style>
-        <p:txBody>
-          <a:bodyPr rtlCol="0" anchor="ctr"/>
-          <a:lstStyle/>
-          <a:p>
-            <a:pPr algn="ctr">
-              <a:defRPr sz="1500" b="1">
-                <a:solidFill>
-                  <a:srgbClr val="FFFFFF"/>
-                </a:solidFill>
-                <a:latin typeface="Calibri"/>
-              </a:defRPr>
-            </a:pPr>
-            <a:r>
-              <a:t>Paso 4</a:t>
-            </a:r>
-          </a:p>
-        </p:txBody>
-      </p:sp>
-      <p:sp>
-        <p:nvSpPr>
-          <p:cNvPr id="5" name="TextBox 4"/>
+          <p:cNvPr id="4" name="TextBox 3"/>
           <p:cNvSpPr txBox="1"/>
           <p:nvPr/>
         </p:nvSpPr>
         <p:spPr>
           <a:xfrm>
-            <a:off x="731520" y="1600200"/>
-            <a:ext cx="10789920" cy="822960"/>
+            <a:off x="731520" y="914400"/>
+            <a:ext cx="10789920" cy="1280160"/>
           </a:xfrm>
           <a:prstGeom prst="rect">
             <a:avLst/>
@@ -4537,71 +5136,48 @@
           <a:noFill/>
         </p:spPr>
         <p:txBody>
-          <a:bodyPr wrap="none">
+          <a:bodyPr wrap="square">
             <a:spAutoFit/>
           </a:bodyPr>
           <a:lstStyle/>
           <a:p>
             <a:pPr algn="l">
-              <a:defRPr sz="3300" b="1">
-                <a:solidFill>
-                  <a:srgbClr val="112D66"/>
-                </a:solidFill>
-                <a:latin typeface="Calibri"/>
-              </a:defRPr>
-            </a:pPr>
-            <a:r>
-              <a:t>Gestión Multiempresa y Seguridad Operativa</a:t>
-            </a:r>
-          </a:p>
-        </p:txBody>
-      </p:sp>
-      <p:sp>
-        <p:nvSpPr>
-          <p:cNvPr id="6" name="TextBox 5"/>
-          <p:cNvSpPr txBox="1"/>
-          <p:nvPr/>
-        </p:nvSpPr>
-        <p:spPr>
-          <a:xfrm>
-            <a:off x="731520" y="2468880"/>
-            <a:ext cx="10698480" cy="914400"/>
-          </a:xfrm>
-          <a:prstGeom prst="rect">
-            <a:avLst/>
-          </a:prstGeom>
-          <a:noFill/>
-        </p:spPr>
-        <p:txBody>
-          <a:bodyPr wrap="none">
-            <a:spAutoFit/>
-          </a:bodyPr>
-          <a:lstStyle/>
-          <a:p>
-            <a:pPr algn="l">
-              <a:defRPr sz="1800" b="0">
-                <a:solidFill>
-                  <a:srgbClr val="505C70"/>
-                </a:solidFill>
-                <a:latin typeface="Calibri"/>
-              </a:defRPr>
-            </a:pPr>
-            <a:r>
-              <a:t>Administración centralizada por empresa/sucursal, usuarios, roles y permisos.</a:t>
-            </a:r>
-          </a:p>
-        </p:txBody>
-      </p:sp>
-      <p:sp>
-        <p:nvSpPr>
-          <p:cNvPr id="7" name="Rounded Rectangle 6"/>
+              <a:defRPr sz="3400" b="1" u="none">
+                <a:solidFill>
+                  <a:srgbClr val="143475"/>
+                </a:solidFill>
+                <a:latin typeface="Calibri"/>
+              </a:defRPr>
+            </a:pPr>
+            <a:r>
+              <a:t>Experiencia del equipo RRHH</a:t>
+            </a:r>
+          </a:p>
+          <a:p>
+            <a:pPr algn="l">
+              <a:defRPr sz="1800" b="0" u="none">
+                <a:solidFill>
+                  <a:srgbClr val="566177"/>
+                </a:solidFill>
+                <a:latin typeface="Calibri"/>
+              </a:defRPr>
+            </a:pPr>
+            <a:r>
+              <a:t>Gestión ordenada, colaborativa y medible.</a:t>
+            </a:r>
+          </a:p>
+        </p:txBody>
+      </p:sp>
+      <p:sp>
+        <p:nvSpPr>
+          <p:cNvPr id="5" name="Rounded Rectangle 4"/>
           <p:cNvSpPr/>
           <p:nvPr/>
         </p:nvSpPr>
         <p:spPr>
           <a:xfrm>
-            <a:off x="731520" y="3566160"/>
-            <a:ext cx="10698480" cy="2286000"/>
+            <a:off x="731520" y="1965960"/>
+            <a:ext cx="10698480" cy="3886200"/>
           </a:xfrm>
           <a:prstGeom prst="roundRect">
             <a:avLst/>
@@ -4611,7 +5187,7 @@
           </a:solidFill>
           <a:ln>
             <a:solidFill>
-              <a:srgbClr val="DCE4F1"/>
+              <a:srgbClr val="D8E2F3"/>
             </a:solidFill>
           </a:ln>
         </p:spPr>
@@ -4630,81 +5206,84 @@
           </a:fontRef>
         </p:style>
         <p:txBody>
-          <a:bodyPr rtlCol="0" anchor="ctr"/>
-          <a:lstStyle/>
-          <a:p>
-            <a:pPr algn="l">
-              <a:defRPr sz="1800" b="0">
-                <a:solidFill>
-                  <a:srgbClr val="172135"/>
-                </a:solidFill>
-                <a:latin typeface="Calibri"/>
-              </a:defRPr>
-            </a:pPr>
-            <a:r>
-              <a:t>• Login con selección de empresa y filtros de acceso por asignación.</a:t>
-            </a:r>
-          </a:p>
-          <a:p>
-            <a:pPr algn="l">
-              <a:defRPr sz="1800" b="0">
-                <a:solidFill>
-                  <a:srgbClr val="172135"/>
-                </a:solidFill>
-                <a:latin typeface="Calibri"/>
-              </a:defRPr>
-            </a:pPr>
-            <a:r>
-              <a:t>• Configuración separada para empresas, usuarios y roles.</a:t>
-            </a:r>
-          </a:p>
-          <a:p>
-            <a:pPr algn="l">
-              <a:defRPr sz="1800" b="0">
-                <a:solidFill>
-                  <a:srgbClr val="172135"/>
-                </a:solidFill>
-                <a:latin typeface="Calibri"/>
-              </a:defRPr>
-            </a:pPr>
-            <a:r>
-              <a:t>• Control RBAC para conversaciones, historial y administración.</a:t>
-            </a:r>
-          </a:p>
-        </p:txBody>
-      </p:sp>
-      <p:sp>
-        <p:nvSpPr>
-          <p:cNvPr id="8" name="TextBox 7"/>
-          <p:cNvSpPr txBox="1"/>
-          <p:nvPr/>
-        </p:nvSpPr>
-        <p:spPr>
-          <a:xfrm>
-            <a:off x="822960" y="5989320"/>
-            <a:ext cx="10515600" cy="320040"/>
-          </a:xfrm>
-          <a:prstGeom prst="rect">
-            <a:avLst/>
-          </a:prstGeom>
-          <a:noFill/>
-        </p:spPr>
-        <p:txBody>
-          <a:bodyPr wrap="none">
-            <a:spAutoFit/>
-          </a:bodyPr>
-          <a:lstStyle/>
-          <a:p>
-            <a:pPr algn="l">
-              <a:defRPr sz="1400" b="1">
-                <a:solidFill>
-                  <a:srgbClr val="148F68"/>
-                </a:solidFill>
-                <a:latin typeface="Calibri"/>
-              </a:defRPr>
-            </a:pPr>
-            <a:r>
-              <a:t>Tecnología principal: Autenticación RRHH + RBAC + configuración general</a:t>
+          <a:bodyPr rtlCol="0" anchor="ctr" wrap="square"/>
+          <a:lstStyle/>
+          <a:p>
+            <a:pPr algn="l">
+              <a:defRPr sz="2000" b="1" u="none">
+                <a:solidFill>
+                  <a:srgbClr val="2D63D6"/>
+                </a:solidFill>
+                <a:latin typeface="Calibri"/>
+              </a:defRPr>
+            </a:pPr>
+            <a:r>
+              <a:t>Qué cambia para RRHH</a:t>
+            </a:r>
+          </a:p>
+          <a:p>
+            <a:pPr algn="l">
+              <a:defRPr sz="1600" b="0" u="none">
+                <a:solidFill>
+                  <a:srgbClr val="16213A"/>
+                </a:solidFill>
+                <a:latin typeface="Calibri"/>
+              </a:defRPr>
+            </a:pPr>
+            <a:r>
+              <a:t>• Las conversaciones llegan organizadas y priorizadas.</a:t>
+            </a:r>
+          </a:p>
+          <a:p>
+            <a:pPr algn="l">
+              <a:defRPr sz="1600" b="0" u="none">
+                <a:solidFill>
+                  <a:srgbClr val="16213A"/>
+                </a:solidFill>
+                <a:latin typeface="Calibri"/>
+              </a:defRPr>
+            </a:pPr>
+            <a:r>
+              <a:t>• Se pueden tomar, reasignar y cerrar casos con trazabilidad.</a:t>
+            </a:r>
+          </a:p>
+          <a:p>
+            <a:pPr algn="l">
+              <a:defRPr sz="1600" b="0" u="none">
+                <a:solidFill>
+                  <a:srgbClr val="16213A"/>
+                </a:solidFill>
+                <a:latin typeface="Calibri"/>
+              </a:defRPr>
+            </a:pPr>
+            <a:r>
+              <a:t>• La operación se divide por empresa/sucursal según permisos.</a:t>
+            </a:r>
+          </a:p>
+          <a:p>
+            <a:pPr algn="l">
+              <a:defRPr sz="1600" b="0" u="none">
+                <a:solidFill>
+                  <a:srgbClr val="16213A"/>
+                </a:solidFill>
+                <a:latin typeface="Calibri"/>
+              </a:defRPr>
+            </a:pPr>
+            <a:r>
+              <a:t>• Se reduce la carga administrativa y mejora el tiempo de respuesta.</a:t>
+            </a:r>
+          </a:p>
+          <a:p>
+            <a:pPr algn="l">
+              <a:defRPr sz="1600" b="0" u="none">
+                <a:solidFill>
+                  <a:srgbClr val="16213A"/>
+                </a:solidFill>
+                <a:latin typeface="Calibri"/>
+              </a:defRPr>
+            </a:pPr>
+            <a:r>
+              <a:t>• La información queda centralizada para control y auditoría.</a:t>
             </a:r>
           </a:p>
         </p:txBody>
@@ -4723,7 +5302,7 @@
     <p:bg>
       <p:bgPr>
         <a:solidFill>
-          <a:srgbClr val="F4F7FD"/>
+          <a:srgbClr val="F5F8FE"/>
         </a:solidFill>
         <a:effectLst/>
       </p:bgPr>
@@ -4744,13 +5323,13 @@
         <p:spPr>
           <a:xfrm>
             <a:off x="0" y="0"/>
-            <a:ext cx="12191695" cy="658368"/>
+            <a:ext cx="12191695" cy="640080"/>
           </a:xfrm>
           <a:prstGeom prst="rect">
             <a:avLst/>
           </a:prstGeom>
           <a:solidFill>
-            <a:srgbClr val="112D66"/>
+            <a:srgbClr val="143475"/>
           </a:solidFill>
           <a:ln>
             <a:noFill/>
@@ -4786,8 +5365,8 @@
         </p:nvSpPr>
         <p:spPr>
           <a:xfrm>
-            <a:off x="411480" y="109728"/>
-            <a:ext cx="6858000" cy="365760"/>
+            <a:off x="457200" y="109728"/>
+            <a:ext cx="6858000" cy="320040"/>
           </a:xfrm>
           <a:prstGeom prst="rect">
             <a:avLst/>
@@ -4801,7 +5380,7 @@
           <a:lstStyle/>
           <a:p>
             <a:pPr algn="l">
-              <a:defRPr sz="1600" b="1">
+              <a:defRPr sz="1600" b="1" u="none">
                 <a:solidFill>
                   <a:srgbClr val="FFFFFF"/>
                 </a:solidFill>
@@ -4816,67 +5395,14 @@
       </p:sp>
       <p:sp>
         <p:nvSpPr>
-          <p:cNvPr id="4" name="Rounded Rectangle 3"/>
-          <p:cNvSpPr/>
-          <p:nvPr/>
-        </p:nvSpPr>
-        <p:spPr>
-          <a:xfrm>
-            <a:off x="731520" y="914400"/>
-            <a:ext cx="1737360" cy="502920"/>
-          </a:xfrm>
-          <a:prstGeom prst="roundRect">
-            <a:avLst/>
-          </a:prstGeom>
-          <a:solidFill>
-            <a:srgbClr val="275DD2"/>
-          </a:solidFill>
-          <a:ln>
-            <a:noFill/>
-          </a:ln>
-        </p:spPr>
-        <p:style>
-          <a:lnRef idx="1">
-            <a:schemeClr val="accent1"/>
-          </a:lnRef>
-          <a:fillRef idx="3">
-            <a:schemeClr val="accent1"/>
-          </a:fillRef>
-          <a:effectRef idx="2">
-            <a:schemeClr val="accent1"/>
-          </a:effectRef>
-          <a:fontRef idx="minor">
-            <a:schemeClr val="lt1"/>
-          </a:fontRef>
-        </p:style>
-        <p:txBody>
-          <a:bodyPr rtlCol="0" anchor="ctr"/>
-          <a:lstStyle/>
-          <a:p>
-            <a:pPr algn="ctr">
-              <a:defRPr sz="1500" b="1">
-                <a:solidFill>
-                  <a:srgbClr val="FFFFFF"/>
-                </a:solidFill>
-                <a:latin typeface="Calibri"/>
-              </a:defRPr>
-            </a:pPr>
-            <a:r>
-              <a:t>Paso 5</a:t>
-            </a:r>
-          </a:p>
-        </p:txBody>
-      </p:sp>
-      <p:sp>
-        <p:nvSpPr>
-          <p:cNvPr id="5" name="TextBox 4"/>
+          <p:cNvPr id="4" name="TextBox 3"/>
           <p:cNvSpPr txBox="1"/>
           <p:nvPr/>
         </p:nvSpPr>
         <p:spPr>
           <a:xfrm>
-            <a:off x="731520" y="1600200"/>
-            <a:ext cx="10789920" cy="822960"/>
+            <a:off x="731520" y="914400"/>
+            <a:ext cx="10789920" cy="1280160"/>
           </a:xfrm>
           <a:prstGeom prst="rect">
             <a:avLst/>
@@ -4884,71 +5410,35 @@
           <a:noFill/>
         </p:spPr>
         <p:txBody>
-          <a:bodyPr wrap="none">
+          <a:bodyPr wrap="square">
             <a:spAutoFit/>
           </a:bodyPr>
           <a:lstStyle/>
           <a:p>
             <a:pPr algn="l">
-              <a:defRPr sz="3300" b="1">
-                <a:solidFill>
-                  <a:srgbClr val="112D66"/>
-                </a:solidFill>
-                <a:latin typeface="Calibri"/>
-              </a:defRPr>
-            </a:pPr>
-            <a:r>
-              <a:t>Historial, Métricas y Mejora Continua</a:t>
-            </a:r>
-          </a:p>
-        </p:txBody>
-      </p:sp>
-      <p:sp>
-        <p:nvSpPr>
-          <p:cNvPr id="6" name="TextBox 5"/>
-          <p:cNvSpPr txBox="1"/>
-          <p:nvPr/>
-        </p:nvSpPr>
-        <p:spPr>
-          <a:xfrm>
-            <a:off x="731520" y="2468880"/>
-            <a:ext cx="10698480" cy="914400"/>
-          </a:xfrm>
-          <a:prstGeom prst="rect">
-            <a:avLst/>
-          </a:prstGeom>
-          <a:noFill/>
-        </p:spPr>
-        <p:txBody>
-          <a:bodyPr wrap="none">
-            <a:spAutoFit/>
-          </a:bodyPr>
-          <a:lstStyle/>
-          <a:p>
-            <a:pPr algn="l">
-              <a:defRPr sz="1800" b="0">
-                <a:solidFill>
-                  <a:srgbClr val="505C70"/>
-                </a:solidFill>
-                <a:latin typeface="Calibri"/>
-              </a:defRPr>
-            </a:pPr>
-            <a:r>
-              <a:t>Cada conversación se registra para auditar operación y optimizar el servicio.</a:t>
-            </a:r>
-          </a:p>
-        </p:txBody>
-      </p:sp>
-      <p:sp>
-        <p:nvSpPr>
-          <p:cNvPr id="7" name="Rounded Rectangle 6"/>
+              <a:defRPr sz="3400" b="1" u="none">
+                <a:solidFill>
+                  <a:srgbClr val="143475"/>
+                </a:solidFill>
+                <a:latin typeface="Calibri"/>
+              </a:defRPr>
+            </a:pPr>
+            <a:r>
+              <a:t>Capacidades de negocio ya disponibles</a:t>
+            </a:r>
+          </a:p>
+        </p:txBody>
+      </p:sp>
+      <p:sp>
+        <p:nvSpPr>
+          <p:cNvPr id="5" name="Rounded Rectangle 4"/>
           <p:cNvSpPr/>
           <p:nvPr/>
         </p:nvSpPr>
         <p:spPr>
           <a:xfrm>
-            <a:off x="731520" y="3566160"/>
-            <a:ext cx="10698480" cy="2286000"/>
+            <a:off x="731520" y="2011680"/>
+            <a:ext cx="5257800" cy="3657600"/>
           </a:xfrm>
           <a:prstGeom prst="roundRect">
             <a:avLst/>
@@ -4958,7 +5448,7 @@
           </a:solidFill>
           <a:ln>
             <a:solidFill>
-              <a:srgbClr val="DCE4F1"/>
+              <a:srgbClr val="D8E2F3"/>
             </a:solidFill>
           </a:ln>
         </p:spPr>
@@ -4977,81 +5467,178 @@
           </a:fontRef>
         </p:style>
         <p:txBody>
-          <a:bodyPr rtlCol="0" anchor="ctr"/>
-          <a:lstStyle/>
-          <a:p>
-            <a:pPr algn="l">
-              <a:defRPr sz="1800" b="0">
-                <a:solidFill>
-                  <a:srgbClr val="172135"/>
-                </a:solidFill>
-                <a:latin typeface="Calibri"/>
-              </a:defRPr>
-            </a:pPr>
-            <a:r>
-              <a:t>• Historial completo de interacciones y eventos de handoff.</a:t>
-            </a:r>
-          </a:p>
-          <a:p>
-            <a:pPr algn="l">
-              <a:defRPr sz="1800" b="0">
-                <a:solidFill>
-                  <a:srgbClr val="172135"/>
-                </a:solidFill>
-                <a:latin typeface="Calibri"/>
-              </a:defRPr>
-            </a:pPr>
-            <a:r>
-              <a:t>• Dashboard con KPIs operativos y seguimiento en tiempo real.</a:t>
-            </a:r>
-          </a:p>
-          <a:p>
-            <a:pPr algn="l">
-              <a:defRPr sz="1800" b="0">
-                <a:solidFill>
-                  <a:srgbClr val="172135"/>
-                </a:solidFill>
-                <a:latin typeface="Calibri"/>
-              </a:defRPr>
-            </a:pPr>
-            <a:r>
-              <a:t>• Base para decisiones de capacidad y experiencia del colaborador.</a:t>
-            </a:r>
-          </a:p>
-        </p:txBody>
-      </p:sp>
-      <p:sp>
-        <p:nvSpPr>
-          <p:cNvPr id="8" name="TextBox 7"/>
-          <p:cNvSpPr txBox="1"/>
+          <a:bodyPr rtlCol="0" anchor="ctr" wrap="square"/>
+          <a:lstStyle/>
+          <a:p>
+            <a:pPr algn="l">
+              <a:defRPr sz="2000" b="1" u="none">
+                <a:solidFill>
+                  <a:srgbClr val="2D63D6"/>
+                </a:solidFill>
+                <a:latin typeface="Calibri"/>
+              </a:defRPr>
+            </a:pPr>
+            <a:r>
+              <a:t>Operación y servicio</a:t>
+            </a:r>
+          </a:p>
+          <a:p>
+            <a:pPr algn="l">
+              <a:defRPr sz="1600" b="0" u="none">
+                <a:solidFill>
+                  <a:srgbClr val="16213A"/>
+                </a:solidFill>
+                <a:latin typeface="Calibri"/>
+              </a:defRPr>
+            </a:pPr>
+            <a:r>
+              <a:t>• Atención inicial automática 24/7.</a:t>
+            </a:r>
+          </a:p>
+          <a:p>
+            <a:pPr algn="l">
+              <a:defRPr sz="1600" b="0" u="none">
+                <a:solidFill>
+                  <a:srgbClr val="16213A"/>
+                </a:solidFill>
+                <a:latin typeface="Calibri"/>
+              </a:defRPr>
+            </a:pPr>
+            <a:r>
+              <a:t>• Derivación a personas cuando el caso lo necesita.</a:t>
+            </a:r>
+          </a:p>
+          <a:p>
+            <a:pPr algn="l">
+              <a:defRPr sz="1600" b="0" u="none">
+                <a:solidFill>
+                  <a:srgbClr val="16213A"/>
+                </a:solidFill>
+                <a:latin typeface="Calibri"/>
+              </a:defRPr>
+            </a:pPr>
+            <a:r>
+              <a:t>• Historial de conversaciones centralizado.</a:t>
+            </a:r>
+          </a:p>
+          <a:p>
+            <a:pPr algn="l">
+              <a:defRPr sz="1600" b="0" u="none">
+                <a:solidFill>
+                  <a:srgbClr val="16213A"/>
+                </a:solidFill>
+                <a:latin typeface="Calibri"/>
+              </a:defRPr>
+            </a:pPr>
+            <a:r>
+              <a:t>• Dashboard con indicadores clave.</a:t>
+            </a:r>
+          </a:p>
+        </p:txBody>
+      </p:sp>
+      <p:sp>
+        <p:nvSpPr>
+          <p:cNvPr id="6" name="Rounded Rectangle 5"/>
+          <p:cNvSpPr/>
           <p:nvPr/>
         </p:nvSpPr>
         <p:spPr>
           <a:xfrm>
-            <a:off x="822960" y="5989320"/>
-            <a:ext cx="10515600" cy="320040"/>
-          </a:xfrm>
-          <a:prstGeom prst="rect">
+            <a:off x="6172200" y="2011680"/>
+            <a:ext cx="5257800" cy="3657600"/>
+          </a:xfrm>
+          <a:prstGeom prst="roundRect">
             <a:avLst/>
           </a:prstGeom>
-          <a:noFill/>
-        </p:spPr>
-        <p:txBody>
-          <a:bodyPr wrap="none">
-            <a:spAutoFit/>
-          </a:bodyPr>
-          <a:lstStyle/>
-          <a:p>
-            <a:pPr algn="l">
-              <a:defRPr sz="1400" b="1">
-                <a:solidFill>
-                  <a:srgbClr val="148F68"/>
-                </a:solidFill>
-                <a:latin typeface="Calibri"/>
-              </a:defRPr>
-            </a:pPr>
-            <a:r>
-              <a:t>Tecnología principal: Firestore + panel estadísticas + exportables</a:t>
+          <a:solidFill>
+            <a:srgbClr val="FFFFFF"/>
+          </a:solidFill>
+          <a:ln>
+            <a:solidFill>
+              <a:srgbClr val="D8E2F3"/>
+            </a:solidFill>
+          </a:ln>
+        </p:spPr>
+        <p:style>
+          <a:lnRef idx="1">
+            <a:schemeClr val="accent1"/>
+          </a:lnRef>
+          <a:fillRef idx="3">
+            <a:schemeClr val="accent1"/>
+          </a:fillRef>
+          <a:effectRef idx="2">
+            <a:schemeClr val="accent1"/>
+          </a:effectRef>
+          <a:fontRef idx="minor">
+            <a:schemeClr val="lt1"/>
+          </a:fontRef>
+        </p:style>
+        <p:txBody>
+          <a:bodyPr rtlCol="0" anchor="ctr" wrap="square"/>
+          <a:lstStyle/>
+          <a:p>
+            <a:pPr algn="l">
+              <a:defRPr sz="2000" b="1" u="none">
+                <a:solidFill>
+                  <a:srgbClr val="15946E"/>
+                </a:solidFill>
+                <a:latin typeface="Calibri"/>
+              </a:defRPr>
+            </a:pPr>
+            <a:r>
+              <a:t>Escala y gobierno</a:t>
+            </a:r>
+          </a:p>
+          <a:p>
+            <a:pPr algn="l">
+              <a:defRPr sz="1600" b="0" u="none">
+                <a:solidFill>
+                  <a:srgbClr val="16213A"/>
+                </a:solidFill>
+                <a:latin typeface="Calibri"/>
+              </a:defRPr>
+            </a:pPr>
+            <a:r>
+              <a:t>• Gestión multiempresa y multisucursal.</a:t>
+            </a:r>
+          </a:p>
+          <a:p>
+            <a:pPr algn="l">
+              <a:defRPr sz="1600" b="0" u="none">
+                <a:solidFill>
+                  <a:srgbClr val="16213A"/>
+                </a:solidFill>
+                <a:latin typeface="Calibri"/>
+              </a:defRPr>
+            </a:pPr>
+            <a:r>
+              <a:t>• Usuarios, roles y permisos administrables.</a:t>
+            </a:r>
+          </a:p>
+          <a:p>
+            <a:pPr algn="l">
+              <a:defRPr sz="1600" b="0" u="none">
+                <a:solidFill>
+                  <a:srgbClr val="16213A"/>
+                </a:solidFill>
+                <a:latin typeface="Calibri"/>
+              </a:defRPr>
+            </a:pPr>
+            <a:r>
+              <a:t>• Asignación automática y manual de conversaciones.</a:t>
+            </a:r>
+          </a:p>
+          <a:p>
+            <a:pPr algn="l">
+              <a:defRPr sz="1600" b="0" u="none">
+                <a:solidFill>
+                  <a:srgbClr val="16213A"/>
+                </a:solidFill>
+                <a:latin typeface="Calibri"/>
+              </a:defRPr>
+            </a:pPr>
+            <a:r>
+              <a:t>• Base lista para expansión a WhatsApp.</a:t>
             </a:r>
           </a:p>
         </p:txBody>
@@ -5070,7 +5657,7 @@
     <p:bg>
       <p:bgPr>
         <a:solidFill>
-          <a:srgbClr val="F4F7FD"/>
+          <a:srgbClr val="F5F8FE"/>
         </a:solidFill>
         <a:effectLst/>
       </p:bgPr>
@@ -5091,13 +5678,13 @@
         <p:spPr>
           <a:xfrm>
             <a:off x="0" y="0"/>
-            <a:ext cx="12191695" cy="658368"/>
+            <a:ext cx="12191695" cy="640080"/>
           </a:xfrm>
           <a:prstGeom prst="rect">
             <a:avLst/>
           </a:prstGeom>
           <a:solidFill>
-            <a:srgbClr val="112D66"/>
+            <a:srgbClr val="143475"/>
           </a:solidFill>
           <a:ln>
             <a:noFill/>
@@ -5133,8 +5720,8 @@
         </p:nvSpPr>
         <p:spPr>
           <a:xfrm>
-            <a:off x="411480" y="109728"/>
-            <a:ext cx="6858000" cy="365760"/>
+            <a:off x="457200" y="109728"/>
+            <a:ext cx="6858000" cy="320040"/>
           </a:xfrm>
           <a:prstGeom prst="rect">
             <a:avLst/>
@@ -5148,7 +5735,7 @@
           <a:lstStyle/>
           <a:p>
             <a:pPr algn="l">
-              <a:defRPr sz="1600" b="1">
+              <a:defRPr sz="1600" b="1" u="none">
                 <a:solidFill>
                   <a:srgbClr val="FFFFFF"/>
                 </a:solidFill>
@@ -5169,8 +5756,8 @@
         </p:nvSpPr>
         <p:spPr>
           <a:xfrm>
-            <a:off x="731520" y="1051560"/>
-            <a:ext cx="10789920" cy="640080"/>
+            <a:off x="731520" y="914400"/>
+            <a:ext cx="10789920" cy="1280160"/>
           </a:xfrm>
           <a:prstGeom prst="rect">
             <a:avLst/>
@@ -5178,21 +5765,34 @@
           <a:noFill/>
         </p:spPr>
         <p:txBody>
-          <a:bodyPr wrap="none">
+          <a:bodyPr wrap="square">
             <a:spAutoFit/>
           </a:bodyPr>
           <a:lstStyle/>
           <a:p>
             <a:pPr algn="l">
-              <a:defRPr sz="3100" b="1">
-                <a:solidFill>
-                  <a:srgbClr val="112D66"/>
-                </a:solidFill>
-                <a:latin typeface="Calibri"/>
-              </a:defRPr>
-            </a:pPr>
-            <a:r>
-              <a:t>Ventajas Operativas y de Escalabilidad</a:t>
+              <a:defRPr sz="3400" b="1" u="none">
+                <a:solidFill>
+                  <a:srgbClr val="143475"/>
+                </a:solidFill>
+                <a:latin typeface="Calibri"/>
+              </a:defRPr>
+            </a:pPr>
+            <a:r>
+              <a:t>Qué vamos a necesitar para producción</a:t>
+            </a:r>
+          </a:p>
+          <a:p>
+            <a:pPr algn="l">
+              <a:defRPr sz="1800" b="0" u="none">
+                <a:solidFill>
+                  <a:srgbClr val="566177"/>
+                </a:solidFill>
+                <a:latin typeface="Calibri"/>
+              </a:defRPr>
+            </a:pPr>
+            <a:r>
+              <a:t>Componentes clave para operar con estabilidad y escalar el servicio.</a:t>
             </a:r>
           </a:p>
         </p:txBody>
@@ -5206,7 +5806,7 @@
         <p:spPr>
           <a:xfrm>
             <a:off x="731520" y="2011680"/>
-            <a:ext cx="2468880" cy="3566160"/>
+            <a:ext cx="3429000" cy="3657600"/>
           </a:xfrm>
           <a:prstGeom prst="roundRect">
             <a:avLst/>
@@ -5216,7 +5816,7 @@
           </a:solidFill>
           <a:ln>
             <a:solidFill>
-              <a:srgbClr val="D7E2F3"/>
+              <a:srgbClr val="D8E2F3"/>
             </a:solidFill>
           </a:ln>
         </p:spPr>
@@ -5235,32 +5835,71 @@
           </a:fontRef>
         </p:style>
         <p:txBody>
-          <a:bodyPr rtlCol="0" anchor="ctr"/>
-          <a:lstStyle/>
-          <a:p>
-            <a:pPr algn="ctr">
-              <a:defRPr sz="1800" b="1">
-                <a:solidFill>
-                  <a:srgbClr val="275DD2"/>
-                </a:solidFill>
-                <a:latin typeface="Calibri"/>
-              </a:defRPr>
-            </a:pPr>
-            <a:r>
-              <a:t>Capacidad</a:t>
-            </a:r>
-          </a:p>
-          <a:p>
-            <a:pPr algn="ctr">
-              <a:defRPr sz="1400" b="0">
-                <a:solidFill>
-                  <a:srgbClr val="172135"/>
-                </a:solidFill>
-                <a:latin typeface="Calibri"/>
-              </a:defRPr>
-            </a:pPr>
-            <a:r>
-              <a:t>800 a 1000 consultas/mes sin ampliar equipo base.</a:t>
+          <a:bodyPr rtlCol="0" anchor="ctr" wrap="square"/>
+          <a:lstStyle/>
+          <a:p>
+            <a:pPr algn="l">
+              <a:defRPr sz="2000" b="1" u="none">
+                <a:solidFill>
+                  <a:srgbClr val="2D63D6"/>
+                </a:solidFill>
+                <a:latin typeface="Calibri"/>
+              </a:defRPr>
+            </a:pPr>
+            <a:r>
+              <a:t>Base de datos</a:t>
+            </a:r>
+          </a:p>
+          <a:p>
+            <a:pPr algn="l">
+              <a:defRPr sz="1600" b="0" u="none">
+                <a:solidFill>
+                  <a:srgbClr val="16213A"/>
+                </a:solidFill>
+                <a:latin typeface="Calibri"/>
+              </a:defRPr>
+            </a:pPr>
+            <a:r>
+              <a:t>• Firestore</a:t>
+            </a:r>
+          </a:p>
+          <a:p>
+            <a:pPr algn="l">
+              <a:defRPr sz="1600" b="0" u="none">
+                <a:solidFill>
+                  <a:srgbClr val="16213A"/>
+                </a:solidFill>
+                <a:latin typeface="Calibri"/>
+              </a:defRPr>
+            </a:pPr>
+            <a:r>
+              <a:t>• Historial y métricas</a:t>
+            </a:r>
+          </a:p>
+          <a:p>
+            <a:pPr algn="l">
+              <a:defRPr sz="1600" b="0" u="none">
+                <a:solidFill>
+                  <a:srgbClr val="16213A"/>
+                </a:solidFill>
+                <a:latin typeface="Calibri"/>
+              </a:defRPr>
+            </a:pPr>
+            <a:r>
+              <a:t>• Configuración multiempresa</a:t>
+            </a:r>
+          </a:p>
+          <a:p>
+            <a:pPr algn="l">
+              <a:defRPr sz="1600" b="0" u="none">
+                <a:solidFill>
+                  <a:srgbClr val="16213A"/>
+                </a:solidFill>
+                <a:latin typeface="Calibri"/>
+              </a:defRPr>
+            </a:pPr>
+            <a:r>
+              <a:t>• Persistencia segura</a:t>
             </a:r>
           </a:p>
         </p:txBody>
@@ -5273,8 +5912,8 @@
         </p:nvSpPr>
         <p:spPr>
           <a:xfrm>
-            <a:off x="3611880" y="2011680"/>
-            <a:ext cx="2468880" cy="3566160"/>
+            <a:off x="4389120" y="2011680"/>
+            <a:ext cx="3429000" cy="3657600"/>
           </a:xfrm>
           <a:prstGeom prst="roundRect">
             <a:avLst/>
@@ -5284,7 +5923,7 @@
           </a:solidFill>
           <a:ln>
             <a:solidFill>
-              <a:srgbClr val="D7E2F3"/>
+              <a:srgbClr val="D8E2F3"/>
             </a:solidFill>
           </a:ln>
         </p:spPr>
@@ -5303,32 +5942,71 @@
           </a:fontRef>
         </p:style>
         <p:txBody>
-          <a:bodyPr rtlCol="0" anchor="ctr"/>
-          <a:lstStyle/>
-          <a:p>
-            <a:pPr algn="ctr">
-              <a:defRPr sz="1800" b="1">
-                <a:solidFill>
-                  <a:srgbClr val="275DD2"/>
-                </a:solidFill>
-                <a:latin typeface="Calibri"/>
-              </a:defRPr>
-            </a:pPr>
-            <a:r>
-              <a:t>Disponibilidad</a:t>
-            </a:r>
-          </a:p>
-          <a:p>
-            <a:pPr algn="ctr">
-              <a:defRPr sz="1400" b="0">
-                <a:solidFill>
-                  <a:srgbClr val="172135"/>
-                </a:solidFill>
-                <a:latin typeface="Calibri"/>
-              </a:defRPr>
-            </a:pPr>
-            <a:r>
-              <a:t>Atención 24/7 con autogestión + derivación humana cuando aplica.</a:t>
+          <a:bodyPr rtlCol="0" anchor="ctr" wrap="square"/>
+          <a:lstStyle/>
+          <a:p>
+            <a:pPr algn="l">
+              <a:defRPr sz="2000" b="1" u="none">
+                <a:solidFill>
+                  <a:srgbClr val="15946E"/>
+                </a:solidFill>
+                <a:latin typeface="Calibri"/>
+              </a:defRPr>
+            </a:pPr>
+            <a:r>
+              <a:t>Inteligencia</a:t>
+            </a:r>
+          </a:p>
+          <a:p>
+            <a:pPr algn="l">
+              <a:defRPr sz="1600" b="0" u="none">
+                <a:solidFill>
+                  <a:srgbClr val="16213A"/>
+                </a:solidFill>
+                <a:latin typeface="Calibri"/>
+              </a:defRPr>
+            </a:pPr>
+            <a:r>
+              <a:t>• Google AI Studio (prototipo)</a:t>
+            </a:r>
+          </a:p>
+          <a:p>
+            <a:pPr algn="l">
+              <a:defRPr sz="1600" b="0" u="none">
+                <a:solidFill>
+                  <a:srgbClr val="16213A"/>
+                </a:solidFill>
+                <a:latin typeface="Calibri"/>
+              </a:defRPr>
+            </a:pPr>
+            <a:r>
+              <a:t>• Gemini API para producción</a:t>
+            </a:r>
+          </a:p>
+          <a:p>
+            <a:pPr algn="l">
+              <a:defRPr sz="1600" b="0" u="none">
+                <a:solidFill>
+                  <a:srgbClr val="16213A"/>
+                </a:solidFill>
+                <a:latin typeface="Calibri"/>
+              </a:defRPr>
+            </a:pPr>
+            <a:r>
+              <a:t>• Mejor respuesta por contexto</a:t>
+            </a:r>
+          </a:p>
+          <a:p>
+            <a:pPr algn="l">
+              <a:defRPr sz="1600" b="0" u="none">
+                <a:solidFill>
+                  <a:srgbClr val="16213A"/>
+                </a:solidFill>
+                <a:latin typeface="Calibri"/>
+              </a:defRPr>
+            </a:pPr>
+            <a:r>
+              <a:t>• Escalabilidad por consumo</a:t>
             </a:r>
           </a:p>
         </p:txBody>
@@ -5341,8 +6019,8 @@
         </p:nvSpPr>
         <p:spPr>
           <a:xfrm>
-            <a:off x="6492240" y="2011680"/>
-            <a:ext cx="2468880" cy="3566160"/>
+            <a:off x="8046720" y="2011680"/>
+            <a:ext cx="3429000" cy="3657600"/>
           </a:xfrm>
           <a:prstGeom prst="roundRect">
             <a:avLst/>
@@ -5352,7 +6030,7 @@
           </a:solidFill>
           <a:ln>
             <a:solidFill>
-              <a:srgbClr val="D7E2F3"/>
+              <a:srgbClr val="D8E2F3"/>
             </a:solidFill>
           </a:ln>
         </p:spPr>
@@ -5371,100 +6049,71 @@
           </a:fontRef>
         </p:style>
         <p:txBody>
-          <a:bodyPr rtlCol="0" anchor="ctr"/>
-          <a:lstStyle/>
-          <a:p>
-            <a:pPr algn="ctr">
-              <a:defRPr sz="1800" b="1">
-                <a:solidFill>
-                  <a:srgbClr val="275DD2"/>
-                </a:solidFill>
-                <a:latin typeface="Calibri"/>
-              </a:defRPr>
-            </a:pPr>
-            <a:r>
-              <a:t>Trazabilidad</a:t>
-            </a:r>
-          </a:p>
-          <a:p>
-            <a:pPr algn="ctr">
-              <a:defRPr sz="1400" b="0">
-                <a:solidFill>
-                  <a:srgbClr val="172135"/>
-                </a:solidFill>
-                <a:latin typeface="Calibri"/>
-              </a:defRPr>
-            </a:pPr>
-            <a:r>
-              <a:t>Historial completo y métricas en tiempo real por empresa/sucursal.</a:t>
-            </a:r>
-          </a:p>
-        </p:txBody>
-      </p:sp>
-      <p:sp>
-        <p:nvSpPr>
-          <p:cNvPr id="8" name="Rounded Rectangle 7"/>
-          <p:cNvSpPr/>
-          <p:nvPr/>
-        </p:nvSpPr>
-        <p:spPr>
-          <a:xfrm>
-            <a:off x="9372600" y="2011680"/>
-            <a:ext cx="2468880" cy="3566160"/>
-          </a:xfrm>
-          <a:prstGeom prst="roundRect">
-            <a:avLst/>
-          </a:prstGeom>
-          <a:solidFill>
-            <a:srgbClr val="FFFFFF"/>
-          </a:solidFill>
-          <a:ln>
-            <a:solidFill>
-              <a:srgbClr val="D7E2F3"/>
-            </a:solidFill>
-          </a:ln>
-        </p:spPr>
-        <p:style>
-          <a:lnRef idx="1">
-            <a:schemeClr val="accent1"/>
-          </a:lnRef>
-          <a:fillRef idx="3">
-            <a:schemeClr val="accent1"/>
-          </a:fillRef>
-          <a:effectRef idx="2">
-            <a:schemeClr val="accent1"/>
-          </a:effectRef>
-          <a:fontRef idx="minor">
-            <a:schemeClr val="lt1"/>
-          </a:fontRef>
-        </p:style>
-        <p:txBody>
-          <a:bodyPr rtlCol="0" anchor="ctr"/>
-          <a:lstStyle/>
-          <a:p>
-            <a:pPr algn="ctr">
-              <a:defRPr sz="1800" b="1">
-                <a:solidFill>
-                  <a:srgbClr val="275DD2"/>
-                </a:solidFill>
-                <a:latin typeface="Calibri"/>
-              </a:defRPr>
-            </a:pPr>
-            <a:r>
-              <a:t>Escalabilidad</a:t>
-            </a:r>
-          </a:p>
-          <a:p>
-            <a:pPr algn="ctr">
-              <a:defRPr sz="1400" b="0">
-                <a:solidFill>
-                  <a:srgbClr val="172135"/>
-                </a:solidFill>
-                <a:latin typeface="Calibri"/>
-              </a:defRPr>
-            </a:pPr>
-            <a:r>
-              <a:t>Arquitectura multiempresa y roles para crecer con bajo costo incremental.</a:t>
+          <a:bodyPr rtlCol="0" anchor="ctr" wrap="square"/>
+          <a:lstStyle/>
+          <a:p>
+            <a:pPr algn="l">
+              <a:defRPr sz="2000" b="1" u="none">
+                <a:solidFill>
+                  <a:srgbClr val="E8931F"/>
+                </a:solidFill>
+                <a:latin typeface="Calibri"/>
+              </a:defRPr>
+            </a:pPr>
+            <a:r>
+              <a:t>Canal y operación</a:t>
+            </a:r>
+          </a:p>
+          <a:p>
+            <a:pPr algn="l">
+              <a:defRPr sz="1600" b="0" u="none">
+                <a:solidFill>
+                  <a:srgbClr val="16213A"/>
+                </a:solidFill>
+                <a:latin typeface="Calibri"/>
+              </a:defRPr>
+            </a:pPr>
+            <a:r>
+              <a:t>• WhatsApp Business API</a:t>
+            </a:r>
+          </a:p>
+          <a:p>
+            <a:pPr algn="l">
+              <a:defRPr sz="1600" b="0" u="none">
+                <a:solidFill>
+                  <a:srgbClr val="16213A"/>
+                </a:solidFill>
+                <a:latin typeface="Calibri"/>
+              </a:defRPr>
+            </a:pPr>
+            <a:r>
+              <a:t>• Proveedor BSP habilitado</a:t>
+            </a:r>
+          </a:p>
+          <a:p>
+            <a:pPr algn="l">
+              <a:defRPr sz="1600" b="0" u="none">
+                <a:solidFill>
+                  <a:srgbClr val="16213A"/>
+                </a:solidFill>
+                <a:latin typeface="Calibri"/>
+              </a:defRPr>
+            </a:pPr>
+            <a:r>
+              <a:t>• Cloud Run para backend</a:t>
+            </a:r>
+          </a:p>
+          <a:p>
+            <a:pPr algn="l">
+              <a:defRPr sz="1600" b="0" u="none">
+                <a:solidFill>
+                  <a:srgbClr val="16213A"/>
+                </a:solidFill>
+                <a:latin typeface="Calibri"/>
+              </a:defRPr>
+            </a:pPr>
+            <a:r>
+              <a:t>• Monitoreo y seguridad</a:t>
             </a:r>
           </a:p>
         </p:txBody>
@@ -5483,7 +6132,7 @@
     <p:bg>
       <p:bgPr>
         <a:solidFill>
-          <a:srgbClr val="F4F7FD"/>
+          <a:srgbClr val="F5F8FE"/>
         </a:solidFill>
         <a:effectLst/>
       </p:bgPr>
@@ -5504,13 +6153,13 @@
         <p:spPr>
           <a:xfrm>
             <a:off x="0" y="0"/>
-            <a:ext cx="12191695" cy="658368"/>
+            <a:ext cx="12191695" cy="640080"/>
           </a:xfrm>
           <a:prstGeom prst="rect">
             <a:avLst/>
           </a:prstGeom>
           <a:solidFill>
-            <a:srgbClr val="112D66"/>
+            <a:srgbClr val="143475"/>
           </a:solidFill>
           <a:ln>
             <a:noFill/>
@@ -5546,8 +6195,8 @@
         </p:nvSpPr>
         <p:spPr>
           <a:xfrm>
-            <a:off x="411480" y="109728"/>
-            <a:ext cx="6858000" cy="365760"/>
+            <a:off x="457200" y="109728"/>
+            <a:ext cx="6858000" cy="320040"/>
           </a:xfrm>
           <a:prstGeom prst="rect">
             <a:avLst/>
@@ -5561,7 +6210,7 @@
           <a:lstStyle/>
           <a:p>
             <a:pPr algn="l">
-              <a:defRPr sz="1600" b="1">
+              <a:defRPr sz="1600" b="1" u="none">
                 <a:solidFill>
                   <a:srgbClr val="FFFFFF"/>
                 </a:solidFill>
@@ -5582,8 +6231,8 @@
         </p:nvSpPr>
         <p:spPr>
           <a:xfrm>
-            <a:off x="731520" y="1051560"/>
-            <a:ext cx="10789920" cy="640080"/>
+            <a:off x="731520" y="914400"/>
+            <a:ext cx="10789920" cy="1280160"/>
           </a:xfrm>
           <a:prstGeom prst="rect">
             <a:avLst/>
@@ -5591,21 +6240,34 @@
           <a:noFill/>
         </p:spPr>
         <p:txBody>
-          <a:bodyPr wrap="none">
+          <a:bodyPr wrap="square">
             <a:spAutoFit/>
           </a:bodyPr>
           <a:lstStyle/>
           <a:p>
             <a:pPr algn="l">
-              <a:defRPr sz="3100" b="1">
-                <a:solidFill>
-                  <a:srgbClr val="112D66"/>
-                </a:solidFill>
-                <a:latin typeface="Calibri"/>
-              </a:defRPr>
-            </a:pPr>
-            <a:r>
-              <a:t>Tecnología y Arquitectura del Chatbot</a:t>
+              <a:defRPr sz="3400" b="1" u="none">
+                <a:solidFill>
+                  <a:srgbClr val="143475"/>
+                </a:solidFill>
+                <a:latin typeface="Calibri"/>
+              </a:defRPr>
+            </a:pPr>
+            <a:r>
+              <a:t>Inversión mensual estimada (USD)</a:t>
+            </a:r>
+          </a:p>
+          <a:p>
+            <a:pPr algn="l">
+              <a:defRPr sz="1800" b="0" u="none">
+                <a:solidFill>
+                  <a:srgbClr val="566177"/>
+                </a:solidFill>
+                <a:latin typeface="Calibri"/>
+              </a:defRPr>
+            </a:pPr>
+            <a:r>
+              <a:t>Referencia para 800 a 1000 consultas mensuales. Valores orientativos sujetos a uso y país.</a:t>
             </a:r>
           </a:p>
         </p:txBody>
@@ -5618,8 +6280,8 @@
         </p:nvSpPr>
         <p:spPr>
           <a:xfrm>
-            <a:off x="822960" y="1920240"/>
-            <a:ext cx="10424160" cy="749808"/>
+            <a:off x="731520" y="2011680"/>
+            <a:ext cx="3429000" cy="3474720"/>
           </a:xfrm>
           <a:prstGeom prst="roundRect">
             <a:avLst/>
@@ -5629,7 +6291,7 @@
           </a:solidFill>
           <a:ln>
             <a:solidFill>
-              <a:srgbClr val="DBE6F4"/>
+              <a:srgbClr val="D8E2F3"/>
             </a:solidFill>
           </a:ln>
         </p:spPr>
@@ -5648,32 +6310,71 @@
           </a:fontRef>
         </p:style>
         <p:txBody>
-          <a:bodyPr rtlCol="0" anchor="ctr"/>
-          <a:lstStyle/>
-          <a:p>
-            <a:pPr algn="l">
-              <a:defRPr sz="1600" b="1">
-                <a:solidFill>
-                  <a:srgbClr val="275DD2"/>
-                </a:solidFill>
-                <a:latin typeface="Calibri"/>
-              </a:defRPr>
-            </a:pPr>
-            <a:r>
-              <a:t>Flask + Python: </a:t>
-            </a:r>
-          </a:p>
-          <a:p>
-            <a:pPr algn="l">
-              <a:defRPr sz="1400" b="0">
-                <a:solidFill>
-                  <a:srgbClr val="172135"/>
-                </a:solidFill>
-                <a:latin typeface="Calibri"/>
-              </a:defRPr>
-            </a:pPr>
-            <a:r>
-              <a:t>API del chatbot, panel RRHH y autenticación.</a:t>
+          <a:bodyPr rtlCol="0" anchor="ctr" wrap="square"/>
+          <a:lstStyle/>
+          <a:p>
+            <a:pPr algn="ctr">
+              <a:defRPr sz="1800" b="1" u="none">
+                <a:solidFill>
+                  <a:srgbClr val="2D63D6"/>
+                </a:solidFill>
+                <a:latin typeface="Calibri"/>
+              </a:defRPr>
+            </a:pPr>
+            <a:r>
+              <a:t>Escenario base</a:t>
+            </a:r>
+          </a:p>
+          <a:p>
+            <a:pPr algn="ctr">
+              <a:defRPr sz="2200" b="1" u="none">
+                <a:solidFill>
+                  <a:srgbClr val="16213A"/>
+                </a:solidFill>
+                <a:latin typeface="Calibri"/>
+              </a:defRPr>
+            </a:pPr>
+            <a:r>
+              <a:t>USD 120 - 220 / mes</a:t>
+            </a:r>
+          </a:p>
+          <a:p>
+            <a:pPr algn="l">
+              <a:defRPr sz="1400" b="0" u="none">
+                <a:solidFill>
+                  <a:srgbClr val="16213A"/>
+                </a:solidFill>
+                <a:latin typeface="Calibri"/>
+              </a:defRPr>
+            </a:pPr>
+            <a:r>
+              <a:t>• Piloto controlado</a:t>
+            </a:r>
+          </a:p>
+          <a:p>
+            <a:pPr algn="l">
+              <a:defRPr sz="1400" b="0" u="none">
+                <a:solidFill>
+                  <a:srgbClr val="16213A"/>
+                </a:solidFill>
+                <a:latin typeface="Calibri"/>
+              </a:defRPr>
+            </a:pPr>
+            <a:r>
+              <a:t>• Volumen moderado</a:t>
+            </a:r>
+          </a:p>
+          <a:p>
+            <a:pPr algn="l">
+              <a:defRPr sz="1400" b="0" u="none">
+                <a:solidFill>
+                  <a:srgbClr val="16213A"/>
+                </a:solidFill>
+                <a:latin typeface="Calibri"/>
+              </a:defRPr>
+            </a:pPr>
+            <a:r>
+              <a:t>• Uso inicial de WhatsApp</a:t>
             </a:r>
           </a:p>
         </p:txBody>
@@ -5686,8 +6387,8 @@
         </p:nvSpPr>
         <p:spPr>
           <a:xfrm>
-            <a:off x="822960" y="2788920"/>
-            <a:ext cx="10424160" cy="749808"/>
+            <a:off x="4389120" y="2011680"/>
+            <a:ext cx="3429000" cy="3474720"/>
           </a:xfrm>
           <a:prstGeom prst="roundRect">
             <a:avLst/>
@@ -5697,7 +6398,7 @@
           </a:solidFill>
           <a:ln>
             <a:solidFill>
-              <a:srgbClr val="DBE6F4"/>
+              <a:srgbClr val="D8E2F3"/>
             </a:solidFill>
           </a:ln>
         </p:spPr>
@@ -5716,32 +6417,71 @@
           </a:fontRef>
         </p:style>
         <p:txBody>
-          <a:bodyPr rtlCol="0" anchor="ctr"/>
-          <a:lstStyle/>
-          <a:p>
-            <a:pPr algn="l">
-              <a:defRPr sz="1600" b="1">
-                <a:solidFill>
-                  <a:srgbClr val="275DD2"/>
-                </a:solidFill>
-                <a:latin typeface="Calibri"/>
-              </a:defRPr>
-            </a:pPr>
-            <a:r>
-              <a:t>Firestore: </a:t>
-            </a:r>
-          </a:p>
-          <a:p>
-            <a:pPr algn="l">
-              <a:defRPr sz="1400" b="0">
-                <a:solidFill>
-                  <a:srgbClr val="172135"/>
-                </a:solidFill>
-                <a:latin typeface="Calibri"/>
-              </a:defRPr>
-            </a:pPr>
-            <a:r>
-              <a:t>Persistencia de conversaciones, handoff, historial y configuración.</a:t>
+          <a:bodyPr rtlCol="0" anchor="ctr" wrap="square"/>
+          <a:lstStyle/>
+          <a:p>
+            <a:pPr algn="ctr">
+              <a:defRPr sz="1800" b="1" u="none">
+                <a:solidFill>
+                  <a:srgbClr val="15946E"/>
+                </a:solidFill>
+                <a:latin typeface="Calibri"/>
+              </a:defRPr>
+            </a:pPr>
+            <a:r>
+              <a:t>Escenario objetivo</a:t>
+            </a:r>
+          </a:p>
+          <a:p>
+            <a:pPr algn="ctr">
+              <a:defRPr sz="2200" b="1" u="none">
+                <a:solidFill>
+                  <a:srgbClr val="16213A"/>
+                </a:solidFill>
+                <a:latin typeface="Calibri"/>
+              </a:defRPr>
+            </a:pPr>
+            <a:r>
+              <a:t>USD 220 - 380 / mes</a:t>
+            </a:r>
+          </a:p>
+          <a:p>
+            <a:pPr algn="l">
+              <a:defRPr sz="1400" b="0" u="none">
+                <a:solidFill>
+                  <a:srgbClr val="16213A"/>
+                </a:solidFill>
+                <a:latin typeface="Calibri"/>
+              </a:defRPr>
+            </a:pPr>
+            <a:r>
+              <a:t>• 800-1000 consultas/mes</a:t>
+            </a:r>
+          </a:p>
+          <a:p>
+            <a:pPr algn="l">
+              <a:defRPr sz="1400" b="0" u="none">
+                <a:solidFill>
+                  <a:srgbClr val="16213A"/>
+                </a:solidFill>
+                <a:latin typeface="Calibri"/>
+              </a:defRPr>
+            </a:pPr>
+            <a:r>
+              <a:t>• Operación continua</a:t>
+            </a:r>
+          </a:p>
+          <a:p>
+            <a:pPr algn="l">
+              <a:defRPr sz="1400" b="0" u="none">
+                <a:solidFill>
+                  <a:srgbClr val="16213A"/>
+                </a:solidFill>
+                <a:latin typeface="Calibri"/>
+              </a:defRPr>
+            </a:pPr>
+            <a:r>
+              <a:t>• RRHH + métricas completas</a:t>
             </a:r>
           </a:p>
         </p:txBody>
@@ -5754,8 +6494,8 @@
         </p:nvSpPr>
         <p:spPr>
           <a:xfrm>
-            <a:off x="822960" y="3657600"/>
-            <a:ext cx="10424160" cy="749808"/>
+            <a:off x="8046720" y="2011680"/>
+            <a:ext cx="3429000" cy="3474720"/>
           </a:xfrm>
           <a:prstGeom prst="roundRect">
             <a:avLst/>
@@ -5765,7 +6505,7 @@
           </a:solidFill>
           <a:ln>
             <a:solidFill>
-              <a:srgbClr val="DBE6F4"/>
+              <a:srgbClr val="D8E2F3"/>
             </a:solidFill>
           </a:ln>
         </p:spPr>
@@ -5784,168 +6524,107 @@
           </a:fontRef>
         </p:style>
         <p:txBody>
-          <a:bodyPr rtlCol="0" anchor="ctr"/>
-          <a:lstStyle/>
-          <a:p>
-            <a:pPr algn="l">
-              <a:defRPr sz="1600" b="1">
-                <a:solidFill>
-                  <a:srgbClr val="275DD2"/>
-                </a:solidFill>
-                <a:latin typeface="Calibri"/>
-              </a:defRPr>
-            </a:pPr>
-            <a:r>
-              <a:t>Panel RRHH Web: </a:t>
-            </a:r>
-          </a:p>
-          <a:p>
-            <a:pPr algn="l">
-              <a:defRPr sz="1400" b="0">
-                <a:solidFill>
-                  <a:srgbClr val="172135"/>
-                </a:solidFill>
-                <a:latin typeface="Calibri"/>
-              </a:defRPr>
-            </a:pPr>
-            <a:r>
-              <a:t>Atención humana en vivo, reasignación y cierre de casos.</a:t>
-            </a:r>
-          </a:p>
-        </p:txBody>
-      </p:sp>
-      <p:sp>
-        <p:nvSpPr>
-          <p:cNvPr id="8" name="Rounded Rectangle 7"/>
-          <p:cNvSpPr/>
+          <a:bodyPr rtlCol="0" anchor="ctr" wrap="square"/>
+          <a:lstStyle/>
+          <a:p>
+            <a:pPr algn="ctr">
+              <a:defRPr sz="1800" b="1" u="none">
+                <a:solidFill>
+                  <a:srgbClr val="E8931F"/>
+                </a:solidFill>
+                <a:latin typeface="Calibri"/>
+              </a:defRPr>
+            </a:pPr>
+            <a:r>
+              <a:t>Escenario escalado</a:t>
+            </a:r>
+          </a:p>
+          <a:p>
+            <a:pPr algn="ctr">
+              <a:defRPr sz="2200" b="1" u="none">
+                <a:solidFill>
+                  <a:srgbClr val="16213A"/>
+                </a:solidFill>
+                <a:latin typeface="Calibri"/>
+              </a:defRPr>
+            </a:pPr>
+            <a:r>
+              <a:t>USD 380 - 650 / mes</a:t>
+            </a:r>
+          </a:p>
+          <a:p>
+            <a:pPr algn="l">
+              <a:defRPr sz="1400" b="0" u="none">
+                <a:solidFill>
+                  <a:srgbClr val="16213A"/>
+                </a:solidFill>
+                <a:latin typeface="Calibri"/>
+              </a:defRPr>
+            </a:pPr>
+            <a:r>
+              <a:t>• Más empresas/sucursales</a:t>
+            </a:r>
+          </a:p>
+          <a:p>
+            <a:pPr algn="l">
+              <a:defRPr sz="1400" b="0" u="none">
+                <a:solidFill>
+                  <a:srgbClr val="16213A"/>
+                </a:solidFill>
+                <a:latin typeface="Calibri"/>
+              </a:defRPr>
+            </a:pPr>
+            <a:r>
+              <a:t>• Mayor tráfico</a:t>
+            </a:r>
+          </a:p>
+          <a:p>
+            <a:pPr algn="l">
+              <a:defRPr sz="1400" b="0" u="none">
+                <a:solidFill>
+                  <a:srgbClr val="16213A"/>
+                </a:solidFill>
+                <a:latin typeface="Calibri"/>
+              </a:defRPr>
+            </a:pPr>
+            <a:r>
+              <a:t>• Campañas y plantillas WhatsApp</a:t>
+            </a:r>
+          </a:p>
+        </p:txBody>
+      </p:sp>
+      <p:sp>
+        <p:nvSpPr>
+          <p:cNvPr id="8" name="TextBox 7"/>
+          <p:cNvSpPr txBox="1"/>
           <p:nvPr/>
         </p:nvSpPr>
         <p:spPr>
           <a:xfrm>
-            <a:off x="822960" y="4526280"/>
-            <a:ext cx="10424160" cy="749808"/>
-          </a:xfrm>
-          <a:prstGeom prst="roundRect">
+            <a:off x="822960" y="5669280"/>
+            <a:ext cx="10607040" cy="502920"/>
+          </a:xfrm>
+          <a:prstGeom prst="rect">
             <a:avLst/>
           </a:prstGeom>
-          <a:solidFill>
-            <a:srgbClr val="FFFFFF"/>
-          </a:solidFill>
-          <a:ln>
-            <a:solidFill>
-              <a:srgbClr val="DBE6F4"/>
-            </a:solidFill>
-          </a:ln>
-        </p:spPr>
-        <p:style>
-          <a:lnRef idx="1">
-            <a:schemeClr val="accent1"/>
-          </a:lnRef>
-          <a:fillRef idx="3">
-            <a:schemeClr val="accent1"/>
-          </a:fillRef>
-          <a:effectRef idx="2">
-            <a:schemeClr val="accent1"/>
-          </a:effectRef>
-          <a:fontRef idx="minor">
-            <a:schemeClr val="lt1"/>
-          </a:fontRef>
-        </p:style>
-        <p:txBody>
-          <a:bodyPr rtlCol="0" anchor="ctr"/>
-          <a:lstStyle/>
-          <a:p>
-            <a:pPr algn="l">
-              <a:defRPr sz="1600" b="1">
-                <a:solidFill>
-                  <a:srgbClr val="275DD2"/>
-                </a:solidFill>
-                <a:latin typeface="Calibri"/>
-              </a:defRPr>
-            </a:pPr>
-            <a:r>
-              <a:t>RBAC + Configuración: </a:t>
-            </a:r>
-          </a:p>
-          <a:p>
-            <a:pPr algn="l">
-              <a:defRPr sz="1400" b="0">
-                <a:solidFill>
-                  <a:srgbClr val="172135"/>
-                </a:solidFill>
-                <a:latin typeface="Calibri"/>
-              </a:defRPr>
-            </a:pPr>
-            <a:r>
-              <a:t>Usuarios, roles, permisos y gestión multiempresa/sucursal.</a:t>
-            </a:r>
-          </a:p>
-        </p:txBody>
-      </p:sp>
-      <p:sp>
-        <p:nvSpPr>
-          <p:cNvPr id="9" name="Rounded Rectangle 8"/>
-          <p:cNvSpPr/>
-          <p:nvPr/>
-        </p:nvSpPr>
-        <p:spPr>
-          <a:xfrm>
-            <a:off x="822960" y="5394960"/>
-            <a:ext cx="10424160" cy="749808"/>
-          </a:xfrm>
-          <a:prstGeom prst="roundRect">
-            <a:avLst/>
-          </a:prstGeom>
-          <a:solidFill>
-            <a:srgbClr val="FFFFFF"/>
-          </a:solidFill>
-          <a:ln>
-            <a:solidFill>
-              <a:srgbClr val="DBE6F4"/>
-            </a:solidFill>
-          </a:ln>
-        </p:spPr>
-        <p:style>
-          <a:lnRef idx="1">
-            <a:schemeClr val="accent1"/>
-          </a:lnRef>
-          <a:fillRef idx="3">
-            <a:schemeClr val="accent1"/>
-          </a:fillRef>
-          <a:effectRef idx="2">
-            <a:schemeClr val="accent1"/>
-          </a:effectRef>
-          <a:fontRef idx="minor">
-            <a:schemeClr val="lt1"/>
-          </a:fontRef>
-        </p:style>
-        <p:txBody>
-          <a:bodyPr rtlCol="0" anchor="ctr"/>
-          <a:lstStyle/>
-          <a:p>
-            <a:pPr algn="l">
-              <a:defRPr sz="1600" b="1">
-                <a:solidFill>
-                  <a:srgbClr val="275DD2"/>
-                </a:solidFill>
-                <a:latin typeface="Calibri"/>
-              </a:defRPr>
-            </a:pPr>
-            <a:r>
-              <a:t>Cloud Ready: </a:t>
-            </a:r>
-          </a:p>
-          <a:p>
-            <a:pPr algn="l">
-              <a:defRPr sz="1400" b="0">
-                <a:solidFill>
-                  <a:srgbClr val="172135"/>
-                </a:solidFill>
-                <a:latin typeface="Calibri"/>
-              </a:defRPr>
-            </a:pPr>
-            <a:r>
-              <a:t>Despliegue en Cloud Run/Firebase con escalabilidad administrada.</a:t>
+          <a:noFill/>
+        </p:spPr>
+        <p:txBody>
+          <a:bodyPr wrap="square">
+            <a:spAutoFit/>
+          </a:bodyPr>
+          <a:lstStyle/>
+          <a:p>
+            <a:pPr algn="ctr">
+              <a:defRPr sz="1500" b="1" u="none">
+                <a:solidFill>
+                  <a:srgbClr val="143475"/>
+                </a:solidFill>
+                <a:latin typeface="Calibri"/>
+              </a:defRPr>
+            </a:pPr>
+            <a:r>
+              <a:t>Sugerencia de presupuesto inicial al comité: USD 300/mes + 20% de contingencia durante los primeros 90 días.</a:t>
             </a:r>
           </a:p>
         </p:txBody>
@@ -5964,7 +6643,7 @@
     <p:bg>
       <p:bgPr>
         <a:solidFill>
-          <a:srgbClr val="F4F7FD"/>
+          <a:srgbClr val="F5F8FE"/>
         </a:solidFill>
         <a:effectLst/>
       </p:bgPr>
@@ -5985,13 +6664,13 @@
         <p:spPr>
           <a:xfrm>
             <a:off x="0" y="0"/>
-            <a:ext cx="12191695" cy="658368"/>
+            <a:ext cx="12191695" cy="640080"/>
           </a:xfrm>
           <a:prstGeom prst="rect">
             <a:avLst/>
           </a:prstGeom>
           <a:solidFill>
-            <a:srgbClr val="112D66"/>
+            <a:srgbClr val="143475"/>
           </a:solidFill>
           <a:ln>
             <a:noFill/>
@@ -6027,8 +6706,8 @@
         </p:nvSpPr>
         <p:spPr>
           <a:xfrm>
-            <a:off x="411480" y="109728"/>
-            <a:ext cx="6858000" cy="365760"/>
+            <a:off x="457200" y="109728"/>
+            <a:ext cx="6858000" cy="320040"/>
           </a:xfrm>
           <a:prstGeom prst="rect">
             <a:avLst/>
@@ -6042,7 +6721,7 @@
           <a:lstStyle/>
           <a:p>
             <a:pPr algn="l">
-              <a:defRPr sz="1600" b="1">
+              <a:defRPr sz="1600" b="1" u="none">
                 <a:solidFill>
                   <a:srgbClr val="FFFFFF"/>
                 </a:solidFill>
@@ -6063,8 +6742,8 @@
         </p:nvSpPr>
         <p:spPr>
           <a:xfrm>
-            <a:off x="731520" y="1005840"/>
-            <a:ext cx="10789920" cy="640080"/>
+            <a:off x="731520" y="914400"/>
+            <a:ext cx="10789920" cy="1280160"/>
           </a:xfrm>
           <a:prstGeom prst="rect">
             <a:avLst/>
@@ -6072,21 +6751,34 @@
           <a:noFill/>
         </p:spPr>
         <p:txBody>
-          <a:bodyPr wrap="none">
+          <a:bodyPr wrap="square">
             <a:spAutoFit/>
           </a:bodyPr>
           <a:lstStyle/>
           <a:p>
             <a:pPr algn="l">
-              <a:defRPr sz="3100" b="1">
-                <a:solidFill>
-                  <a:srgbClr val="112D66"/>
-                </a:solidFill>
-                <a:latin typeface="Calibri"/>
-              </a:defRPr>
-            </a:pPr>
-            <a:r>
-              <a:t>Impacto en la Organización y Próximos Pasos</a:t>
+              <a:defRPr sz="3400" b="1" u="none">
+                <a:solidFill>
+                  <a:srgbClr val="143475"/>
+                </a:solidFill>
+                <a:latin typeface="Calibri"/>
+              </a:defRPr>
+            </a:pPr>
+            <a:r>
+              <a:t>Plan de implementación (90 días)</a:t>
+            </a:r>
+          </a:p>
+          <a:p>
+            <a:pPr algn="l">
+              <a:defRPr sz="1800" b="0" u="none">
+                <a:solidFill>
+                  <a:srgbClr val="566177"/>
+                </a:solidFill>
+                <a:latin typeface="Calibri"/>
+              </a:defRPr>
+            </a:pPr>
+            <a:r>
+              <a:t>Ejecución por etapas con hitos de negocio.</a:t>
             </a:r>
           </a:p>
         </p:txBody>
@@ -6099,8 +6791,8 @@
         </p:nvSpPr>
         <p:spPr>
           <a:xfrm>
-            <a:off x="731520" y="1828800"/>
-            <a:ext cx="5212080" cy="3749039"/>
+            <a:off x="777240" y="2011680"/>
+            <a:ext cx="3749039" cy="3566160"/>
           </a:xfrm>
           <a:prstGeom prst="roundRect">
             <a:avLst/>
@@ -6110,7 +6802,7 @@
           </a:solidFill>
           <a:ln>
             <a:solidFill>
-              <a:srgbClr val="D6E1F2"/>
+              <a:srgbClr val="D8E2F3"/>
             </a:solidFill>
           </a:ln>
         </p:spPr>
@@ -6129,71 +6821,58 @@
           </a:fontRef>
         </p:style>
         <p:txBody>
-          <a:bodyPr rtlCol="0" anchor="ctr"/>
-          <a:lstStyle/>
-          <a:p>
-            <a:pPr algn="l">
-              <a:defRPr sz="2000" b="1">
-                <a:solidFill>
-                  <a:srgbClr val="275DD2"/>
-                </a:solidFill>
-                <a:latin typeface="Calibri"/>
-              </a:defRPr>
-            </a:pPr>
-            <a:r>
-              <a:t>Impacto actual</a:t>
-            </a:r>
-          </a:p>
-          <a:p>
-            <a:pPr algn="l">
-              <a:defRPr sz="1500" b="0">
-                <a:solidFill>
-                  <a:srgbClr val="172135"/>
-                </a:solidFill>
-                <a:latin typeface="Calibri"/>
-              </a:defRPr>
-            </a:pPr>
-            <a:r>
-              <a:t>• Respuesta inmediata a FAQs de RRHH.</a:t>
-            </a:r>
-          </a:p>
-          <a:p>
-            <a:pPr algn="l">
-              <a:defRPr sz="1500" b="0">
-                <a:solidFill>
-                  <a:srgbClr val="172135"/>
-                </a:solidFill>
-                <a:latin typeface="Calibri"/>
-              </a:defRPr>
-            </a:pPr>
-            <a:r>
-              <a:t>• Derivación automática a agentes cuando se requiere intervención humana.</a:t>
-            </a:r>
-          </a:p>
-          <a:p>
-            <a:pPr algn="l">
-              <a:defRPr sz="1500" b="0">
-                <a:solidFill>
-                  <a:srgbClr val="172135"/>
-                </a:solidFill>
-                <a:latin typeface="Calibri"/>
-              </a:defRPr>
-            </a:pPr>
-            <a:r>
-              <a:t>• Operación por empresa/sucursal con trazabilidad completa.</a:t>
-            </a:r>
-          </a:p>
-          <a:p>
-            <a:pPr algn="l">
-              <a:defRPr sz="1500" b="0">
-                <a:solidFill>
-                  <a:srgbClr val="172135"/>
-                </a:solidFill>
-                <a:latin typeface="Calibri"/>
-              </a:defRPr>
-            </a:pPr>
-            <a:r>
-              <a:t>• Menor carga operativa para RRHH y mejor experiencia del colaborador.</a:t>
+          <a:bodyPr rtlCol="0" anchor="ctr" wrap="square"/>
+          <a:lstStyle/>
+          <a:p>
+            <a:pPr algn="l">
+              <a:defRPr sz="2000" b="1" u="none">
+                <a:solidFill>
+                  <a:srgbClr val="2D63D6"/>
+                </a:solidFill>
+                <a:latin typeface="Calibri"/>
+              </a:defRPr>
+            </a:pPr>
+            <a:r>
+              <a:t>Fase 1 (0-30 días)</a:t>
+            </a:r>
+          </a:p>
+          <a:p>
+            <a:pPr algn="l">
+              <a:defRPr sz="1600" b="0" u="none">
+                <a:solidFill>
+                  <a:srgbClr val="16213A"/>
+                </a:solidFill>
+                <a:latin typeface="Calibri"/>
+              </a:defRPr>
+            </a:pPr>
+            <a:r>
+              <a:t>• Ajustes finales del chatbot</a:t>
+            </a:r>
+          </a:p>
+          <a:p>
+            <a:pPr algn="l">
+              <a:defRPr sz="1600" b="0" u="none">
+                <a:solidFill>
+                  <a:srgbClr val="16213A"/>
+                </a:solidFill>
+                <a:latin typeface="Calibri"/>
+              </a:defRPr>
+            </a:pPr>
+            <a:r>
+              <a:t>• Validación de métricas</a:t>
+            </a:r>
+          </a:p>
+          <a:p>
+            <a:pPr algn="l">
+              <a:defRPr sz="1600" b="0" u="none">
+                <a:solidFill>
+                  <a:srgbClr val="16213A"/>
+                </a:solidFill>
+                <a:latin typeface="Calibri"/>
+              </a:defRPr>
+            </a:pPr>
+            <a:r>
+              <a:t>• Prueba controlada</a:t>
             </a:r>
           </a:p>
         </p:txBody>
@@ -6206,8 +6885,8 @@
         </p:nvSpPr>
         <p:spPr>
           <a:xfrm>
-            <a:off x="6217920" y="1828800"/>
-            <a:ext cx="5212080" cy="3749039"/>
+            <a:off x="4617720" y="2011680"/>
+            <a:ext cx="3749039" cy="3566160"/>
           </a:xfrm>
           <a:prstGeom prst="roundRect">
             <a:avLst/>
@@ -6217,7 +6896,7 @@
           </a:solidFill>
           <a:ln>
             <a:solidFill>
-              <a:srgbClr val="D6E1F2"/>
+              <a:srgbClr val="D8E2F3"/>
             </a:solidFill>
           </a:ln>
         </p:spPr>
@@ -6236,107 +6915,152 @@
           </a:fontRef>
         </p:style>
         <p:txBody>
-          <a:bodyPr rtlCol="0" anchor="ctr"/>
-          <a:lstStyle/>
-          <a:p>
-            <a:pPr algn="l">
-              <a:defRPr sz="2000" b="1">
-                <a:solidFill>
-                  <a:srgbClr val="148F68"/>
-                </a:solidFill>
-                <a:latin typeface="Calibri"/>
-              </a:defRPr>
-            </a:pPr>
-            <a:r>
-              <a:t>Próxima etapa</a:t>
-            </a:r>
-          </a:p>
-          <a:p>
-            <a:pPr algn="l">
-              <a:defRPr sz="1500" b="0">
-                <a:solidFill>
-                  <a:srgbClr val="172135"/>
-                </a:solidFill>
-                <a:latin typeface="Calibri"/>
-              </a:defRPr>
-            </a:pPr>
-            <a:r>
-              <a:t>• Integración con WhatsApp Business.</a:t>
-            </a:r>
-          </a:p>
-          <a:p>
-            <a:pPr algn="l">
-              <a:defRPr sz="1500" b="0">
-                <a:solidFill>
-                  <a:srgbClr val="172135"/>
-                </a:solidFill>
-                <a:latin typeface="Calibri"/>
-              </a:defRPr>
-            </a:pPr>
-            <a:r>
-              <a:t>• Ajustes de métricas por SLA y productividad de agentes.</a:t>
-            </a:r>
-          </a:p>
-          <a:p>
-            <a:pPr algn="l">
-              <a:defRPr sz="1500" b="0">
-                <a:solidFill>
-                  <a:srgbClr val="172135"/>
-                </a:solidFill>
-                <a:latin typeface="Calibri"/>
-              </a:defRPr>
-            </a:pPr>
-            <a:r>
-              <a:t>• Despliegue cloud productivo con hardening de seguridad.</a:t>
-            </a:r>
-          </a:p>
-          <a:p>
-            <a:pPr algn="l">
-              <a:defRPr sz="1500" b="0">
-                <a:solidFill>
-                  <a:srgbClr val="172135"/>
-                </a:solidFill>
-                <a:latin typeface="Calibri"/>
-              </a:defRPr>
-            </a:pPr>
-            <a:r>
-              <a:t>• Escalado a nuevas áreas y compañías del grupo.</a:t>
-            </a:r>
-          </a:p>
-        </p:txBody>
-      </p:sp>
-      <p:sp>
-        <p:nvSpPr>
-          <p:cNvPr id="7" name="TextBox 6"/>
-          <p:cNvSpPr txBox="1"/>
+          <a:bodyPr rtlCol="0" anchor="ctr" wrap="square"/>
+          <a:lstStyle/>
+          <a:p>
+            <a:pPr algn="l">
+              <a:defRPr sz="2000" b="1" u="none">
+                <a:solidFill>
+                  <a:srgbClr val="2D63D6"/>
+                </a:solidFill>
+                <a:latin typeface="Calibri"/>
+              </a:defRPr>
+            </a:pPr>
+            <a:r>
+              <a:t>Fase 2 (31-60 días)</a:t>
+            </a:r>
+          </a:p>
+          <a:p>
+            <a:pPr algn="l">
+              <a:defRPr sz="1600" b="0" u="none">
+                <a:solidFill>
+                  <a:srgbClr val="16213A"/>
+                </a:solidFill>
+                <a:latin typeface="Calibri"/>
+              </a:defRPr>
+            </a:pPr>
+            <a:r>
+              <a:t>• Integración WhatsApp</a:t>
+            </a:r>
+          </a:p>
+          <a:p>
+            <a:pPr algn="l">
+              <a:defRPr sz="1600" b="0" u="none">
+                <a:solidFill>
+                  <a:srgbClr val="16213A"/>
+                </a:solidFill>
+                <a:latin typeface="Calibri"/>
+              </a:defRPr>
+            </a:pPr>
+            <a:r>
+              <a:t>• Capacitación de RRHH</a:t>
+            </a:r>
+          </a:p>
+          <a:p>
+            <a:pPr algn="l">
+              <a:defRPr sz="1600" b="0" u="none">
+                <a:solidFill>
+                  <a:srgbClr val="16213A"/>
+                </a:solidFill>
+                <a:latin typeface="Calibri"/>
+              </a:defRPr>
+            </a:pPr>
+            <a:r>
+              <a:t>• Inicio operación asistida</a:t>
+            </a:r>
+          </a:p>
+        </p:txBody>
+      </p:sp>
+      <p:sp>
+        <p:nvSpPr>
+          <p:cNvPr id="7" name="Rounded Rectangle 6"/>
+          <p:cNvSpPr/>
           <p:nvPr/>
         </p:nvSpPr>
         <p:spPr>
           <a:xfrm>
-            <a:off x="777240" y="5806440"/>
-            <a:ext cx="10607040" cy="411480"/>
-          </a:xfrm>
-          <a:prstGeom prst="rect">
+            <a:off x="8458200" y="2011680"/>
+            <a:ext cx="3749039" cy="3566160"/>
+          </a:xfrm>
+          <a:prstGeom prst="roundRect">
             <a:avLst/>
           </a:prstGeom>
-          <a:noFill/>
-        </p:spPr>
-        <p:txBody>
-          <a:bodyPr wrap="none">
-            <a:spAutoFit/>
-          </a:bodyPr>
-          <a:lstStyle/>
-          <a:p>
-            <a:pPr algn="ctr">
-              <a:defRPr sz="1400" b="1">
-                <a:solidFill>
-                  <a:srgbClr val="148F68"/>
-                </a:solidFill>
-                <a:latin typeface="Calibri"/>
-              </a:defRPr>
-            </a:pPr>
-            <a:r>
-              <a:t>Visión: consolidar un canal único, auditable y escalable para la gestión de consultas de RRHH.</a:t>
+          <a:solidFill>
+            <a:srgbClr val="FFFFFF"/>
+          </a:solidFill>
+          <a:ln>
+            <a:solidFill>
+              <a:srgbClr val="D8E2F3"/>
+            </a:solidFill>
+          </a:ln>
+        </p:spPr>
+        <p:style>
+          <a:lnRef idx="1">
+            <a:schemeClr val="accent1"/>
+          </a:lnRef>
+          <a:fillRef idx="3">
+            <a:schemeClr val="accent1"/>
+          </a:fillRef>
+          <a:effectRef idx="2">
+            <a:schemeClr val="accent1"/>
+          </a:effectRef>
+          <a:fontRef idx="minor">
+            <a:schemeClr val="lt1"/>
+          </a:fontRef>
+        </p:style>
+        <p:txBody>
+          <a:bodyPr rtlCol="0" anchor="ctr" wrap="square"/>
+          <a:lstStyle/>
+          <a:p>
+            <a:pPr algn="l">
+              <a:defRPr sz="2000" b="1" u="none">
+                <a:solidFill>
+                  <a:srgbClr val="2D63D6"/>
+                </a:solidFill>
+                <a:latin typeface="Calibri"/>
+              </a:defRPr>
+            </a:pPr>
+            <a:r>
+              <a:t>Fase 3 (61-90 días)</a:t>
+            </a:r>
+          </a:p>
+          <a:p>
+            <a:pPr algn="l">
+              <a:defRPr sz="1600" b="0" u="none">
+                <a:solidFill>
+                  <a:srgbClr val="16213A"/>
+                </a:solidFill>
+                <a:latin typeface="Calibri"/>
+              </a:defRPr>
+            </a:pPr>
+            <a:r>
+              <a:t>• Escalado por empresa/sucursal</a:t>
+            </a:r>
+          </a:p>
+          <a:p>
+            <a:pPr algn="l">
+              <a:defRPr sz="1600" b="0" u="none">
+                <a:solidFill>
+                  <a:srgbClr val="16213A"/>
+                </a:solidFill>
+                <a:latin typeface="Calibri"/>
+              </a:defRPr>
+            </a:pPr>
+            <a:r>
+              <a:t>• Optimización de costos</a:t>
+            </a:r>
+          </a:p>
+          <a:p>
+            <a:pPr algn="l">
+              <a:defRPr sz="1600" b="0" u="none">
+                <a:solidFill>
+                  <a:srgbClr val="16213A"/>
+                </a:solidFill>
+                <a:latin typeface="Calibri"/>
+              </a:defRPr>
+            </a:pPr>
+            <a:r>
+              <a:t>• KPIs para comité</a:t>
             </a:r>
           </a:p>
         </p:txBody>

</xml_diff>

<commit_message>
docs: simplify executive deck language and add visual backgrounds
Co-authored-by: deboraq <deboraq@users.noreply.github.com>
</commit_message>
<xml_diff>
--- a/docs/Presentacion_Chatbot_RRHH_Bacar.pptx
+++ b/docs/Presentacion_Chatbot_RRHH_Bacar.pptx
@@ -14,7 +14,6 @@
     <p:sldId id="262" r:id="rId13"/>
     <p:sldId id="263" r:id="rId14"/>
     <p:sldId id="264" r:id="rId15"/>
-    <p:sldId id="265" r:id="rId16"/>
   </p:sldIdLst>
   <p:sldSz cx="12191695" cy="6858000" type="screen4x3"/>
   <p:notesSz cx="6858000" cy="9144000"/>
@@ -3090,14 +3089,6 @@
 <file path=ppt/slides/slide1.xml><?xml version="1.0" encoding="utf-8"?>
 <p:sld xmlns:a="http://schemas.openxmlformats.org/drawingml/2006/main" xmlns:p="http://schemas.openxmlformats.org/presentationml/2006/main" xmlns:r="http://schemas.openxmlformats.org/officeDocument/2006/relationships">
   <p:cSld>
-    <p:bg>
-      <p:bgPr>
-        <a:solidFill>
-          <a:srgbClr val="F5F8FE"/>
-        </a:solidFill>
-        <a:effectLst/>
-      </p:bgPr>
-    </p:bg>
     <p:spTree>
       <p:nvGrpSpPr>
         <p:cNvPr id="1" name=""/>
@@ -3105,22 +3096,46 @@
         <p:nvPr/>
       </p:nvGrpSpPr>
       <p:grpSpPr/>
-      <p:sp>
-        <p:nvSpPr>
-          <p:cNvPr id="2" name="Rectangle 1"/>
+      <p:pic>
+        <p:nvPicPr>
+          <p:cNvPr id="2" name="Picture 1" descr="chatbot-bg-1.jpg"/>
+          <p:cNvPicPr>
+            <a:picLocks noChangeAspect="1"/>
+          </p:cNvPicPr>
+          <p:nvPr/>
+        </p:nvPicPr>
+        <p:blipFill>
+          <a:blip r:embed="rId2"/>
+          <a:stretch>
+            <a:fillRect/>
+          </a:stretch>
+        </p:blipFill>
+        <p:spPr>
+          <a:xfrm>
+            <a:off x="0" y="0"/>
+            <a:ext cx="12191695" cy="6858000"/>
+          </a:xfrm>
+          <a:prstGeom prst="rect">
+            <a:avLst/>
+          </a:prstGeom>
+        </p:spPr>
+      </p:pic>
+      <p:sp>
+        <p:nvSpPr>
+          <p:cNvPr id="3" name="Rectangle 2"/>
           <p:cNvSpPr/>
           <p:nvPr/>
         </p:nvSpPr>
         <p:spPr>
           <a:xfrm>
             <a:off x="0" y="0"/>
-            <a:ext cx="12191695" cy="640080"/>
+            <a:ext cx="12191695" cy="6858000"/>
           </a:xfrm>
           <a:prstGeom prst="rect">
             <a:avLst/>
           </a:prstGeom>
           <a:solidFill>
-            <a:srgbClr val="143475"/>
+            <a:srgbClr val="070F1E"/>
           </a:solidFill>
           <a:ln>
             <a:noFill/>
@@ -3150,167 +3165,20 @@
       </p:sp>
       <p:sp>
         <p:nvSpPr>
-          <p:cNvPr id="3" name="TextBox 2"/>
-          <p:cNvSpPr txBox="1"/>
+          <p:cNvPr id="4" name="Rectangle 3"/>
+          <p:cNvSpPr/>
           <p:nvPr/>
         </p:nvSpPr>
         <p:spPr>
           <a:xfrm>
-            <a:off x="457200" y="109728"/>
-            <a:ext cx="6858000" cy="320040"/>
+            <a:off x="0" y="0"/>
+            <a:ext cx="12191695" cy="621792"/>
           </a:xfrm>
           <a:prstGeom prst="rect">
             <a:avLst/>
           </a:prstGeom>
-          <a:noFill/>
-        </p:spPr>
-        <p:txBody>
-          <a:bodyPr wrap="none">
-            <a:spAutoFit/>
-          </a:bodyPr>
-          <a:lstStyle/>
-          <a:p>
-            <a:pPr algn="l">
-              <a:defRPr sz="1600" b="1" u="none">
-                <a:solidFill>
-                  <a:srgbClr val="FFFFFF"/>
-                </a:solidFill>
-                <a:latin typeface="Calibri"/>
-              </a:defRPr>
-            </a:pPr>
-            <a:r>
-              <a:t>BacarIT  |  Chatbot RRHH</a:t>
-            </a:r>
-          </a:p>
-        </p:txBody>
-      </p:sp>
-      <p:sp>
-        <p:nvSpPr>
-          <p:cNvPr id="4" name="TextBox 3"/>
-          <p:cNvSpPr txBox="1"/>
-          <p:nvPr/>
-        </p:nvSpPr>
-        <p:spPr>
-          <a:xfrm>
-            <a:off x="731520" y="1325880"/>
-            <a:ext cx="10789920" cy="1280160"/>
-          </a:xfrm>
-          <a:prstGeom prst="rect">
-            <a:avLst/>
-          </a:prstGeom>
-          <a:noFill/>
-        </p:spPr>
-        <p:txBody>
-          <a:bodyPr wrap="square">
-            <a:spAutoFit/>
-          </a:bodyPr>
-          <a:lstStyle/>
-          <a:p>
-            <a:pPr algn="l">
-              <a:defRPr sz="3400" b="1" u="none">
-                <a:solidFill>
-                  <a:srgbClr val="143475"/>
-                </a:solidFill>
-                <a:latin typeface="Calibri"/>
-              </a:defRPr>
-            </a:pPr>
-            <a:r>
-              <a:t>CHATBOT RRHH</a:t>
-            </a:r>
-          </a:p>
-          <a:p>
-            <a:pPr algn="l">
-              <a:defRPr sz="1800" b="0" u="none">
-                <a:solidFill>
-                  <a:srgbClr val="566177"/>
-                </a:solidFill>
-                <a:latin typeface="Calibri"/>
-              </a:defRPr>
-            </a:pPr>
-            <a:r>
-              <a:t>Propuesta ejecutiva para mejorar servicio al colaborador y eficiencia operativa</a:t>
-            </a:r>
-          </a:p>
-        </p:txBody>
-      </p:sp>
-      <p:sp>
-        <p:nvSpPr>
-          <p:cNvPr id="5" name="TextBox 4"/>
-          <p:cNvSpPr txBox="1"/>
-          <p:nvPr/>
-        </p:nvSpPr>
-        <p:spPr>
-          <a:xfrm>
-            <a:off x="822960" y="2514600"/>
-            <a:ext cx="10515600" cy="1463040"/>
-          </a:xfrm>
-          <a:prstGeom prst="rect">
-            <a:avLst/>
-          </a:prstGeom>
-          <a:noFill/>
-        </p:spPr>
-        <p:txBody>
-          <a:bodyPr wrap="square">
-            <a:spAutoFit/>
-          </a:bodyPr>
-          <a:lstStyle/>
-          <a:p>
-            <a:pPr algn="l">
-              <a:defRPr sz="1900" b="0" u="none">
-                <a:solidFill>
-                  <a:srgbClr val="16213A"/>
-                </a:solidFill>
-                <a:latin typeface="Calibri"/>
-              </a:defRPr>
-            </a:pPr>
-            <a:r>
-              <a:t>• Atención rápida y consistente para consultas frecuentes</a:t>
-            </a:r>
-          </a:p>
-          <a:p>
-            <a:pPr algn="l">
-              <a:defRPr sz="1900" b="0" u="none">
-                <a:solidFill>
-                  <a:srgbClr val="16213A"/>
-                </a:solidFill>
-                <a:latin typeface="Calibri"/>
-              </a:defRPr>
-            </a:pPr>
-            <a:r>
-              <a:t>• Escalamiento directo a RRHH cuando la consulta requiere intervención humana</a:t>
-            </a:r>
-          </a:p>
-          <a:p>
-            <a:pPr algn="l">
-              <a:defRPr sz="1900" b="0" u="none">
-                <a:solidFill>
-                  <a:srgbClr val="16213A"/>
-                </a:solidFill>
-                <a:latin typeface="Calibri"/>
-              </a:defRPr>
-            </a:pPr>
-            <a:r>
-              <a:t>• Operación por empresa/sucursal con trazabilidad completa</a:t>
-            </a:r>
-          </a:p>
-        </p:txBody>
-      </p:sp>
-      <p:sp>
-        <p:nvSpPr>
-          <p:cNvPr id="6" name="Rounded Rectangle 5"/>
-          <p:cNvSpPr/>
-          <p:nvPr/>
-        </p:nvSpPr>
-        <p:spPr>
-          <a:xfrm>
-            <a:off x="822960" y="4754880"/>
-            <a:ext cx="4754880" cy="566928"/>
-          </a:xfrm>
-          <a:prstGeom prst="roundRect">
-            <a:avLst/>
-          </a:prstGeom>
           <a:solidFill>
-            <a:srgbClr val="15946E"/>
+            <a:srgbClr val="133271"/>
           </a:solidFill>
           <a:ln>
             <a:noFill/>
@@ -3331,85 +3199,6 @@
           </a:fontRef>
         </p:style>
         <p:txBody>
-          <a:bodyPr rtlCol="0" anchor="ctr" wrap="square"/>
-          <a:lstStyle/>
-          <a:p>
-            <a:pPr algn="ctr">
-              <a:defRPr sz="1500" b="1" u="none">
-                <a:solidFill>
-                  <a:srgbClr val="FFFFFF"/>
-                </a:solidFill>
-                <a:latin typeface="Calibri"/>
-              </a:defRPr>
-            </a:pPr>
-            <a:r>
-              <a:t>Objetivo: aprobar implementación productiva</a:t>
-            </a:r>
-          </a:p>
-        </p:txBody>
-      </p:sp>
-    </p:spTree>
-  </p:cSld>
-  <p:clrMapOvr>
-    <a:masterClrMapping/>
-  </p:clrMapOvr>
-</p:sld>
-</file>
-
-<file path=ppt/slides/slide10.xml><?xml version="1.0" encoding="utf-8"?>
-<p:sld xmlns:a="http://schemas.openxmlformats.org/drawingml/2006/main" xmlns:p="http://schemas.openxmlformats.org/presentationml/2006/main" xmlns:r="http://schemas.openxmlformats.org/officeDocument/2006/relationships">
-  <p:cSld>
-    <p:bg>
-      <p:bgPr>
-        <a:solidFill>
-          <a:srgbClr val="F5F8FE"/>
-        </a:solidFill>
-        <a:effectLst/>
-      </p:bgPr>
-    </p:bg>
-    <p:spTree>
-      <p:nvGrpSpPr>
-        <p:cNvPr id="1" name=""/>
-        <p:cNvGrpSpPr/>
-        <p:nvPr/>
-      </p:nvGrpSpPr>
-      <p:grpSpPr/>
-      <p:sp>
-        <p:nvSpPr>
-          <p:cNvPr id="2" name="Rectangle 1"/>
-          <p:cNvSpPr/>
-          <p:nvPr/>
-        </p:nvSpPr>
-        <p:spPr>
-          <a:xfrm>
-            <a:off x="0" y="0"/>
-            <a:ext cx="12191695" cy="640080"/>
-          </a:xfrm>
-          <a:prstGeom prst="rect">
-            <a:avLst/>
-          </a:prstGeom>
-          <a:solidFill>
-            <a:srgbClr val="143475"/>
-          </a:solidFill>
-          <a:ln>
-            <a:noFill/>
-          </a:ln>
-        </p:spPr>
-        <p:style>
-          <a:lnRef idx="1">
-            <a:schemeClr val="accent1"/>
-          </a:lnRef>
-          <a:fillRef idx="3">
-            <a:schemeClr val="accent1"/>
-          </a:fillRef>
-          <a:effectRef idx="2">
-            <a:schemeClr val="accent1"/>
-          </a:effectRef>
-          <a:fontRef idx="minor">
-            <a:schemeClr val="lt1"/>
-          </a:fontRef>
-        </p:style>
-        <p:txBody>
           <a:bodyPr rtlCol="0" anchor="ctr"/>
           <a:lstStyle/>
           <a:p>
@@ -3419,14 +3208,14 @@
       </p:sp>
       <p:sp>
         <p:nvSpPr>
-          <p:cNvPr id="3" name="TextBox 2"/>
+          <p:cNvPr id="5" name="TextBox 4"/>
           <p:cNvSpPr txBox="1"/>
           <p:nvPr/>
         </p:nvSpPr>
         <p:spPr>
           <a:xfrm>
             <a:off x="457200" y="109728"/>
-            <a:ext cx="6858000" cy="320040"/>
+            <a:ext cx="7132320" cy="320040"/>
           </a:xfrm>
           <a:prstGeom prst="rect">
             <a:avLst/>
@@ -3455,14 +3244,14 @@
       </p:sp>
       <p:sp>
         <p:nvSpPr>
-          <p:cNvPr id="4" name="TextBox 3"/>
+          <p:cNvPr id="6" name="TextBox 5"/>
           <p:cNvSpPr txBox="1"/>
           <p:nvPr/>
         </p:nvSpPr>
         <p:spPr>
           <a:xfrm>
-            <a:off x="731520" y="914400"/>
-            <a:ext cx="10789920" cy="1280160"/>
+            <a:off x="685800" y="1280160"/>
+            <a:ext cx="10972800" cy="1234440"/>
           </a:xfrm>
           <a:prstGeom prst="rect">
             <a:avLst/>
@@ -3478,27 +3267,40 @@
             <a:pPr algn="l">
               <a:defRPr sz="3400" b="1" u="none">
                 <a:solidFill>
-                  <a:srgbClr val="143475"/>
-                </a:solidFill>
-                <a:latin typeface="Calibri"/>
-              </a:defRPr>
-            </a:pPr>
-            <a:r>
-              <a:t>Decisión solicitada al Comité Ejecutivo</a:t>
-            </a:r>
-          </a:p>
-        </p:txBody>
-      </p:sp>
-      <p:sp>
-        <p:nvSpPr>
-          <p:cNvPr id="5" name="Rounded Rectangle 4"/>
+                  <a:srgbClr val="FFFFFF"/>
+                </a:solidFill>
+                <a:latin typeface="Calibri"/>
+              </a:defRPr>
+            </a:pPr>
+            <a:r>
+              <a:t>CHATBOT RRHH</a:t>
+            </a:r>
+          </a:p>
+          <a:p>
+            <a:pPr algn="l">
+              <a:defRPr sz="1800" b="0" u="none">
+                <a:solidFill>
+                  <a:srgbClr val="E6ECF8"/>
+                </a:solidFill>
+                <a:latin typeface="Calibri"/>
+              </a:defRPr>
+            </a:pPr>
+            <a:r>
+              <a:t>Propuesta ejecutiva para mejorar la experiencia del colaborador y la productividad de RRHH</a:t>
+            </a:r>
+          </a:p>
+        </p:txBody>
+      </p:sp>
+      <p:sp>
+        <p:nvSpPr>
+          <p:cNvPr id="7" name="Rounded Rectangle 6"/>
           <p:cNvSpPr/>
           <p:nvPr/>
         </p:nvSpPr>
         <p:spPr>
           <a:xfrm>
-            <a:off x="731520" y="1965960"/>
-            <a:ext cx="5303520" cy="3840480"/>
+            <a:off x="777240" y="2651760"/>
+            <a:ext cx="10652760" cy="1828800"/>
           </a:xfrm>
           <a:prstGeom prst="roundRect">
             <a:avLst/>
@@ -3508,7 +3310,7 @@
           </a:solidFill>
           <a:ln>
             <a:solidFill>
-              <a:srgbClr val="D8E2F3"/>
+              <a:srgbClr val="D2DDF0"/>
             </a:solidFill>
           </a:ln>
         </p:spPr>
@@ -3533,90 +3335,75 @@
             <a:pPr algn="l">
               <a:defRPr sz="2000" b="1" u="none">
                 <a:solidFill>
-                  <a:srgbClr val="E8931F"/>
-                </a:solidFill>
-                <a:latin typeface="Calibri"/>
-              </a:defRPr>
-            </a:pPr>
-            <a:r>
-              <a:t>Aprobaciones requeridas</a:t>
+                  <a:srgbClr val="3168DA"/>
+                </a:solidFill>
+                <a:latin typeface="Calibri"/>
+              </a:defRPr>
+            </a:pPr>
+            <a:r>
+              <a:t>Resumen ejecutivo</a:t>
             </a:r>
           </a:p>
           <a:p>
             <a:pPr algn="l">
               <a:defRPr sz="1600" b="0" u="none">
                 <a:solidFill>
-                  <a:srgbClr val="16213A"/>
-                </a:solidFill>
-                <a:latin typeface="Calibri"/>
-              </a:defRPr>
-            </a:pPr>
-            <a:r>
-              <a:t>• Presupuesto mensual inicial para operación.</a:t>
+                  <a:srgbClr val="1C263C"/>
+                </a:solidFill>
+                <a:latin typeface="Calibri"/>
+              </a:defRPr>
+            </a:pPr>
+            <a:r>
+              <a:t>• Atención rápida y uniforme para consultas frecuentes.</a:t>
             </a:r>
           </a:p>
           <a:p>
             <a:pPr algn="l">
               <a:defRPr sz="1600" b="0" u="none">
                 <a:solidFill>
-                  <a:srgbClr val="16213A"/>
-                </a:solidFill>
-                <a:latin typeface="Calibri"/>
-              </a:defRPr>
-            </a:pPr>
-            <a:r>
-              <a:t>• Habilitación de infraestructura Google y IA.</a:t>
+                  <a:srgbClr val="1C263C"/>
+                </a:solidFill>
+                <a:latin typeface="Calibri"/>
+              </a:defRPr>
+            </a:pPr>
+            <a:r>
+              <a:t>• Derivación directa a RRHH cuando el caso requiere intervención humana.</a:t>
             </a:r>
           </a:p>
           <a:p>
             <a:pPr algn="l">
               <a:defRPr sz="1600" b="0" u="none">
                 <a:solidFill>
-                  <a:srgbClr val="16213A"/>
-                </a:solidFill>
-                <a:latin typeface="Calibri"/>
-              </a:defRPr>
-            </a:pPr>
-            <a:r>
-              <a:t>• Habilitación del canal WhatsApp Business.</a:t>
-            </a:r>
-          </a:p>
-          <a:p>
-            <a:pPr algn="l">
-              <a:defRPr sz="1600" b="0" u="none">
-                <a:solidFill>
-                  <a:srgbClr val="16213A"/>
-                </a:solidFill>
-                <a:latin typeface="Calibri"/>
-              </a:defRPr>
-            </a:pPr>
-            <a:r>
-              <a:t>• Sponsor de negocio para seguimiento trimestral.</a:t>
-            </a:r>
-          </a:p>
-        </p:txBody>
-      </p:sp>
-      <p:sp>
-        <p:nvSpPr>
-          <p:cNvPr id="6" name="Rounded Rectangle 5"/>
+                  <a:srgbClr val="1C263C"/>
+                </a:solidFill>
+                <a:latin typeface="Calibri"/>
+              </a:defRPr>
+            </a:pPr>
+            <a:r>
+              <a:t>• Gestión por empresa/sucursal con trazabilidad y métricas de operación.</a:t>
+            </a:r>
+          </a:p>
+        </p:txBody>
+      </p:sp>
+      <p:sp>
+        <p:nvSpPr>
+          <p:cNvPr id="8" name="Rounded Rectangle 7"/>
           <p:cNvSpPr/>
           <p:nvPr/>
         </p:nvSpPr>
         <p:spPr>
           <a:xfrm>
-            <a:off x="6172200" y="1965960"/>
-            <a:ext cx="5257800" cy="3840480"/>
+            <a:off x="822960" y="4892040"/>
+            <a:ext cx="4754880" cy="566928"/>
           </a:xfrm>
           <a:prstGeom prst="roundRect">
             <a:avLst/>
           </a:prstGeom>
           <a:solidFill>
-            <a:srgbClr val="FFFFFF"/>
+            <a:srgbClr val="189D75"/>
           </a:solidFill>
           <a:ln>
-            <a:solidFill>
-              <a:srgbClr val="D8E2F3"/>
-            </a:solidFill>
+            <a:noFill/>
           </a:ln>
         </p:spPr>
         <p:style>
@@ -3637,68 +3424,16 @@
           <a:bodyPr rtlCol="0" anchor="ctr" wrap="square"/>
           <a:lstStyle/>
           <a:p>
-            <a:pPr algn="l">
-              <a:defRPr sz="2000" b="1" u="none">
-                <a:solidFill>
-                  <a:srgbClr val="15946E"/>
-                </a:solidFill>
-                <a:latin typeface="Calibri"/>
-              </a:defRPr>
-            </a:pPr>
-            <a:r>
-              <a:t>Resultado esperado</a:t>
-            </a:r>
-          </a:p>
-          <a:p>
-            <a:pPr algn="l">
-              <a:defRPr sz="1600" b="0" u="none">
-                <a:solidFill>
-                  <a:srgbClr val="16213A"/>
-                </a:solidFill>
-                <a:latin typeface="Calibri"/>
-              </a:defRPr>
-            </a:pPr>
-            <a:r>
-              <a:t>• Mejor experiencia del colaborador.</a:t>
-            </a:r>
-          </a:p>
-          <a:p>
-            <a:pPr algn="l">
-              <a:defRPr sz="1600" b="0" u="none">
-                <a:solidFill>
-                  <a:srgbClr val="16213A"/>
-                </a:solidFill>
-                <a:latin typeface="Calibri"/>
-              </a:defRPr>
-            </a:pPr>
-            <a:r>
-              <a:t>• Menor carga operativa del equipo RRHH.</a:t>
-            </a:r>
-          </a:p>
-          <a:p>
-            <a:pPr algn="l">
-              <a:defRPr sz="1600" b="0" u="none">
-                <a:solidFill>
-                  <a:srgbClr val="16213A"/>
-                </a:solidFill>
-                <a:latin typeface="Calibri"/>
-              </a:defRPr>
-            </a:pPr>
-            <a:r>
-              <a:t>• Mayor trazabilidad y control de gestión.</a:t>
-            </a:r>
-          </a:p>
-          <a:p>
-            <a:pPr algn="l">
-              <a:defRPr sz="1600" b="0" u="none">
-                <a:solidFill>
-                  <a:srgbClr val="16213A"/>
-                </a:solidFill>
-                <a:latin typeface="Calibri"/>
-              </a:defRPr>
-            </a:pPr>
-            <a:r>
-              <a:t>• Base escalable para nuevas unidades del grupo.</a:t>
+            <a:pPr algn="ctr">
+              <a:defRPr sz="1500" b="1" u="none">
+                <a:solidFill>
+                  <a:srgbClr val="FFFFFF"/>
+                </a:solidFill>
+                <a:latin typeface="Calibri"/>
+              </a:defRPr>
+            </a:pPr>
+            <a:r>
+              <a:t>Objetivo del comité: validar presupuesto y salida productiva</a:t>
             </a:r>
           </a:p>
         </p:txBody>
@@ -3714,14 +3449,6 @@
 <file path=ppt/slides/slide2.xml><?xml version="1.0" encoding="utf-8"?>
 <p:sld xmlns:a="http://schemas.openxmlformats.org/drawingml/2006/main" xmlns:p="http://schemas.openxmlformats.org/presentationml/2006/main" xmlns:r="http://schemas.openxmlformats.org/officeDocument/2006/relationships">
   <p:cSld>
-    <p:bg>
-      <p:bgPr>
-        <a:solidFill>
-          <a:srgbClr val="F5F8FE"/>
-        </a:solidFill>
-        <a:effectLst/>
-      </p:bgPr>
-    </p:bg>
     <p:spTree>
       <p:nvGrpSpPr>
         <p:cNvPr id="1" name=""/>
@@ -3729,22 +3456,46 @@
         <p:nvPr/>
       </p:nvGrpSpPr>
       <p:grpSpPr/>
-      <p:sp>
-        <p:nvSpPr>
-          <p:cNvPr id="2" name="Rectangle 1"/>
+      <p:pic>
+        <p:nvPicPr>
+          <p:cNvPr id="2" name="Picture 1" descr="chatbot-bg-2.jpg"/>
+          <p:cNvPicPr>
+            <a:picLocks noChangeAspect="1"/>
+          </p:cNvPicPr>
+          <p:nvPr/>
+        </p:nvPicPr>
+        <p:blipFill>
+          <a:blip r:embed="rId2"/>
+          <a:stretch>
+            <a:fillRect/>
+          </a:stretch>
+        </p:blipFill>
+        <p:spPr>
+          <a:xfrm>
+            <a:off x="0" y="0"/>
+            <a:ext cx="12191695" cy="6858000"/>
+          </a:xfrm>
+          <a:prstGeom prst="rect">
+            <a:avLst/>
+          </a:prstGeom>
+        </p:spPr>
+      </p:pic>
+      <p:sp>
+        <p:nvSpPr>
+          <p:cNvPr id="3" name="Rectangle 2"/>
           <p:cNvSpPr/>
           <p:nvPr/>
         </p:nvSpPr>
         <p:spPr>
           <a:xfrm>
             <a:off x="0" y="0"/>
-            <a:ext cx="12191695" cy="640080"/>
+            <a:ext cx="12191695" cy="6858000"/>
           </a:xfrm>
           <a:prstGeom prst="rect">
             <a:avLst/>
           </a:prstGeom>
           <a:solidFill>
-            <a:srgbClr val="143475"/>
+            <a:srgbClr val="070F1E"/>
           </a:solidFill>
           <a:ln>
             <a:noFill/>
@@ -3774,14 +3525,57 @@
       </p:sp>
       <p:sp>
         <p:nvSpPr>
-          <p:cNvPr id="3" name="TextBox 2"/>
+          <p:cNvPr id="4" name="Rectangle 3"/>
+          <p:cNvSpPr/>
+          <p:nvPr/>
+        </p:nvSpPr>
+        <p:spPr>
+          <a:xfrm>
+            <a:off x="0" y="0"/>
+            <a:ext cx="12191695" cy="621792"/>
+          </a:xfrm>
+          <a:prstGeom prst="rect">
+            <a:avLst/>
+          </a:prstGeom>
+          <a:solidFill>
+            <a:srgbClr val="133271"/>
+          </a:solidFill>
+          <a:ln>
+            <a:noFill/>
+          </a:ln>
+        </p:spPr>
+        <p:style>
+          <a:lnRef idx="1">
+            <a:schemeClr val="accent1"/>
+          </a:lnRef>
+          <a:fillRef idx="3">
+            <a:schemeClr val="accent1"/>
+          </a:fillRef>
+          <a:effectRef idx="2">
+            <a:schemeClr val="accent1"/>
+          </a:effectRef>
+          <a:fontRef idx="minor">
+            <a:schemeClr val="lt1"/>
+          </a:fontRef>
+        </p:style>
+        <p:txBody>
+          <a:bodyPr rtlCol="0" anchor="ctr"/>
+          <a:lstStyle/>
+          <a:p>
+            <a:pPr algn="ctr"/>
+          </a:p>
+        </p:txBody>
+      </p:sp>
+      <p:sp>
+        <p:nvSpPr>
+          <p:cNvPr id="5" name="TextBox 4"/>
           <p:cNvSpPr txBox="1"/>
           <p:nvPr/>
         </p:nvSpPr>
         <p:spPr>
           <a:xfrm>
             <a:off x="457200" y="109728"/>
-            <a:ext cx="6858000" cy="320040"/>
+            <a:ext cx="7132320" cy="320040"/>
           </a:xfrm>
           <a:prstGeom prst="rect">
             <a:avLst/>
@@ -3810,14 +3604,14 @@
       </p:sp>
       <p:sp>
         <p:nvSpPr>
-          <p:cNvPr id="4" name="TextBox 3"/>
+          <p:cNvPr id="6" name="TextBox 5"/>
           <p:cNvSpPr txBox="1"/>
           <p:nvPr/>
         </p:nvSpPr>
         <p:spPr>
           <a:xfrm>
-            <a:off x="731520" y="914400"/>
-            <a:ext cx="10789920" cy="1280160"/>
+            <a:off x="685800" y="868680"/>
+            <a:ext cx="10972800" cy="1234440"/>
           </a:xfrm>
           <a:prstGeom prst="rect">
             <a:avLst/>
@@ -3833,7 +3627,7 @@
             <a:pPr algn="l">
               <a:defRPr sz="3400" b="1" u="none">
                 <a:solidFill>
-                  <a:srgbClr val="143475"/>
+                  <a:srgbClr val="FFFFFF"/>
                 </a:solidFill>
                 <a:latin typeface="Calibri"/>
               </a:defRPr>
@@ -3846,27 +3640,27 @@
             <a:pPr algn="l">
               <a:defRPr sz="1800" b="0" u="none">
                 <a:solidFill>
-                  <a:srgbClr val="566177"/>
-                </a:solidFill>
-                <a:latin typeface="Calibri"/>
-              </a:defRPr>
-            </a:pPr>
-            <a:r>
-              <a:t>Hoy RRHH enfrenta demanda creciente con procesos que pueden ser más ágiles.</a:t>
-            </a:r>
-          </a:p>
-        </p:txBody>
-      </p:sp>
-      <p:sp>
-        <p:nvSpPr>
-          <p:cNvPr id="5" name="Rounded Rectangle 4"/>
+                  <a:srgbClr val="E6ECF8"/>
+                </a:solidFill>
+                <a:latin typeface="Calibri"/>
+              </a:defRPr>
+            </a:pPr>
+            <a:r>
+              <a:t>Hay oportunidad concreta de mejorar tiempos y calidad de atención.</a:t>
+            </a:r>
+          </a:p>
+        </p:txBody>
+      </p:sp>
+      <p:sp>
+        <p:nvSpPr>
+          <p:cNvPr id="7" name="Rounded Rectangle 6"/>
           <p:cNvSpPr/>
           <p:nvPr/>
         </p:nvSpPr>
         <p:spPr>
           <a:xfrm>
             <a:off x="731520" y="2011680"/>
-            <a:ext cx="5394960" cy="3657600"/>
+            <a:ext cx="5349240" cy="3611880"/>
           </a:xfrm>
           <a:prstGeom prst="roundRect">
             <a:avLst/>
@@ -3876,7 +3670,7 @@
           </a:solidFill>
           <a:ln>
             <a:solidFill>
-              <a:srgbClr val="D8E2F3"/>
+              <a:srgbClr val="D2DDF0"/>
             </a:solidFill>
           </a:ln>
         </p:spPr>
@@ -3901,79 +3695,79 @@
             <a:pPr algn="l">
               <a:defRPr sz="2000" b="1" u="none">
                 <a:solidFill>
-                  <a:srgbClr val="E8931F"/>
-                </a:solidFill>
-                <a:latin typeface="Calibri"/>
-              </a:defRPr>
-            </a:pPr>
-            <a:r>
-              <a:t>Dolores principales</a:t>
+                  <a:srgbClr val="E89420"/>
+                </a:solidFill>
+                <a:latin typeface="Calibri"/>
+              </a:defRPr>
+            </a:pPr>
+            <a:r>
+              <a:t>Dolores hoy</a:t>
             </a:r>
           </a:p>
           <a:p>
             <a:pPr algn="l">
               <a:defRPr sz="1600" b="0" u="none">
                 <a:solidFill>
-                  <a:srgbClr val="16213A"/>
-                </a:solidFill>
-                <a:latin typeface="Calibri"/>
-              </a:defRPr>
-            </a:pPr>
-            <a:r>
-              <a:t>• Consultas repetitivas consumen tiempo operativo.</a:t>
+                  <a:srgbClr val="1C263C"/>
+                </a:solidFill>
+                <a:latin typeface="Calibri"/>
+              </a:defRPr>
+            </a:pPr>
+            <a:r>
+              <a:t>• Consultas repetitivas consumen tiempo del equipo.</a:t>
             </a:r>
           </a:p>
           <a:p>
             <a:pPr algn="l">
               <a:defRPr sz="1600" b="0" u="none">
                 <a:solidFill>
-                  <a:srgbClr val="16213A"/>
-                </a:solidFill>
-                <a:latin typeface="Calibri"/>
-              </a:defRPr>
-            </a:pPr>
-            <a:r>
-              <a:t>• Respuesta desigual según horario o disponibilidad.</a:t>
+                  <a:srgbClr val="1C263C"/>
+                </a:solidFill>
+                <a:latin typeface="Calibri"/>
+              </a:defRPr>
+            </a:pPr>
+            <a:r>
+              <a:t>• La experiencia del colaborador depende del horario.</a:t>
             </a:r>
           </a:p>
           <a:p>
             <a:pPr algn="l">
               <a:defRPr sz="1600" b="0" u="none">
                 <a:solidFill>
-                  <a:srgbClr val="16213A"/>
-                </a:solidFill>
-                <a:latin typeface="Calibri"/>
-              </a:defRPr>
-            </a:pPr>
-            <a:r>
-              <a:t>• Derivaciones manuales sin un circuito unificado.</a:t>
+                  <a:srgbClr val="1C263C"/>
+                </a:solidFill>
+                <a:latin typeface="Calibri"/>
+              </a:defRPr>
+            </a:pPr>
+            <a:r>
+              <a:t>• No siempre hay un circuito único para seguimiento.</a:t>
             </a:r>
           </a:p>
           <a:p>
             <a:pPr algn="l">
               <a:defRPr sz="1600" b="0" u="none">
                 <a:solidFill>
-                  <a:srgbClr val="16213A"/>
-                </a:solidFill>
-                <a:latin typeface="Calibri"/>
-              </a:defRPr>
-            </a:pPr>
-            <a:r>
-              <a:t>• Menor tiempo para tareas estratégicas de RRHH.</a:t>
-            </a:r>
-          </a:p>
-        </p:txBody>
-      </p:sp>
-      <p:sp>
-        <p:nvSpPr>
-          <p:cNvPr id="6" name="Rounded Rectangle 5"/>
+                  <a:srgbClr val="1C263C"/>
+                </a:solidFill>
+                <a:latin typeface="Calibri"/>
+              </a:defRPr>
+            </a:pPr>
+            <a:r>
+              <a:t>• Se pierde foco en tareas de mayor valor para RRHH.</a:t>
+            </a:r>
+          </a:p>
+        </p:txBody>
+      </p:sp>
+      <p:sp>
+        <p:nvSpPr>
+          <p:cNvPr id="8" name="Rounded Rectangle 7"/>
           <p:cNvSpPr/>
           <p:nvPr/>
         </p:nvSpPr>
         <p:spPr>
           <a:xfrm>
             <a:off x="6126480" y="2011680"/>
-            <a:ext cx="5303520" cy="3657600"/>
+            <a:ext cx="5349240" cy="3611880"/>
           </a:xfrm>
           <a:prstGeom prst="roundRect">
             <a:avLst/>
@@ -3983,7 +3777,7 @@
           </a:solidFill>
           <a:ln>
             <a:solidFill>
-              <a:srgbClr val="D8E2F3"/>
+              <a:srgbClr val="D2DDF0"/>
             </a:solidFill>
           </a:ln>
         </p:spPr>
@@ -4008,65 +3802,65 @@
             <a:pPr algn="l">
               <a:defRPr sz="2000" b="1" u="none">
                 <a:solidFill>
-                  <a:srgbClr val="15946E"/>
-                </a:solidFill>
-                <a:latin typeface="Calibri"/>
-              </a:defRPr>
-            </a:pPr>
-            <a:r>
-              <a:t>Oportunidad de mejora</a:t>
+                  <a:srgbClr val="189D75"/>
+                </a:solidFill>
+                <a:latin typeface="Calibri"/>
+              </a:defRPr>
+            </a:pPr>
+            <a:r>
+              <a:t>Qué ganamos al resolverlo</a:t>
             </a:r>
           </a:p>
           <a:p>
             <a:pPr algn="l">
               <a:defRPr sz="1600" b="0" u="none">
                 <a:solidFill>
-                  <a:srgbClr val="16213A"/>
-                </a:solidFill>
-                <a:latin typeface="Calibri"/>
-              </a:defRPr>
-            </a:pPr>
-            <a:r>
-              <a:t>• Automatizar primera respuesta y clasificación.</a:t>
+                  <a:srgbClr val="1C263C"/>
+                </a:solidFill>
+                <a:latin typeface="Calibri"/>
+              </a:defRPr>
+            </a:pPr>
+            <a:r>
+              <a:t>• Menos carga operativa en preguntas frecuentes.</a:t>
             </a:r>
           </a:p>
           <a:p>
             <a:pPr algn="l">
               <a:defRPr sz="1600" b="0" u="none">
                 <a:solidFill>
-                  <a:srgbClr val="16213A"/>
-                </a:solidFill>
-                <a:latin typeface="Calibri"/>
-              </a:defRPr>
-            </a:pPr>
-            <a:r>
-              <a:t>• Derivar solo casos que realmente necesitan intervención humana.</a:t>
+                  <a:srgbClr val="1C263C"/>
+                </a:solidFill>
+                <a:latin typeface="Calibri"/>
+              </a:defRPr>
+            </a:pPr>
+            <a:r>
+              <a:t>• Respuesta más rápida y consistente.</a:t>
             </a:r>
           </a:p>
           <a:p>
             <a:pPr algn="l">
               <a:defRPr sz="1600" b="0" u="none">
                 <a:solidFill>
-                  <a:srgbClr val="16213A"/>
-                </a:solidFill>
-                <a:latin typeface="Calibri"/>
-              </a:defRPr>
-            </a:pPr>
-            <a:r>
-              <a:t>• Medir tiempos, volumen y satisfacción en una sola vista.</a:t>
+                  <a:srgbClr val="1C263C"/>
+                </a:solidFill>
+                <a:latin typeface="Calibri"/>
+              </a:defRPr>
+            </a:pPr>
+            <a:r>
+              <a:t>• Más tiempo del equipo en casos críticos.</a:t>
             </a:r>
           </a:p>
           <a:p>
             <a:pPr algn="l">
               <a:defRPr sz="1600" b="0" u="none">
                 <a:solidFill>
-                  <a:srgbClr val="16213A"/>
-                </a:solidFill>
-                <a:latin typeface="Calibri"/>
-              </a:defRPr>
-            </a:pPr>
-            <a:r>
-              <a:t>• Escalar el servicio sin crecer linealmente en costos.</a:t>
+                  <a:srgbClr val="1C263C"/>
+                </a:solidFill>
+                <a:latin typeface="Calibri"/>
+              </a:defRPr>
+            </a:pPr>
+            <a:r>
+              <a:t>• Datos claros para gestión y mejora continua.</a:t>
             </a:r>
           </a:p>
         </p:txBody>
@@ -4082,14 +3876,6 @@
 <file path=ppt/slides/slide3.xml><?xml version="1.0" encoding="utf-8"?>
 <p:sld xmlns:a="http://schemas.openxmlformats.org/drawingml/2006/main" xmlns:p="http://schemas.openxmlformats.org/presentationml/2006/main" xmlns:r="http://schemas.openxmlformats.org/officeDocument/2006/relationships">
   <p:cSld>
-    <p:bg>
-      <p:bgPr>
-        <a:solidFill>
-          <a:srgbClr val="F5F8FE"/>
-        </a:solidFill>
-        <a:effectLst/>
-      </p:bgPr>
-    </p:bg>
     <p:spTree>
       <p:nvGrpSpPr>
         <p:cNvPr id="1" name=""/>
@@ -4097,22 +3883,46 @@
         <p:nvPr/>
       </p:nvGrpSpPr>
       <p:grpSpPr/>
-      <p:sp>
-        <p:nvSpPr>
-          <p:cNvPr id="2" name="Rectangle 1"/>
+      <p:pic>
+        <p:nvPicPr>
+          <p:cNvPr id="2" name="Picture 1" descr="chatbot-bg-3.jpg"/>
+          <p:cNvPicPr>
+            <a:picLocks noChangeAspect="1"/>
+          </p:cNvPicPr>
+          <p:nvPr/>
+        </p:nvPicPr>
+        <p:blipFill>
+          <a:blip r:embed="rId2"/>
+          <a:stretch>
+            <a:fillRect/>
+          </a:stretch>
+        </p:blipFill>
+        <p:spPr>
+          <a:xfrm>
+            <a:off x="0" y="0"/>
+            <a:ext cx="12191695" cy="6858000"/>
+          </a:xfrm>
+          <a:prstGeom prst="rect">
+            <a:avLst/>
+          </a:prstGeom>
+        </p:spPr>
+      </p:pic>
+      <p:sp>
+        <p:nvSpPr>
+          <p:cNvPr id="3" name="Rectangle 2"/>
           <p:cNvSpPr/>
           <p:nvPr/>
         </p:nvSpPr>
         <p:spPr>
           <a:xfrm>
             <a:off x="0" y="0"/>
-            <a:ext cx="12191695" cy="640080"/>
+            <a:ext cx="12191695" cy="6858000"/>
           </a:xfrm>
           <a:prstGeom prst="rect">
             <a:avLst/>
           </a:prstGeom>
           <a:solidFill>
-            <a:srgbClr val="143475"/>
+            <a:srgbClr val="070F1E"/>
           </a:solidFill>
           <a:ln>
             <a:noFill/>
@@ -4142,14 +3952,57 @@
       </p:sp>
       <p:sp>
         <p:nvSpPr>
-          <p:cNvPr id="3" name="TextBox 2"/>
+          <p:cNvPr id="4" name="Rectangle 3"/>
+          <p:cNvSpPr/>
+          <p:nvPr/>
+        </p:nvSpPr>
+        <p:spPr>
+          <a:xfrm>
+            <a:off x="0" y="0"/>
+            <a:ext cx="12191695" cy="621792"/>
+          </a:xfrm>
+          <a:prstGeom prst="rect">
+            <a:avLst/>
+          </a:prstGeom>
+          <a:solidFill>
+            <a:srgbClr val="133271"/>
+          </a:solidFill>
+          <a:ln>
+            <a:noFill/>
+          </a:ln>
+        </p:spPr>
+        <p:style>
+          <a:lnRef idx="1">
+            <a:schemeClr val="accent1"/>
+          </a:lnRef>
+          <a:fillRef idx="3">
+            <a:schemeClr val="accent1"/>
+          </a:fillRef>
+          <a:effectRef idx="2">
+            <a:schemeClr val="accent1"/>
+          </a:effectRef>
+          <a:fontRef idx="minor">
+            <a:schemeClr val="lt1"/>
+          </a:fontRef>
+        </p:style>
+        <p:txBody>
+          <a:bodyPr rtlCol="0" anchor="ctr"/>
+          <a:lstStyle/>
+          <a:p>
+            <a:pPr algn="ctr"/>
+          </a:p>
+        </p:txBody>
+      </p:sp>
+      <p:sp>
+        <p:nvSpPr>
+          <p:cNvPr id="5" name="TextBox 4"/>
           <p:cNvSpPr txBox="1"/>
           <p:nvPr/>
         </p:nvSpPr>
         <p:spPr>
           <a:xfrm>
             <a:off x="457200" y="109728"/>
-            <a:ext cx="6858000" cy="320040"/>
+            <a:ext cx="7132320" cy="320040"/>
           </a:xfrm>
           <a:prstGeom prst="rect">
             <a:avLst/>
@@ -4178,14 +4031,14 @@
       </p:sp>
       <p:sp>
         <p:nvSpPr>
-          <p:cNvPr id="4" name="TextBox 3"/>
+          <p:cNvPr id="6" name="TextBox 5"/>
           <p:cNvSpPr txBox="1"/>
           <p:nvPr/>
         </p:nvSpPr>
         <p:spPr>
           <a:xfrm>
-            <a:off x="731520" y="914400"/>
-            <a:ext cx="10789920" cy="1280160"/>
+            <a:off x="685800" y="868680"/>
+            <a:ext cx="10972800" cy="1234440"/>
           </a:xfrm>
           <a:prstGeom prst="rect">
             <a:avLst/>
@@ -4201,7 +4054,7 @@
             <a:pPr algn="l">
               <a:defRPr sz="3400" b="1" u="none">
                 <a:solidFill>
-                  <a:srgbClr val="143475"/>
+                  <a:srgbClr val="FFFFFF"/>
                 </a:solidFill>
                 <a:latin typeface="Calibri"/>
               </a:defRPr>
@@ -4214,27 +4067,27 @@
             <a:pPr algn="l">
               <a:defRPr sz="1800" b="0" u="none">
                 <a:solidFill>
-                  <a:srgbClr val="566177"/>
-                </a:solidFill>
-                <a:latin typeface="Calibri"/>
-              </a:defRPr>
-            </a:pPr>
-            <a:r>
-              <a:t>Un asistente de RRHH con atención automática + atención humana integrada.</a:t>
-            </a:r>
-          </a:p>
-        </p:txBody>
-      </p:sp>
-      <p:sp>
-        <p:nvSpPr>
-          <p:cNvPr id="5" name="Rounded Rectangle 4"/>
+                  <a:srgbClr val="E6ECF8"/>
+                </a:solidFill>
+                <a:latin typeface="Calibri"/>
+              </a:defRPr>
+            </a:pPr>
+            <a:r>
+              <a:t>Un canal único de atención: chatbot + atención humana integrada.</a:t>
+            </a:r>
+          </a:p>
+        </p:txBody>
+      </p:sp>
+      <p:sp>
+        <p:nvSpPr>
+          <p:cNvPr id="7" name="Rounded Rectangle 6"/>
           <p:cNvSpPr/>
           <p:nvPr/>
         </p:nvSpPr>
         <p:spPr>
           <a:xfrm>
-            <a:off x="731520" y="1965960"/>
-            <a:ext cx="10698480" cy="1554480"/>
+            <a:off x="731520" y="2011680"/>
+            <a:ext cx="10698480" cy="1600200"/>
           </a:xfrm>
           <a:prstGeom prst="roundRect">
             <a:avLst/>
@@ -4244,7 +4097,7 @@
           </a:solidFill>
           <a:ln>
             <a:solidFill>
-              <a:srgbClr val="D8E2F3"/>
+              <a:srgbClr val="D2DDF0"/>
             </a:solidFill>
           </a:ln>
         </p:spPr>
@@ -4269,53 +4122,53 @@
             <a:pPr algn="l">
               <a:defRPr sz="2000" b="1" u="none">
                 <a:solidFill>
-                  <a:srgbClr val="2D63D6"/>
-                </a:solidFill>
-                <a:latin typeface="Calibri"/>
-              </a:defRPr>
-            </a:pPr>
-            <a:r>
-              <a:t>¿Qué hace el chatbot?</a:t>
+                  <a:srgbClr val="3168DA"/>
+                </a:solidFill>
+                <a:latin typeface="Calibri"/>
+              </a:defRPr>
+            </a:pPr>
+            <a:r>
+              <a:t>Qué hace el chatbot</a:t>
             </a:r>
           </a:p>
           <a:p>
             <a:pPr algn="l">
               <a:defRPr sz="1600" b="0" u="none">
                 <a:solidFill>
-                  <a:srgbClr val="16213A"/>
-                </a:solidFill>
-                <a:latin typeface="Calibri"/>
-              </a:defRPr>
-            </a:pPr>
-            <a:r>
-              <a:t>• Responde preguntas frecuentes al instante y guía al colaborador.</a:t>
+                  <a:srgbClr val="1C263C"/>
+                </a:solidFill>
+                <a:latin typeface="Calibri"/>
+              </a:defRPr>
+            </a:pPr>
+            <a:r>
+              <a:t>• Responde automáticamente consultas frecuentes.</a:t>
             </a:r>
           </a:p>
           <a:p>
             <a:pPr algn="l">
               <a:defRPr sz="1600" b="0" u="none">
                 <a:solidFill>
-                  <a:srgbClr val="16213A"/>
-                </a:solidFill>
-                <a:latin typeface="Calibri"/>
-              </a:defRPr>
-            </a:pPr>
-            <a:r>
-              <a:t>• Si hace falta, deriva la conversación al equipo de RRHH en vivo.</a:t>
-            </a:r>
-          </a:p>
-        </p:txBody>
-      </p:sp>
-      <p:sp>
-        <p:nvSpPr>
-          <p:cNvPr id="6" name="Rounded Rectangle 5"/>
+                  <a:srgbClr val="1C263C"/>
+                </a:solidFill>
+                <a:latin typeface="Calibri"/>
+              </a:defRPr>
+            </a:pPr>
+            <a:r>
+              <a:t>• Escala a RRHH en tiempo real cuando corresponde.</a:t>
+            </a:r>
+          </a:p>
+        </p:txBody>
+      </p:sp>
+      <p:sp>
+        <p:nvSpPr>
+          <p:cNvPr id="8" name="Rounded Rectangle 7"/>
           <p:cNvSpPr/>
           <p:nvPr/>
         </p:nvSpPr>
         <p:spPr>
           <a:xfrm>
-            <a:off x="731520" y="3657600"/>
-            <a:ext cx="3429000" cy="2011680"/>
+            <a:off x="731520" y="3794760"/>
+            <a:ext cx="3429000" cy="1828800"/>
           </a:xfrm>
           <a:prstGeom prst="roundRect">
             <a:avLst/>
@@ -4325,7 +4178,7 @@
           </a:solidFill>
           <a:ln>
             <a:solidFill>
-              <a:srgbClr val="D8E2F3"/>
+              <a:srgbClr val="D2DDF0"/>
             </a:solidFill>
           </a:ln>
         </p:spPr>
@@ -4350,7 +4203,7 @@
             <a:pPr algn="l">
               <a:defRPr sz="2000" b="1" u="none">
                 <a:solidFill>
-                  <a:srgbClr val="2D63D6"/>
+                  <a:srgbClr val="3168DA"/>
                 </a:solidFill>
                 <a:latin typeface="Calibri"/>
               </a:defRPr>
@@ -4363,53 +4216,53 @@
             <a:pPr algn="l">
               <a:defRPr sz="1600" b="0" u="none">
                 <a:solidFill>
-                  <a:srgbClr val="16213A"/>
-                </a:solidFill>
-                <a:latin typeface="Calibri"/>
-              </a:defRPr>
-            </a:pPr>
-            <a:r>
-              <a:t>• Canal claro y rápido.</a:t>
+                  <a:srgbClr val="1C263C"/>
+                </a:solidFill>
+                <a:latin typeface="Calibri"/>
+              </a:defRPr>
+            </a:pPr>
+            <a:r>
+              <a:t>• Respuesta rápida</a:t>
             </a:r>
           </a:p>
           <a:p>
             <a:pPr algn="l">
               <a:defRPr sz="1600" b="0" u="none">
                 <a:solidFill>
-                  <a:srgbClr val="16213A"/>
-                </a:solidFill>
-                <a:latin typeface="Calibri"/>
-              </a:defRPr>
-            </a:pPr>
-            <a:r>
-              <a:t>• Menos espera.</a:t>
+                  <a:srgbClr val="1C263C"/>
+                </a:solidFill>
+                <a:latin typeface="Calibri"/>
+              </a:defRPr>
+            </a:pPr>
+            <a:r>
+              <a:t>• Canal claro</a:t>
             </a:r>
           </a:p>
           <a:p>
             <a:pPr algn="l">
               <a:defRPr sz="1600" b="0" u="none">
                 <a:solidFill>
-                  <a:srgbClr val="16213A"/>
-                </a:solidFill>
-                <a:latin typeface="Calibri"/>
-              </a:defRPr>
-            </a:pPr>
-            <a:r>
-              <a:t>• Mejor experiencia.</a:t>
-            </a:r>
-          </a:p>
-        </p:txBody>
-      </p:sp>
-      <p:sp>
-        <p:nvSpPr>
-          <p:cNvPr id="7" name="Rounded Rectangle 6"/>
+                  <a:srgbClr val="1C263C"/>
+                </a:solidFill>
+                <a:latin typeface="Calibri"/>
+              </a:defRPr>
+            </a:pPr>
+            <a:r>
+              <a:t>• Mejor experiencia</a:t>
+            </a:r>
+          </a:p>
+        </p:txBody>
+      </p:sp>
+      <p:sp>
+        <p:nvSpPr>
+          <p:cNvPr id="9" name="Rounded Rectangle 8"/>
           <p:cNvSpPr/>
           <p:nvPr/>
         </p:nvSpPr>
         <p:spPr>
           <a:xfrm>
-            <a:off x="4389120" y="3657600"/>
-            <a:ext cx="3429000" cy="2011680"/>
+            <a:off x="4389120" y="3794760"/>
+            <a:ext cx="3429000" cy="1828800"/>
           </a:xfrm>
           <a:prstGeom prst="roundRect">
             <a:avLst/>
@@ -4419,7 +4272,7 @@
           </a:solidFill>
           <a:ln>
             <a:solidFill>
-              <a:srgbClr val="D8E2F3"/>
+              <a:srgbClr val="D2DDF0"/>
             </a:solidFill>
           </a:ln>
         </p:spPr>
@@ -4444,7 +4297,7 @@
             <a:pPr algn="l">
               <a:defRPr sz="2000" b="1" u="none">
                 <a:solidFill>
-                  <a:srgbClr val="2D63D6"/>
+                  <a:srgbClr val="3168DA"/>
                 </a:solidFill>
                 <a:latin typeface="Calibri"/>
               </a:defRPr>
@@ -4457,53 +4310,53 @@
             <a:pPr algn="l">
               <a:defRPr sz="1600" b="0" u="none">
                 <a:solidFill>
-                  <a:srgbClr val="16213A"/>
-                </a:solidFill>
-                <a:latin typeface="Calibri"/>
-              </a:defRPr>
-            </a:pPr>
-            <a:r>
-              <a:t>• Menos carga repetitiva.</a:t>
+                  <a:srgbClr val="1C263C"/>
+                </a:solidFill>
+                <a:latin typeface="Calibri"/>
+              </a:defRPr>
+            </a:pPr>
+            <a:r>
+              <a:t>• Menos repetición</a:t>
             </a:r>
           </a:p>
           <a:p>
             <a:pPr algn="l">
               <a:defRPr sz="1600" b="0" u="none">
                 <a:solidFill>
-                  <a:srgbClr val="16213A"/>
-                </a:solidFill>
-                <a:latin typeface="Calibri"/>
-              </a:defRPr>
-            </a:pPr>
-            <a:r>
-              <a:t>• Más foco en casos críticos.</a:t>
+                  <a:srgbClr val="1C263C"/>
+                </a:solidFill>
+                <a:latin typeface="Calibri"/>
+              </a:defRPr>
+            </a:pPr>
+            <a:r>
+              <a:t>• Más foco</a:t>
             </a:r>
           </a:p>
           <a:p>
             <a:pPr algn="l">
               <a:defRPr sz="1600" b="0" u="none">
                 <a:solidFill>
-                  <a:srgbClr val="16213A"/>
-                </a:solidFill>
-                <a:latin typeface="Calibri"/>
-              </a:defRPr>
-            </a:pPr>
-            <a:r>
-              <a:t>• Bandeja única de atención.</a:t>
-            </a:r>
-          </a:p>
-        </p:txBody>
-      </p:sp>
-      <p:sp>
-        <p:nvSpPr>
-          <p:cNvPr id="8" name="Rounded Rectangle 7"/>
+                  <a:srgbClr val="1C263C"/>
+                </a:solidFill>
+                <a:latin typeface="Calibri"/>
+              </a:defRPr>
+            </a:pPr>
+            <a:r>
+              <a:t>• Bandeja unificada</a:t>
+            </a:r>
+          </a:p>
+        </p:txBody>
+      </p:sp>
+      <p:sp>
+        <p:nvSpPr>
+          <p:cNvPr id="10" name="Rounded Rectangle 9"/>
           <p:cNvSpPr/>
           <p:nvPr/>
         </p:nvSpPr>
         <p:spPr>
           <a:xfrm>
-            <a:off x="8001000" y="3657600"/>
-            <a:ext cx="3429000" cy="2011680"/>
+            <a:off x="8046720" y="3794760"/>
+            <a:ext cx="3383280" cy="1828800"/>
           </a:xfrm>
           <a:prstGeom prst="roundRect">
             <a:avLst/>
@@ -4513,7 +4366,7 @@
           </a:solidFill>
           <a:ln>
             <a:solidFill>
-              <a:srgbClr val="D8E2F3"/>
+              <a:srgbClr val="D2DDF0"/>
             </a:solidFill>
           </a:ln>
         </p:spPr>
@@ -4538,7 +4391,7 @@
             <a:pPr algn="l">
               <a:defRPr sz="2000" b="1" u="none">
                 <a:solidFill>
-                  <a:srgbClr val="2D63D6"/>
+                  <a:srgbClr val="189D75"/>
                 </a:solidFill>
                 <a:latin typeface="Calibri"/>
               </a:defRPr>
@@ -4551,39 +4404,39 @@
             <a:pPr algn="l">
               <a:defRPr sz="1600" b="0" u="none">
                 <a:solidFill>
-                  <a:srgbClr val="16213A"/>
-                </a:solidFill>
-                <a:latin typeface="Calibri"/>
-              </a:defRPr>
-            </a:pPr>
-            <a:r>
-              <a:t>• Visibilidad de métricas.</a:t>
+                  <a:srgbClr val="1C263C"/>
+                </a:solidFill>
+                <a:latin typeface="Calibri"/>
+              </a:defRPr>
+            </a:pPr>
+            <a:r>
+              <a:t>• Métricas claras</a:t>
             </a:r>
           </a:p>
           <a:p>
             <a:pPr algn="l">
               <a:defRPr sz="1600" b="0" u="none">
                 <a:solidFill>
-                  <a:srgbClr val="16213A"/>
-                </a:solidFill>
-                <a:latin typeface="Calibri"/>
-              </a:defRPr>
-            </a:pPr>
-            <a:r>
-              <a:t>• Escalabilidad controlada.</a:t>
+                  <a:srgbClr val="1C263C"/>
+                </a:solidFill>
+                <a:latin typeface="Calibri"/>
+              </a:defRPr>
+            </a:pPr>
+            <a:r>
+              <a:t>• Escalabilidad</a:t>
             </a:r>
           </a:p>
           <a:p>
             <a:pPr algn="l">
               <a:defRPr sz="1600" b="0" u="none">
                 <a:solidFill>
-                  <a:srgbClr val="16213A"/>
-                </a:solidFill>
-                <a:latin typeface="Calibri"/>
-              </a:defRPr>
-            </a:pPr>
-            <a:r>
-              <a:t>• Mejor productividad global.</a:t>
+                  <a:srgbClr val="1C263C"/>
+                </a:solidFill>
+                <a:latin typeface="Calibri"/>
+              </a:defRPr>
+            </a:pPr>
+            <a:r>
+              <a:t>• Mejor productividad</a:t>
             </a:r>
           </a:p>
         </p:txBody>
@@ -4599,14 +4452,6 @@
 <file path=ppt/slides/slide4.xml><?xml version="1.0" encoding="utf-8"?>
 <p:sld xmlns:a="http://schemas.openxmlformats.org/drawingml/2006/main" xmlns:p="http://schemas.openxmlformats.org/presentationml/2006/main" xmlns:r="http://schemas.openxmlformats.org/officeDocument/2006/relationships">
   <p:cSld>
-    <p:bg>
-      <p:bgPr>
-        <a:solidFill>
-          <a:srgbClr val="F5F8FE"/>
-        </a:solidFill>
-        <a:effectLst/>
-      </p:bgPr>
-    </p:bg>
     <p:spTree>
       <p:nvGrpSpPr>
         <p:cNvPr id="1" name=""/>
@@ -4614,22 +4459,46 @@
         <p:nvPr/>
       </p:nvGrpSpPr>
       <p:grpSpPr/>
-      <p:sp>
-        <p:nvSpPr>
-          <p:cNvPr id="2" name="Rectangle 1"/>
+      <p:pic>
+        <p:nvPicPr>
+          <p:cNvPr id="2" name="Picture 1" descr="chatbot-bg-1.jpg"/>
+          <p:cNvPicPr>
+            <a:picLocks noChangeAspect="1"/>
+          </p:cNvPicPr>
+          <p:nvPr/>
+        </p:nvPicPr>
+        <p:blipFill>
+          <a:blip r:embed="rId2"/>
+          <a:stretch>
+            <a:fillRect/>
+          </a:stretch>
+        </p:blipFill>
+        <p:spPr>
+          <a:xfrm>
+            <a:off x="0" y="0"/>
+            <a:ext cx="12191695" cy="6858000"/>
+          </a:xfrm>
+          <a:prstGeom prst="rect">
+            <a:avLst/>
+          </a:prstGeom>
+        </p:spPr>
+      </p:pic>
+      <p:sp>
+        <p:nvSpPr>
+          <p:cNvPr id="3" name="Rectangle 2"/>
           <p:cNvSpPr/>
           <p:nvPr/>
         </p:nvSpPr>
         <p:spPr>
           <a:xfrm>
             <a:off x="0" y="0"/>
-            <a:ext cx="12191695" cy="640080"/>
+            <a:ext cx="12191695" cy="6858000"/>
           </a:xfrm>
           <a:prstGeom prst="rect">
             <a:avLst/>
           </a:prstGeom>
           <a:solidFill>
-            <a:srgbClr val="143475"/>
+            <a:srgbClr val="070F1E"/>
           </a:solidFill>
           <a:ln>
             <a:noFill/>
@@ -4659,14 +4528,57 @@
       </p:sp>
       <p:sp>
         <p:nvSpPr>
-          <p:cNvPr id="3" name="TextBox 2"/>
+          <p:cNvPr id="4" name="Rectangle 3"/>
+          <p:cNvSpPr/>
+          <p:nvPr/>
+        </p:nvSpPr>
+        <p:spPr>
+          <a:xfrm>
+            <a:off x="0" y="0"/>
+            <a:ext cx="12191695" cy="621792"/>
+          </a:xfrm>
+          <a:prstGeom prst="rect">
+            <a:avLst/>
+          </a:prstGeom>
+          <a:solidFill>
+            <a:srgbClr val="133271"/>
+          </a:solidFill>
+          <a:ln>
+            <a:noFill/>
+          </a:ln>
+        </p:spPr>
+        <p:style>
+          <a:lnRef idx="1">
+            <a:schemeClr val="accent1"/>
+          </a:lnRef>
+          <a:fillRef idx="3">
+            <a:schemeClr val="accent1"/>
+          </a:fillRef>
+          <a:effectRef idx="2">
+            <a:schemeClr val="accent1"/>
+          </a:effectRef>
+          <a:fontRef idx="minor">
+            <a:schemeClr val="lt1"/>
+          </a:fontRef>
+        </p:style>
+        <p:txBody>
+          <a:bodyPr rtlCol="0" anchor="ctr"/>
+          <a:lstStyle/>
+          <a:p>
+            <a:pPr algn="ctr"/>
+          </a:p>
+        </p:txBody>
+      </p:sp>
+      <p:sp>
+        <p:nvSpPr>
+          <p:cNvPr id="5" name="TextBox 4"/>
           <p:cNvSpPr txBox="1"/>
           <p:nvPr/>
         </p:nvSpPr>
         <p:spPr>
           <a:xfrm>
             <a:off x="457200" y="109728"/>
-            <a:ext cx="6858000" cy="320040"/>
+            <a:ext cx="7132320" cy="320040"/>
           </a:xfrm>
           <a:prstGeom prst="rect">
             <a:avLst/>
@@ -4695,14 +4607,14 @@
       </p:sp>
       <p:sp>
         <p:nvSpPr>
-          <p:cNvPr id="4" name="TextBox 3"/>
+          <p:cNvPr id="6" name="TextBox 5"/>
           <p:cNvSpPr txBox="1"/>
           <p:nvPr/>
         </p:nvSpPr>
         <p:spPr>
           <a:xfrm>
-            <a:off x="731520" y="914400"/>
-            <a:ext cx="10789920" cy="1280160"/>
+            <a:off x="685800" y="868680"/>
+            <a:ext cx="10972800" cy="1234440"/>
           </a:xfrm>
           <a:prstGeom prst="rect">
             <a:avLst/>
@@ -4718,7 +4630,7 @@
             <a:pPr algn="l">
               <a:defRPr sz="3400" b="1" u="none">
                 <a:solidFill>
-                  <a:srgbClr val="143475"/>
+                  <a:srgbClr val="FFFFFF"/>
                 </a:solidFill>
                 <a:latin typeface="Calibri"/>
               </a:defRPr>
@@ -4731,27 +4643,27 @@
             <a:pPr algn="l">
               <a:defRPr sz="1800" b="0" u="none">
                 <a:solidFill>
-                  <a:srgbClr val="566177"/>
-                </a:solidFill>
-                <a:latin typeface="Calibri"/>
-              </a:defRPr>
-            </a:pPr>
-            <a:r>
-              <a:t>Recorrido simple en 4 momentos.</a:t>
-            </a:r>
-          </a:p>
-        </p:txBody>
-      </p:sp>
-      <p:sp>
-        <p:nvSpPr>
-          <p:cNvPr id="5" name="Rounded Rectangle 4"/>
+                  <a:srgbClr val="E6ECF8"/>
+                </a:solidFill>
+                <a:latin typeface="Calibri"/>
+              </a:defRPr>
+            </a:pPr>
+            <a:r>
+              <a:t>Flujo simple y entendible en 4 pasos.</a:t>
+            </a:r>
+          </a:p>
+        </p:txBody>
+      </p:sp>
+      <p:sp>
+        <p:nvSpPr>
+          <p:cNvPr id="7" name="Rounded Rectangle 6"/>
           <p:cNvSpPr/>
           <p:nvPr/>
         </p:nvSpPr>
         <p:spPr>
           <a:xfrm>
             <a:off x="777240" y="2148840"/>
-            <a:ext cx="2834640" cy="3200400"/>
+            <a:ext cx="2816352" cy="3291840"/>
           </a:xfrm>
           <a:prstGeom prst="roundRect">
             <a:avLst/>
@@ -4761,7 +4673,7 @@
           </a:solidFill>
           <a:ln>
             <a:solidFill>
-              <a:srgbClr val="D8E2F3"/>
+              <a:srgbClr val="D2DDF0"/>
             </a:solidFill>
           </a:ln>
         </p:spPr>
@@ -4783,43 +4695,43 @@
           <a:bodyPr rtlCol="0" anchor="ctr" wrap="square"/>
           <a:lstStyle/>
           <a:p>
-            <a:pPr algn="ctr">
-              <a:defRPr sz="1700" b="1" u="none">
-                <a:solidFill>
-                  <a:srgbClr val="2D63D6"/>
-                </a:solidFill>
-                <a:latin typeface="Calibri"/>
-              </a:defRPr>
-            </a:pPr>
-            <a:r>
-              <a:t>1) Consulta inicial</a:t>
-            </a:r>
-          </a:p>
-          <a:p>
-            <a:pPr algn="ctr">
-              <a:defRPr sz="1400" b="0" u="none">
-                <a:solidFill>
-                  <a:srgbClr val="16213A"/>
-                </a:solidFill>
-                <a:latin typeface="Calibri"/>
-              </a:defRPr>
-            </a:pPr>
-            <a:r>
-              <a:t>El colaborador escribe su consulta en lenguaje natural.</a:t>
-            </a:r>
-          </a:p>
-        </p:txBody>
-      </p:sp>
-      <p:sp>
-        <p:nvSpPr>
-          <p:cNvPr id="6" name="Rounded Rectangle 5"/>
+            <a:pPr algn="l">
+              <a:defRPr sz="2000" b="1" u="none">
+                <a:solidFill>
+                  <a:srgbClr val="3168DA"/>
+                </a:solidFill>
+                <a:latin typeface="Calibri"/>
+              </a:defRPr>
+            </a:pPr>
+            <a:r>
+              <a:t>1) Consulta</a:t>
+            </a:r>
+          </a:p>
+          <a:p>
+            <a:pPr algn="l">
+              <a:defRPr sz="1600" b="0" u="none">
+                <a:solidFill>
+                  <a:srgbClr val="1C263C"/>
+                </a:solidFill>
+                <a:latin typeface="Calibri"/>
+              </a:defRPr>
+            </a:pPr>
+            <a:r>
+              <a:t>• El colaborador escribe su necesidad.</a:t>
+            </a:r>
+          </a:p>
+        </p:txBody>
+      </p:sp>
+      <p:sp>
+        <p:nvSpPr>
+          <p:cNvPr id="8" name="Rounded Rectangle 7"/>
           <p:cNvSpPr/>
           <p:nvPr/>
         </p:nvSpPr>
         <p:spPr>
           <a:xfrm>
-            <a:off x="3703320" y="2148840"/>
-            <a:ext cx="2834640" cy="3200400"/>
+            <a:off x="3657600" y="2148840"/>
+            <a:ext cx="2816352" cy="3291840"/>
           </a:xfrm>
           <a:prstGeom prst="roundRect">
             <a:avLst/>
@@ -4829,7 +4741,7 @@
           </a:solidFill>
           <a:ln>
             <a:solidFill>
-              <a:srgbClr val="D8E2F3"/>
+              <a:srgbClr val="D2DDF0"/>
             </a:solidFill>
           </a:ln>
         </p:spPr>
@@ -4851,43 +4763,43 @@
           <a:bodyPr rtlCol="0" anchor="ctr" wrap="square"/>
           <a:lstStyle/>
           <a:p>
-            <a:pPr algn="ctr">
-              <a:defRPr sz="1700" b="1" u="none">
-                <a:solidFill>
-                  <a:srgbClr val="2D63D6"/>
-                </a:solidFill>
-                <a:latin typeface="Calibri"/>
-              </a:defRPr>
-            </a:pPr>
-            <a:r>
-              <a:t>2) Respuesta inmediata</a:t>
-            </a:r>
-          </a:p>
-          <a:p>
-            <a:pPr algn="ctr">
-              <a:defRPr sz="1400" b="0" u="none">
-                <a:solidFill>
-                  <a:srgbClr val="16213A"/>
-                </a:solidFill>
-                <a:latin typeface="Calibri"/>
-              </a:defRPr>
-            </a:pPr>
-            <a:r>
-              <a:t>El asistente responde con información clara y accionable.</a:t>
-            </a:r>
-          </a:p>
-        </p:txBody>
-      </p:sp>
-      <p:sp>
-        <p:nvSpPr>
-          <p:cNvPr id="7" name="Rounded Rectangle 6"/>
+            <a:pPr algn="l">
+              <a:defRPr sz="2000" b="1" u="none">
+                <a:solidFill>
+                  <a:srgbClr val="3168DA"/>
+                </a:solidFill>
+                <a:latin typeface="Calibri"/>
+              </a:defRPr>
+            </a:pPr>
+            <a:r>
+              <a:t>2) Respuesta</a:t>
+            </a:r>
+          </a:p>
+          <a:p>
+            <a:pPr algn="l">
+              <a:defRPr sz="1600" b="0" u="none">
+                <a:solidFill>
+                  <a:srgbClr val="1C263C"/>
+                </a:solidFill>
+                <a:latin typeface="Calibri"/>
+              </a:defRPr>
+            </a:pPr>
+            <a:r>
+              <a:t>• Recibe respuesta inmediata y guía.</a:t>
+            </a:r>
+          </a:p>
+        </p:txBody>
+      </p:sp>
+      <p:sp>
+        <p:nvSpPr>
+          <p:cNvPr id="9" name="Rounded Rectangle 8"/>
           <p:cNvSpPr/>
           <p:nvPr/>
         </p:nvSpPr>
         <p:spPr>
           <a:xfrm>
-            <a:off x="6629400" y="2148840"/>
-            <a:ext cx="2834640" cy="3200400"/>
+            <a:off x="6537960" y="2148840"/>
+            <a:ext cx="2816352" cy="3291840"/>
           </a:xfrm>
           <a:prstGeom prst="roundRect">
             <a:avLst/>
@@ -4897,7 +4809,7 @@
           </a:solidFill>
           <a:ln>
             <a:solidFill>
-              <a:srgbClr val="D8E2F3"/>
+              <a:srgbClr val="D2DDF0"/>
             </a:solidFill>
           </a:ln>
         </p:spPr>
@@ -4919,43 +4831,43 @@
           <a:bodyPr rtlCol="0" anchor="ctr" wrap="square"/>
           <a:lstStyle/>
           <a:p>
-            <a:pPr algn="ctr">
-              <a:defRPr sz="1700" b="1" u="none">
-                <a:solidFill>
-                  <a:srgbClr val="2D63D6"/>
-                </a:solidFill>
-                <a:latin typeface="Calibri"/>
-              </a:defRPr>
-            </a:pPr>
-            <a:r>
-              <a:t>3) Si aplica: pase a RRHH</a:t>
-            </a:r>
-          </a:p>
-          <a:p>
-            <a:pPr algn="ctr">
-              <a:defRPr sz="1400" b="0" u="none">
-                <a:solidFill>
-                  <a:srgbClr val="16213A"/>
-                </a:solidFill>
-                <a:latin typeface="Calibri"/>
-              </a:defRPr>
-            </a:pPr>
-            <a:r>
-              <a:t>Cuando el caso lo requiere, un agente humano toma la conversación.</a:t>
-            </a:r>
-          </a:p>
-        </p:txBody>
-      </p:sp>
-      <p:sp>
-        <p:nvSpPr>
-          <p:cNvPr id="8" name="Rounded Rectangle 7"/>
+            <a:pPr algn="l">
+              <a:defRPr sz="2000" b="1" u="none">
+                <a:solidFill>
+                  <a:srgbClr val="3168DA"/>
+                </a:solidFill>
+                <a:latin typeface="Calibri"/>
+              </a:defRPr>
+            </a:pPr>
+            <a:r>
+              <a:t>3) Pase a RRHH</a:t>
+            </a:r>
+          </a:p>
+          <a:p>
+            <a:pPr algn="l">
+              <a:defRPr sz="1600" b="0" u="none">
+                <a:solidFill>
+                  <a:srgbClr val="1C263C"/>
+                </a:solidFill>
+                <a:latin typeface="Calibri"/>
+              </a:defRPr>
+            </a:pPr>
+            <a:r>
+              <a:t>• Si hace falta, toma un agente humano.</a:t>
+            </a:r>
+          </a:p>
+        </p:txBody>
+      </p:sp>
+      <p:sp>
+        <p:nvSpPr>
+          <p:cNvPr id="10" name="Rounded Rectangle 9"/>
           <p:cNvSpPr/>
           <p:nvPr/>
         </p:nvSpPr>
         <p:spPr>
           <a:xfrm>
-            <a:off x="9555480" y="2148840"/>
-            <a:ext cx="2834640" cy="3200400"/>
+            <a:off x="9418320" y="2148840"/>
+            <a:ext cx="2816352" cy="3291840"/>
           </a:xfrm>
           <a:prstGeom prst="roundRect">
             <a:avLst/>
@@ -4965,7 +4877,7 @@
           </a:solidFill>
           <a:ln>
             <a:solidFill>
-              <a:srgbClr val="D8E2F3"/>
+              <a:srgbClr val="D2DDF0"/>
             </a:solidFill>
           </a:ln>
         </p:spPr>
@@ -4987,29 +4899,29 @@
           <a:bodyPr rtlCol="0" anchor="ctr" wrap="square"/>
           <a:lstStyle/>
           <a:p>
-            <a:pPr algn="ctr">
-              <a:defRPr sz="1700" b="1" u="none">
-                <a:solidFill>
-                  <a:srgbClr val="2D63D6"/>
-                </a:solidFill>
-                <a:latin typeface="Calibri"/>
-              </a:defRPr>
-            </a:pPr>
-            <a:r>
-              <a:t>4) Resolución y cierre</a:t>
-            </a:r>
-          </a:p>
-          <a:p>
-            <a:pPr algn="ctr">
-              <a:defRPr sz="1400" b="0" u="none">
-                <a:solidFill>
-                  <a:srgbClr val="16213A"/>
-                </a:solidFill>
-                <a:latin typeface="Calibri"/>
-              </a:defRPr>
-            </a:pPr>
-            <a:r>
-              <a:t>Queda registro de la gestión para seguimiento y mejora.</a:t>
+            <a:pPr algn="l">
+              <a:defRPr sz="2000" b="1" u="none">
+                <a:solidFill>
+                  <a:srgbClr val="3168DA"/>
+                </a:solidFill>
+                <a:latin typeface="Calibri"/>
+              </a:defRPr>
+            </a:pPr>
+            <a:r>
+              <a:t>4) Cierre</a:t>
+            </a:r>
+          </a:p>
+          <a:p>
+            <a:pPr algn="l">
+              <a:defRPr sz="1600" b="0" u="none">
+                <a:solidFill>
+                  <a:srgbClr val="1C263C"/>
+                </a:solidFill>
+                <a:latin typeface="Calibri"/>
+              </a:defRPr>
+            </a:pPr>
+            <a:r>
+              <a:t>• Se resuelve y queda registro.</a:t>
             </a:r>
           </a:p>
         </p:txBody>
@@ -5025,14 +4937,6 @@
 <file path=ppt/slides/slide5.xml><?xml version="1.0" encoding="utf-8"?>
 <p:sld xmlns:a="http://schemas.openxmlformats.org/drawingml/2006/main" xmlns:p="http://schemas.openxmlformats.org/presentationml/2006/main" xmlns:r="http://schemas.openxmlformats.org/officeDocument/2006/relationships">
   <p:cSld>
-    <p:bg>
-      <p:bgPr>
-        <a:solidFill>
-          <a:srgbClr val="F5F8FE"/>
-        </a:solidFill>
-        <a:effectLst/>
-      </p:bgPr>
-    </p:bg>
     <p:spTree>
       <p:nvGrpSpPr>
         <p:cNvPr id="1" name=""/>
@@ -5040,22 +4944,46 @@
         <p:nvPr/>
       </p:nvGrpSpPr>
       <p:grpSpPr/>
-      <p:sp>
-        <p:nvSpPr>
-          <p:cNvPr id="2" name="Rectangle 1"/>
+      <p:pic>
+        <p:nvPicPr>
+          <p:cNvPr id="2" name="Picture 1" descr="chatbot-bg-2.jpg"/>
+          <p:cNvPicPr>
+            <a:picLocks noChangeAspect="1"/>
+          </p:cNvPicPr>
+          <p:nvPr/>
+        </p:nvPicPr>
+        <p:blipFill>
+          <a:blip r:embed="rId2"/>
+          <a:stretch>
+            <a:fillRect/>
+          </a:stretch>
+        </p:blipFill>
+        <p:spPr>
+          <a:xfrm>
+            <a:off x="0" y="0"/>
+            <a:ext cx="12191695" cy="6858000"/>
+          </a:xfrm>
+          <a:prstGeom prst="rect">
+            <a:avLst/>
+          </a:prstGeom>
+        </p:spPr>
+      </p:pic>
+      <p:sp>
+        <p:nvSpPr>
+          <p:cNvPr id="3" name="Rectangle 2"/>
           <p:cNvSpPr/>
           <p:nvPr/>
         </p:nvSpPr>
         <p:spPr>
           <a:xfrm>
             <a:off x="0" y="0"/>
-            <a:ext cx="12191695" cy="640080"/>
+            <a:ext cx="12191695" cy="6858000"/>
           </a:xfrm>
           <a:prstGeom prst="rect">
             <a:avLst/>
           </a:prstGeom>
           <a:solidFill>
-            <a:srgbClr val="143475"/>
+            <a:srgbClr val="070F1E"/>
           </a:solidFill>
           <a:ln>
             <a:noFill/>
@@ -5085,14 +5013,57 @@
       </p:sp>
       <p:sp>
         <p:nvSpPr>
-          <p:cNvPr id="3" name="TextBox 2"/>
+          <p:cNvPr id="4" name="Rectangle 3"/>
+          <p:cNvSpPr/>
+          <p:nvPr/>
+        </p:nvSpPr>
+        <p:spPr>
+          <a:xfrm>
+            <a:off x="0" y="0"/>
+            <a:ext cx="12191695" cy="621792"/>
+          </a:xfrm>
+          <a:prstGeom prst="rect">
+            <a:avLst/>
+          </a:prstGeom>
+          <a:solidFill>
+            <a:srgbClr val="133271"/>
+          </a:solidFill>
+          <a:ln>
+            <a:noFill/>
+          </a:ln>
+        </p:spPr>
+        <p:style>
+          <a:lnRef idx="1">
+            <a:schemeClr val="accent1"/>
+          </a:lnRef>
+          <a:fillRef idx="3">
+            <a:schemeClr val="accent1"/>
+          </a:fillRef>
+          <a:effectRef idx="2">
+            <a:schemeClr val="accent1"/>
+          </a:effectRef>
+          <a:fontRef idx="minor">
+            <a:schemeClr val="lt1"/>
+          </a:fontRef>
+        </p:style>
+        <p:txBody>
+          <a:bodyPr rtlCol="0" anchor="ctr"/>
+          <a:lstStyle/>
+          <a:p>
+            <a:pPr algn="ctr"/>
+          </a:p>
+        </p:txBody>
+      </p:sp>
+      <p:sp>
+        <p:nvSpPr>
+          <p:cNvPr id="5" name="TextBox 4"/>
           <p:cNvSpPr txBox="1"/>
           <p:nvPr/>
         </p:nvSpPr>
         <p:spPr>
           <a:xfrm>
             <a:off x="457200" y="109728"/>
-            <a:ext cx="6858000" cy="320040"/>
+            <a:ext cx="7132320" cy="320040"/>
           </a:xfrm>
           <a:prstGeom prst="rect">
             <a:avLst/>
@@ -5121,14 +5092,14 @@
       </p:sp>
       <p:sp>
         <p:nvSpPr>
-          <p:cNvPr id="4" name="TextBox 3"/>
+          <p:cNvPr id="6" name="TextBox 5"/>
           <p:cNvSpPr txBox="1"/>
           <p:nvPr/>
         </p:nvSpPr>
         <p:spPr>
           <a:xfrm>
-            <a:off x="731520" y="914400"/>
-            <a:ext cx="10789920" cy="1280160"/>
+            <a:off x="685800" y="868680"/>
+            <a:ext cx="10972800" cy="1234440"/>
           </a:xfrm>
           <a:prstGeom prst="rect">
             <a:avLst/>
@@ -5144,7 +5115,7 @@
             <a:pPr algn="l">
               <a:defRPr sz="3400" b="1" u="none">
                 <a:solidFill>
-                  <a:srgbClr val="143475"/>
+                  <a:srgbClr val="FFFFFF"/>
                 </a:solidFill>
                 <a:latin typeface="Calibri"/>
               </a:defRPr>
@@ -5157,27 +5128,27 @@
             <a:pPr algn="l">
               <a:defRPr sz="1800" b="0" u="none">
                 <a:solidFill>
-                  <a:srgbClr val="566177"/>
-                </a:solidFill>
-                <a:latin typeface="Calibri"/>
-              </a:defRPr>
-            </a:pPr>
-            <a:r>
-              <a:t>Gestión ordenada, colaborativa y medible.</a:t>
-            </a:r>
-          </a:p>
-        </p:txBody>
-      </p:sp>
-      <p:sp>
-        <p:nvSpPr>
-          <p:cNvPr id="5" name="Rounded Rectangle 4"/>
+                  <a:srgbClr val="E6ECF8"/>
+                </a:solidFill>
+                <a:latin typeface="Calibri"/>
+              </a:defRPr>
+            </a:pPr>
+            <a:r>
+              <a:t>Gestión más ordenada, colaborativa y medible.</a:t>
+            </a:r>
+          </a:p>
+        </p:txBody>
+      </p:sp>
+      <p:sp>
+        <p:nvSpPr>
+          <p:cNvPr id="7" name="Rounded Rectangle 6"/>
           <p:cNvSpPr/>
           <p:nvPr/>
         </p:nvSpPr>
         <p:spPr>
           <a:xfrm>
             <a:off x="731520" y="1965960"/>
-            <a:ext cx="10698480" cy="3886200"/>
+            <a:ext cx="10698480" cy="3840480"/>
           </a:xfrm>
           <a:prstGeom prst="roundRect">
             <a:avLst/>
@@ -5187,7 +5158,7 @@
           </a:solidFill>
           <a:ln>
             <a:solidFill>
-              <a:srgbClr val="D8E2F3"/>
+              <a:srgbClr val="D2DDF0"/>
             </a:solidFill>
           </a:ln>
         </p:spPr>
@@ -5212,7 +5183,7 @@
             <a:pPr algn="l">
               <a:defRPr sz="2000" b="1" u="none">
                 <a:solidFill>
-                  <a:srgbClr val="2D63D6"/>
+                  <a:srgbClr val="189D75"/>
                 </a:solidFill>
                 <a:latin typeface="Calibri"/>
               </a:defRPr>
@@ -5225,65 +5196,65 @@
             <a:pPr algn="l">
               <a:defRPr sz="1600" b="0" u="none">
                 <a:solidFill>
-                  <a:srgbClr val="16213A"/>
-                </a:solidFill>
-                <a:latin typeface="Calibri"/>
-              </a:defRPr>
-            </a:pPr>
-            <a:r>
-              <a:t>• Las conversaciones llegan organizadas y priorizadas.</a:t>
+                  <a:srgbClr val="1C263C"/>
+                </a:solidFill>
+                <a:latin typeface="Calibri"/>
+              </a:defRPr>
+            </a:pPr>
+            <a:r>
+              <a:t>• Conversaciones centralizadas y priorizadas.</a:t>
             </a:r>
           </a:p>
           <a:p>
             <a:pPr algn="l">
               <a:defRPr sz="1600" b="0" u="none">
                 <a:solidFill>
-                  <a:srgbClr val="16213A"/>
-                </a:solidFill>
-                <a:latin typeface="Calibri"/>
-              </a:defRPr>
-            </a:pPr>
-            <a:r>
-              <a:t>• Se pueden tomar, reasignar y cerrar casos con trazabilidad.</a:t>
+                  <a:srgbClr val="1C263C"/>
+                </a:solidFill>
+                <a:latin typeface="Calibri"/>
+              </a:defRPr>
+            </a:pPr>
+            <a:r>
+              <a:t>• Posibilidad de tomar, reasignar y cerrar casos con registro.</a:t>
             </a:r>
           </a:p>
           <a:p>
             <a:pPr algn="l">
               <a:defRPr sz="1600" b="0" u="none">
                 <a:solidFill>
-                  <a:srgbClr val="16213A"/>
-                </a:solidFill>
-                <a:latin typeface="Calibri"/>
-              </a:defRPr>
-            </a:pPr>
-            <a:r>
-              <a:t>• La operación se divide por empresa/sucursal según permisos.</a:t>
+                  <a:srgbClr val="1C263C"/>
+                </a:solidFill>
+                <a:latin typeface="Calibri"/>
+              </a:defRPr>
+            </a:pPr>
+            <a:r>
+              <a:t>• Operación por empresa/sucursal según permisos.</a:t>
             </a:r>
           </a:p>
           <a:p>
             <a:pPr algn="l">
               <a:defRPr sz="1600" b="0" u="none">
                 <a:solidFill>
-                  <a:srgbClr val="16213A"/>
-                </a:solidFill>
-                <a:latin typeface="Calibri"/>
-              </a:defRPr>
-            </a:pPr>
-            <a:r>
-              <a:t>• Se reduce la carga administrativa y mejora el tiempo de respuesta.</a:t>
+                  <a:srgbClr val="1C263C"/>
+                </a:solidFill>
+                <a:latin typeface="Calibri"/>
+              </a:defRPr>
+            </a:pPr>
+            <a:r>
+              <a:t>• Seguimiento con indicadores de tiempo y volumen.</a:t>
             </a:r>
           </a:p>
           <a:p>
             <a:pPr algn="l">
               <a:defRPr sz="1600" b="0" u="none">
                 <a:solidFill>
-                  <a:srgbClr val="16213A"/>
-                </a:solidFill>
-                <a:latin typeface="Calibri"/>
-              </a:defRPr>
-            </a:pPr>
-            <a:r>
-              <a:t>• La información queda centralizada para control y auditoría.</a:t>
+                  <a:srgbClr val="1C263C"/>
+                </a:solidFill>
+                <a:latin typeface="Calibri"/>
+              </a:defRPr>
+            </a:pPr>
+            <a:r>
+              <a:t>• Menos trabajo administrativo, más foco en personas.</a:t>
             </a:r>
           </a:p>
         </p:txBody>
@@ -5299,14 +5270,6 @@
 <file path=ppt/slides/slide6.xml><?xml version="1.0" encoding="utf-8"?>
 <p:sld xmlns:a="http://schemas.openxmlformats.org/drawingml/2006/main" xmlns:p="http://schemas.openxmlformats.org/presentationml/2006/main" xmlns:r="http://schemas.openxmlformats.org/officeDocument/2006/relationships">
   <p:cSld>
-    <p:bg>
-      <p:bgPr>
-        <a:solidFill>
-          <a:srgbClr val="F5F8FE"/>
-        </a:solidFill>
-        <a:effectLst/>
-      </p:bgPr>
-    </p:bg>
     <p:spTree>
       <p:nvGrpSpPr>
         <p:cNvPr id="1" name=""/>
@@ -5314,22 +5277,46 @@
         <p:nvPr/>
       </p:nvGrpSpPr>
       <p:grpSpPr/>
-      <p:sp>
-        <p:nvSpPr>
-          <p:cNvPr id="2" name="Rectangle 1"/>
+      <p:pic>
+        <p:nvPicPr>
+          <p:cNvPr id="2" name="Picture 1" descr="chatbot-bg-3.jpg"/>
+          <p:cNvPicPr>
+            <a:picLocks noChangeAspect="1"/>
+          </p:cNvPicPr>
+          <p:nvPr/>
+        </p:nvPicPr>
+        <p:blipFill>
+          <a:blip r:embed="rId2"/>
+          <a:stretch>
+            <a:fillRect/>
+          </a:stretch>
+        </p:blipFill>
+        <p:spPr>
+          <a:xfrm>
+            <a:off x="0" y="0"/>
+            <a:ext cx="12191695" cy="6858000"/>
+          </a:xfrm>
+          <a:prstGeom prst="rect">
+            <a:avLst/>
+          </a:prstGeom>
+        </p:spPr>
+      </p:pic>
+      <p:sp>
+        <p:nvSpPr>
+          <p:cNvPr id="3" name="Rectangle 2"/>
           <p:cNvSpPr/>
           <p:nvPr/>
         </p:nvSpPr>
         <p:spPr>
           <a:xfrm>
             <a:off x="0" y="0"/>
-            <a:ext cx="12191695" cy="640080"/>
+            <a:ext cx="12191695" cy="6858000"/>
           </a:xfrm>
           <a:prstGeom prst="rect">
             <a:avLst/>
           </a:prstGeom>
           <a:solidFill>
-            <a:srgbClr val="143475"/>
+            <a:srgbClr val="070F1E"/>
           </a:solidFill>
           <a:ln>
             <a:noFill/>
@@ -5359,14 +5346,57 @@
       </p:sp>
       <p:sp>
         <p:nvSpPr>
-          <p:cNvPr id="3" name="TextBox 2"/>
+          <p:cNvPr id="4" name="Rectangle 3"/>
+          <p:cNvSpPr/>
+          <p:nvPr/>
+        </p:nvSpPr>
+        <p:spPr>
+          <a:xfrm>
+            <a:off x="0" y="0"/>
+            <a:ext cx="12191695" cy="621792"/>
+          </a:xfrm>
+          <a:prstGeom prst="rect">
+            <a:avLst/>
+          </a:prstGeom>
+          <a:solidFill>
+            <a:srgbClr val="133271"/>
+          </a:solidFill>
+          <a:ln>
+            <a:noFill/>
+          </a:ln>
+        </p:spPr>
+        <p:style>
+          <a:lnRef idx="1">
+            <a:schemeClr val="accent1"/>
+          </a:lnRef>
+          <a:fillRef idx="3">
+            <a:schemeClr val="accent1"/>
+          </a:fillRef>
+          <a:effectRef idx="2">
+            <a:schemeClr val="accent1"/>
+          </a:effectRef>
+          <a:fontRef idx="minor">
+            <a:schemeClr val="lt1"/>
+          </a:fontRef>
+        </p:style>
+        <p:txBody>
+          <a:bodyPr rtlCol="0" anchor="ctr"/>
+          <a:lstStyle/>
+          <a:p>
+            <a:pPr algn="ctr"/>
+          </a:p>
+        </p:txBody>
+      </p:sp>
+      <p:sp>
+        <p:nvSpPr>
+          <p:cNvPr id="5" name="TextBox 4"/>
           <p:cNvSpPr txBox="1"/>
           <p:nvPr/>
         </p:nvSpPr>
         <p:spPr>
           <a:xfrm>
             <a:off x="457200" y="109728"/>
-            <a:ext cx="6858000" cy="320040"/>
+            <a:ext cx="7132320" cy="320040"/>
           </a:xfrm>
           <a:prstGeom prst="rect">
             <a:avLst/>
@@ -5395,14 +5425,14 @@
       </p:sp>
       <p:sp>
         <p:nvSpPr>
-          <p:cNvPr id="4" name="TextBox 3"/>
+          <p:cNvPr id="6" name="TextBox 5"/>
           <p:cNvSpPr txBox="1"/>
           <p:nvPr/>
         </p:nvSpPr>
         <p:spPr>
           <a:xfrm>
-            <a:off x="731520" y="914400"/>
-            <a:ext cx="10789920" cy="1280160"/>
+            <a:off x="685800" y="868680"/>
+            <a:ext cx="10972800" cy="1234440"/>
           </a:xfrm>
           <a:prstGeom prst="rect">
             <a:avLst/>
@@ -5418,7 +5448,7 @@
             <a:pPr algn="l">
               <a:defRPr sz="3400" b="1" u="none">
                 <a:solidFill>
-                  <a:srgbClr val="143475"/>
+                  <a:srgbClr val="FFFFFF"/>
                 </a:solidFill>
                 <a:latin typeface="Calibri"/>
               </a:defRPr>
@@ -5431,14 +5461,14 @@
       </p:sp>
       <p:sp>
         <p:nvSpPr>
-          <p:cNvPr id="5" name="Rounded Rectangle 4"/>
+          <p:cNvPr id="7" name="Rounded Rectangle 6"/>
           <p:cNvSpPr/>
           <p:nvPr/>
         </p:nvSpPr>
         <p:spPr>
           <a:xfrm>
             <a:off x="731520" y="2011680"/>
-            <a:ext cx="5257800" cy="3657600"/>
+            <a:ext cx="5303520" cy="3657600"/>
           </a:xfrm>
           <a:prstGeom prst="roundRect">
             <a:avLst/>
@@ -5448,7 +5478,7 @@
           </a:solidFill>
           <a:ln>
             <a:solidFill>
-              <a:srgbClr val="D8E2F3"/>
+              <a:srgbClr val="D2DDF0"/>
             </a:solidFill>
           </a:ln>
         </p:spPr>
@@ -5473,7 +5503,7 @@
             <a:pPr algn="l">
               <a:defRPr sz="2000" b="1" u="none">
                 <a:solidFill>
-                  <a:srgbClr val="2D63D6"/>
+                  <a:srgbClr val="3168DA"/>
                 </a:solidFill>
                 <a:latin typeface="Calibri"/>
               </a:defRPr>
@@ -5486,7 +5516,7 @@
             <a:pPr algn="l">
               <a:defRPr sz="1600" b="0" u="none">
                 <a:solidFill>
-                  <a:srgbClr val="16213A"/>
+                  <a:srgbClr val="1C263C"/>
                 </a:solidFill>
                 <a:latin typeface="Calibri"/>
               </a:defRPr>
@@ -5499,53 +5529,53 @@
             <a:pPr algn="l">
               <a:defRPr sz="1600" b="0" u="none">
                 <a:solidFill>
-                  <a:srgbClr val="16213A"/>
-                </a:solidFill>
-                <a:latin typeface="Calibri"/>
-              </a:defRPr>
-            </a:pPr>
-            <a:r>
-              <a:t>• Derivación a personas cuando el caso lo necesita.</a:t>
+                  <a:srgbClr val="1C263C"/>
+                </a:solidFill>
+                <a:latin typeface="Calibri"/>
+              </a:defRPr>
+            </a:pPr>
+            <a:r>
+              <a:t>• Derivación a personas cuando el caso lo requiere.</a:t>
             </a:r>
           </a:p>
           <a:p>
             <a:pPr algn="l">
               <a:defRPr sz="1600" b="0" u="none">
                 <a:solidFill>
-                  <a:srgbClr val="16213A"/>
-                </a:solidFill>
-                <a:latin typeface="Calibri"/>
-              </a:defRPr>
-            </a:pPr>
-            <a:r>
-              <a:t>• Historial de conversaciones centralizado.</a:t>
+                  <a:srgbClr val="1C263C"/>
+                </a:solidFill>
+                <a:latin typeface="Calibri"/>
+              </a:defRPr>
+            </a:pPr>
+            <a:r>
+              <a:t>• Historial centralizado de conversaciones.</a:t>
             </a:r>
           </a:p>
           <a:p>
             <a:pPr algn="l">
               <a:defRPr sz="1600" b="0" u="none">
                 <a:solidFill>
-                  <a:srgbClr val="16213A"/>
-                </a:solidFill>
-                <a:latin typeface="Calibri"/>
-              </a:defRPr>
-            </a:pPr>
-            <a:r>
-              <a:t>• Dashboard con indicadores clave.</a:t>
-            </a:r>
-          </a:p>
-        </p:txBody>
-      </p:sp>
-      <p:sp>
-        <p:nvSpPr>
-          <p:cNvPr id="6" name="Rounded Rectangle 5"/>
+                  <a:srgbClr val="1C263C"/>
+                </a:solidFill>
+                <a:latin typeface="Calibri"/>
+              </a:defRPr>
+            </a:pPr>
+            <a:r>
+              <a:t>• Dashboard de indicadores operativos.</a:t>
+            </a:r>
+          </a:p>
+        </p:txBody>
+      </p:sp>
+      <p:sp>
+        <p:nvSpPr>
+          <p:cNvPr id="8" name="Rounded Rectangle 7"/>
           <p:cNvSpPr/>
           <p:nvPr/>
         </p:nvSpPr>
         <p:spPr>
           <a:xfrm>
-            <a:off x="6172200" y="2011680"/>
-            <a:ext cx="5257800" cy="3657600"/>
+            <a:off x="6126480" y="2011680"/>
+            <a:ext cx="5303520" cy="3657600"/>
           </a:xfrm>
           <a:prstGeom prst="roundRect">
             <a:avLst/>
@@ -5555,7 +5585,7 @@
           </a:solidFill>
           <a:ln>
             <a:solidFill>
-              <a:srgbClr val="D8E2F3"/>
+              <a:srgbClr val="D2DDF0"/>
             </a:solidFill>
           </a:ln>
         </p:spPr>
@@ -5580,7 +5610,7 @@
             <a:pPr algn="l">
               <a:defRPr sz="2000" b="1" u="none">
                 <a:solidFill>
-                  <a:srgbClr val="15946E"/>
+                  <a:srgbClr val="189D75"/>
                 </a:solidFill>
                 <a:latin typeface="Calibri"/>
               </a:defRPr>
@@ -5593,7 +5623,7 @@
             <a:pPr algn="l">
               <a:defRPr sz="1600" b="0" u="none">
                 <a:solidFill>
-                  <a:srgbClr val="16213A"/>
+                  <a:srgbClr val="1C263C"/>
                 </a:solidFill>
                 <a:latin typeface="Calibri"/>
               </a:defRPr>
@@ -5606,20 +5636,20 @@
             <a:pPr algn="l">
               <a:defRPr sz="1600" b="0" u="none">
                 <a:solidFill>
-                  <a:srgbClr val="16213A"/>
-                </a:solidFill>
-                <a:latin typeface="Calibri"/>
-              </a:defRPr>
-            </a:pPr>
-            <a:r>
-              <a:t>• Usuarios, roles y permisos administrables.</a:t>
+                  <a:srgbClr val="1C263C"/>
+                </a:solidFill>
+                <a:latin typeface="Calibri"/>
+              </a:defRPr>
+            </a:pPr>
+            <a:r>
+              <a:t>• Administración de usuarios, roles y permisos.</a:t>
             </a:r>
           </a:p>
           <a:p>
             <a:pPr algn="l">
               <a:defRPr sz="1600" b="0" u="none">
                 <a:solidFill>
-                  <a:srgbClr val="16213A"/>
+                  <a:srgbClr val="1C263C"/>
                 </a:solidFill>
                 <a:latin typeface="Calibri"/>
               </a:defRPr>
@@ -5632,13 +5662,13 @@
             <a:pPr algn="l">
               <a:defRPr sz="1600" b="0" u="none">
                 <a:solidFill>
-                  <a:srgbClr val="16213A"/>
-                </a:solidFill>
-                <a:latin typeface="Calibri"/>
-              </a:defRPr>
-            </a:pPr>
-            <a:r>
-              <a:t>• Base lista para expansión a WhatsApp.</a:t>
+                  <a:srgbClr val="1C263C"/>
+                </a:solidFill>
+                <a:latin typeface="Calibri"/>
+              </a:defRPr>
+            </a:pPr>
+            <a:r>
+              <a:t>• Base lista para incorporar WhatsApp.</a:t>
             </a:r>
           </a:p>
         </p:txBody>
@@ -5654,14 +5684,6 @@
 <file path=ppt/slides/slide7.xml><?xml version="1.0" encoding="utf-8"?>
 <p:sld xmlns:a="http://schemas.openxmlformats.org/drawingml/2006/main" xmlns:p="http://schemas.openxmlformats.org/presentationml/2006/main" xmlns:r="http://schemas.openxmlformats.org/officeDocument/2006/relationships">
   <p:cSld>
-    <p:bg>
-      <p:bgPr>
-        <a:solidFill>
-          <a:srgbClr val="F5F8FE"/>
-        </a:solidFill>
-        <a:effectLst/>
-      </p:bgPr>
-    </p:bg>
     <p:spTree>
       <p:nvGrpSpPr>
         <p:cNvPr id="1" name=""/>
@@ -5669,22 +5691,46 @@
         <p:nvPr/>
       </p:nvGrpSpPr>
       <p:grpSpPr/>
-      <p:sp>
-        <p:nvSpPr>
-          <p:cNvPr id="2" name="Rectangle 1"/>
+      <p:pic>
+        <p:nvPicPr>
+          <p:cNvPr id="2" name="Picture 1" descr="chatbot-bg-1.jpg"/>
+          <p:cNvPicPr>
+            <a:picLocks noChangeAspect="1"/>
+          </p:cNvPicPr>
+          <p:nvPr/>
+        </p:nvPicPr>
+        <p:blipFill>
+          <a:blip r:embed="rId2"/>
+          <a:stretch>
+            <a:fillRect/>
+          </a:stretch>
+        </p:blipFill>
+        <p:spPr>
+          <a:xfrm>
+            <a:off x="0" y="0"/>
+            <a:ext cx="12191695" cy="6858000"/>
+          </a:xfrm>
+          <a:prstGeom prst="rect">
+            <a:avLst/>
+          </a:prstGeom>
+        </p:spPr>
+      </p:pic>
+      <p:sp>
+        <p:nvSpPr>
+          <p:cNvPr id="3" name="Rectangle 2"/>
           <p:cNvSpPr/>
           <p:nvPr/>
         </p:nvSpPr>
         <p:spPr>
           <a:xfrm>
             <a:off x="0" y="0"/>
-            <a:ext cx="12191695" cy="640080"/>
+            <a:ext cx="12191695" cy="6858000"/>
           </a:xfrm>
           <a:prstGeom prst="rect">
             <a:avLst/>
           </a:prstGeom>
           <a:solidFill>
-            <a:srgbClr val="143475"/>
+            <a:srgbClr val="070F1E"/>
           </a:solidFill>
           <a:ln>
             <a:noFill/>
@@ -5714,14 +5760,57 @@
       </p:sp>
       <p:sp>
         <p:nvSpPr>
-          <p:cNvPr id="3" name="TextBox 2"/>
+          <p:cNvPr id="4" name="Rectangle 3"/>
+          <p:cNvSpPr/>
+          <p:nvPr/>
+        </p:nvSpPr>
+        <p:spPr>
+          <a:xfrm>
+            <a:off x="0" y="0"/>
+            <a:ext cx="12191695" cy="621792"/>
+          </a:xfrm>
+          <a:prstGeom prst="rect">
+            <a:avLst/>
+          </a:prstGeom>
+          <a:solidFill>
+            <a:srgbClr val="133271"/>
+          </a:solidFill>
+          <a:ln>
+            <a:noFill/>
+          </a:ln>
+        </p:spPr>
+        <p:style>
+          <a:lnRef idx="1">
+            <a:schemeClr val="accent1"/>
+          </a:lnRef>
+          <a:fillRef idx="3">
+            <a:schemeClr val="accent1"/>
+          </a:fillRef>
+          <a:effectRef idx="2">
+            <a:schemeClr val="accent1"/>
+          </a:effectRef>
+          <a:fontRef idx="minor">
+            <a:schemeClr val="lt1"/>
+          </a:fontRef>
+        </p:style>
+        <p:txBody>
+          <a:bodyPr rtlCol="0" anchor="ctr"/>
+          <a:lstStyle/>
+          <a:p>
+            <a:pPr algn="ctr"/>
+          </a:p>
+        </p:txBody>
+      </p:sp>
+      <p:sp>
+        <p:nvSpPr>
+          <p:cNvPr id="5" name="TextBox 4"/>
           <p:cNvSpPr txBox="1"/>
           <p:nvPr/>
         </p:nvSpPr>
         <p:spPr>
           <a:xfrm>
             <a:off x="457200" y="109728"/>
-            <a:ext cx="6858000" cy="320040"/>
+            <a:ext cx="7132320" cy="320040"/>
           </a:xfrm>
           <a:prstGeom prst="rect">
             <a:avLst/>
@@ -5750,14 +5839,14 @@
       </p:sp>
       <p:sp>
         <p:nvSpPr>
-          <p:cNvPr id="4" name="TextBox 3"/>
+          <p:cNvPr id="6" name="TextBox 5"/>
           <p:cNvSpPr txBox="1"/>
           <p:nvPr/>
         </p:nvSpPr>
         <p:spPr>
           <a:xfrm>
-            <a:off x="731520" y="914400"/>
-            <a:ext cx="10789920" cy="1280160"/>
+            <a:off x="685800" y="868680"/>
+            <a:ext cx="10972800" cy="1234440"/>
           </a:xfrm>
           <a:prstGeom prst="rect">
             <a:avLst/>
@@ -5773,33 +5862,33 @@
             <a:pPr algn="l">
               <a:defRPr sz="3400" b="1" u="none">
                 <a:solidFill>
-                  <a:srgbClr val="143475"/>
-                </a:solidFill>
-                <a:latin typeface="Calibri"/>
-              </a:defRPr>
-            </a:pPr>
-            <a:r>
-              <a:t>Qué vamos a necesitar para producción</a:t>
+                  <a:srgbClr val="FFFFFF"/>
+                </a:solidFill>
+                <a:latin typeface="Calibri"/>
+              </a:defRPr>
+            </a:pPr>
+            <a:r>
+              <a:t>Qué se necesita para operar en producción</a:t>
             </a:r>
           </a:p>
           <a:p>
             <a:pPr algn="l">
               <a:defRPr sz="1800" b="0" u="none">
                 <a:solidFill>
-                  <a:srgbClr val="566177"/>
-                </a:solidFill>
-                <a:latin typeface="Calibri"/>
-              </a:defRPr>
-            </a:pPr>
-            <a:r>
-              <a:t>Componentes clave para operar con estabilidad y escalar el servicio.</a:t>
-            </a:r>
-          </a:p>
-        </p:txBody>
-      </p:sp>
-      <p:sp>
-        <p:nvSpPr>
-          <p:cNvPr id="5" name="Rounded Rectangle 4"/>
+                  <a:srgbClr val="E6ECF8"/>
+                </a:solidFill>
+                <a:latin typeface="Calibri"/>
+              </a:defRPr>
+            </a:pPr>
+            <a:r>
+              <a:t>Lenguaje simple para decisión ejecutiva.</a:t>
+            </a:r>
+          </a:p>
+        </p:txBody>
+      </p:sp>
+      <p:sp>
+        <p:nvSpPr>
+          <p:cNvPr id="7" name="Rounded Rectangle 6"/>
           <p:cNvSpPr/>
           <p:nvPr/>
         </p:nvSpPr>
@@ -5816,7 +5905,7 @@
           </a:solidFill>
           <a:ln>
             <a:solidFill>
-              <a:srgbClr val="D8E2F3"/>
+              <a:srgbClr val="D2DDF0"/>
             </a:solidFill>
           </a:ln>
         </p:spPr>
@@ -5841,7 +5930,7 @@
             <a:pPr algn="l">
               <a:defRPr sz="2000" b="1" u="none">
                 <a:solidFill>
-                  <a:srgbClr val="2D63D6"/>
+                  <a:srgbClr val="3168DA"/>
                 </a:solidFill>
                 <a:latin typeface="Calibri"/>
               </a:defRPr>
@@ -5854,7 +5943,7 @@
             <a:pPr algn="l">
               <a:defRPr sz="1600" b="0" u="none">
                 <a:solidFill>
-                  <a:srgbClr val="16213A"/>
+                  <a:srgbClr val="1C263C"/>
                 </a:solidFill>
                 <a:latin typeface="Calibri"/>
               </a:defRPr>
@@ -5867,46 +5956,33 @@
             <a:pPr algn="l">
               <a:defRPr sz="1600" b="0" u="none">
                 <a:solidFill>
-                  <a:srgbClr val="16213A"/>
-                </a:solidFill>
-                <a:latin typeface="Calibri"/>
-              </a:defRPr>
-            </a:pPr>
-            <a:r>
-              <a:t>• Historial y métricas</a:t>
+                  <a:srgbClr val="1C263C"/>
+                </a:solidFill>
+                <a:latin typeface="Calibri"/>
+              </a:defRPr>
+            </a:pPr>
+            <a:r>
+              <a:t>• Guarda conversaciones e indicadores</a:t>
             </a:r>
           </a:p>
           <a:p>
             <a:pPr algn="l">
               <a:defRPr sz="1600" b="0" u="none">
                 <a:solidFill>
-                  <a:srgbClr val="16213A"/>
-                </a:solidFill>
-                <a:latin typeface="Calibri"/>
-              </a:defRPr>
-            </a:pPr>
-            <a:r>
-              <a:t>• Configuración multiempresa</a:t>
-            </a:r>
-          </a:p>
-          <a:p>
-            <a:pPr algn="l">
-              <a:defRPr sz="1600" b="0" u="none">
-                <a:solidFill>
-                  <a:srgbClr val="16213A"/>
-                </a:solidFill>
-                <a:latin typeface="Calibri"/>
-              </a:defRPr>
-            </a:pPr>
-            <a:r>
-              <a:t>• Persistencia segura</a:t>
-            </a:r>
-          </a:p>
-        </p:txBody>
-      </p:sp>
-      <p:sp>
-        <p:nvSpPr>
-          <p:cNvPr id="6" name="Rounded Rectangle 5"/>
+                  <a:srgbClr val="1C263C"/>
+                </a:solidFill>
+                <a:latin typeface="Calibri"/>
+              </a:defRPr>
+            </a:pPr>
+            <a:r>
+              <a:t>• Permite operar por empresa/sucursal</a:t>
+            </a:r>
+          </a:p>
+        </p:txBody>
+      </p:sp>
+      <p:sp>
+        <p:nvSpPr>
+          <p:cNvPr id="8" name="Rounded Rectangle 7"/>
           <p:cNvSpPr/>
           <p:nvPr/>
         </p:nvSpPr>
@@ -5923,7 +5999,7 @@
           </a:solidFill>
           <a:ln>
             <a:solidFill>
-              <a:srgbClr val="D8E2F3"/>
+              <a:srgbClr val="D2DDF0"/>
             </a:solidFill>
           </a:ln>
         </p:spPr>
@@ -5948,7 +6024,7 @@
             <a:pPr algn="l">
               <a:defRPr sz="2000" b="1" u="none">
                 <a:solidFill>
-                  <a:srgbClr val="15946E"/>
+                  <a:srgbClr val="189D75"/>
                 </a:solidFill>
                 <a:latin typeface="Calibri"/>
               </a:defRPr>
@@ -5961,59 +6037,46 @@
             <a:pPr algn="l">
               <a:defRPr sz="1600" b="0" u="none">
                 <a:solidFill>
-                  <a:srgbClr val="16213A"/>
-                </a:solidFill>
-                <a:latin typeface="Calibri"/>
-              </a:defRPr>
-            </a:pPr>
-            <a:r>
-              <a:t>• Google AI Studio (prototipo)</a:t>
+                  <a:srgbClr val="1C263C"/>
+                </a:solidFill>
+                <a:latin typeface="Calibri"/>
+              </a:defRPr>
+            </a:pPr>
+            <a:r>
+              <a:t>• Google AI Studio para pruebas</a:t>
             </a:r>
           </a:p>
           <a:p>
             <a:pPr algn="l">
               <a:defRPr sz="1600" b="0" u="none">
                 <a:solidFill>
-                  <a:srgbClr val="16213A"/>
-                </a:solidFill>
-                <a:latin typeface="Calibri"/>
-              </a:defRPr>
-            </a:pPr>
-            <a:r>
-              <a:t>• Gemini API para producción</a:t>
+                  <a:srgbClr val="1C263C"/>
+                </a:solidFill>
+                <a:latin typeface="Calibri"/>
+              </a:defRPr>
+            </a:pPr>
+            <a:r>
+              <a:t>• Gemini API para uso productivo</a:t>
             </a:r>
           </a:p>
           <a:p>
             <a:pPr algn="l">
               <a:defRPr sz="1600" b="0" u="none">
                 <a:solidFill>
-                  <a:srgbClr val="16213A"/>
-                </a:solidFill>
-                <a:latin typeface="Calibri"/>
-              </a:defRPr>
-            </a:pPr>
-            <a:r>
-              <a:t>• Mejor respuesta por contexto</a:t>
-            </a:r>
-          </a:p>
-          <a:p>
-            <a:pPr algn="l">
-              <a:defRPr sz="1600" b="0" u="none">
-                <a:solidFill>
-                  <a:srgbClr val="16213A"/>
-                </a:solidFill>
-                <a:latin typeface="Calibri"/>
-              </a:defRPr>
-            </a:pPr>
-            <a:r>
-              <a:t>• Escalabilidad por consumo</a:t>
-            </a:r>
-          </a:p>
-        </p:txBody>
-      </p:sp>
-      <p:sp>
-        <p:nvSpPr>
-          <p:cNvPr id="7" name="Rounded Rectangle 6"/>
+                  <a:srgbClr val="1C263C"/>
+                </a:solidFill>
+                <a:latin typeface="Calibri"/>
+              </a:defRPr>
+            </a:pPr>
+            <a:r>
+              <a:t>• Respuestas más precisas por contexto</a:t>
+            </a:r>
+          </a:p>
+        </p:txBody>
+      </p:sp>
+      <p:sp>
+        <p:nvSpPr>
+          <p:cNvPr id="9" name="Rounded Rectangle 8"/>
           <p:cNvSpPr/>
           <p:nvPr/>
         </p:nvSpPr>
@@ -6030,7 +6093,7 @@
           </a:solidFill>
           <a:ln>
             <a:solidFill>
-              <a:srgbClr val="D8E2F3"/>
+              <a:srgbClr val="D2DDF0"/>
             </a:solidFill>
           </a:ln>
         </p:spPr>
@@ -6055,7 +6118,7 @@
             <a:pPr algn="l">
               <a:defRPr sz="2000" b="1" u="none">
                 <a:solidFill>
-                  <a:srgbClr val="E8931F"/>
+                  <a:srgbClr val="E89420"/>
                 </a:solidFill>
                 <a:latin typeface="Calibri"/>
               </a:defRPr>
@@ -6068,52 +6131,39 @@
             <a:pPr algn="l">
               <a:defRPr sz="1600" b="0" u="none">
                 <a:solidFill>
-                  <a:srgbClr val="16213A"/>
-                </a:solidFill>
-                <a:latin typeface="Calibri"/>
-              </a:defRPr>
-            </a:pPr>
-            <a:r>
-              <a:t>• WhatsApp Business API</a:t>
+                  <a:srgbClr val="1C263C"/>
+                </a:solidFill>
+                <a:latin typeface="Calibri"/>
+              </a:defRPr>
+            </a:pPr>
+            <a:r>
+              <a:t>• Cuenta oficial WhatsApp Business activa</a:t>
             </a:r>
           </a:p>
           <a:p>
             <a:pPr algn="l">
               <a:defRPr sz="1600" b="0" u="none">
                 <a:solidFill>
-                  <a:srgbClr val="16213A"/>
-                </a:solidFill>
-                <a:latin typeface="Calibri"/>
-              </a:defRPr>
-            </a:pPr>
-            <a:r>
-              <a:t>• Proveedor BSP habilitado</a:t>
+                  <a:srgbClr val="1C263C"/>
+                </a:solidFill>
+                <a:latin typeface="Calibri"/>
+              </a:defRPr>
+            </a:pPr>
+            <a:r>
+              <a:t>• Número verificado y plantillas de mensajes</a:t>
             </a:r>
           </a:p>
           <a:p>
             <a:pPr algn="l">
               <a:defRPr sz="1600" b="0" u="none">
                 <a:solidFill>
-                  <a:srgbClr val="16213A"/>
-                </a:solidFill>
-                <a:latin typeface="Calibri"/>
-              </a:defRPr>
-            </a:pPr>
-            <a:r>
-              <a:t>• Cloud Run para backend</a:t>
-            </a:r>
-          </a:p>
-          <a:p>
-            <a:pPr algn="l">
-              <a:defRPr sz="1600" b="0" u="none">
-                <a:solidFill>
-                  <a:srgbClr val="16213A"/>
-                </a:solidFill>
-                <a:latin typeface="Calibri"/>
-              </a:defRPr>
-            </a:pPr>
-            <a:r>
-              <a:t>• Monitoreo y seguridad</a:t>
+                  <a:srgbClr val="1C263C"/>
+                </a:solidFill>
+                <a:latin typeface="Calibri"/>
+              </a:defRPr>
+            </a:pPr>
+            <a:r>
+              <a:t>• Servidor en la nube 24/7 para continuidad</a:t>
             </a:r>
           </a:p>
         </p:txBody>
@@ -6129,14 +6179,6 @@
 <file path=ppt/slides/slide8.xml><?xml version="1.0" encoding="utf-8"?>
 <p:sld xmlns:a="http://schemas.openxmlformats.org/drawingml/2006/main" xmlns:p="http://schemas.openxmlformats.org/presentationml/2006/main" xmlns:r="http://schemas.openxmlformats.org/officeDocument/2006/relationships">
   <p:cSld>
-    <p:bg>
-      <p:bgPr>
-        <a:solidFill>
-          <a:srgbClr val="F5F8FE"/>
-        </a:solidFill>
-        <a:effectLst/>
-      </p:bgPr>
-    </p:bg>
     <p:spTree>
       <p:nvGrpSpPr>
         <p:cNvPr id="1" name=""/>
@@ -6144,22 +6186,46 @@
         <p:nvPr/>
       </p:nvGrpSpPr>
       <p:grpSpPr/>
-      <p:sp>
-        <p:nvSpPr>
-          <p:cNvPr id="2" name="Rectangle 1"/>
+      <p:pic>
+        <p:nvPicPr>
+          <p:cNvPr id="2" name="Picture 1" descr="chatbot-bg-2.jpg"/>
+          <p:cNvPicPr>
+            <a:picLocks noChangeAspect="1"/>
+          </p:cNvPicPr>
+          <p:nvPr/>
+        </p:nvPicPr>
+        <p:blipFill>
+          <a:blip r:embed="rId2"/>
+          <a:stretch>
+            <a:fillRect/>
+          </a:stretch>
+        </p:blipFill>
+        <p:spPr>
+          <a:xfrm>
+            <a:off x="0" y="0"/>
+            <a:ext cx="12191695" cy="6858000"/>
+          </a:xfrm>
+          <a:prstGeom prst="rect">
+            <a:avLst/>
+          </a:prstGeom>
+        </p:spPr>
+      </p:pic>
+      <p:sp>
+        <p:nvSpPr>
+          <p:cNvPr id="3" name="Rectangle 2"/>
           <p:cNvSpPr/>
           <p:nvPr/>
         </p:nvSpPr>
         <p:spPr>
           <a:xfrm>
             <a:off x="0" y="0"/>
-            <a:ext cx="12191695" cy="640080"/>
+            <a:ext cx="12191695" cy="6858000"/>
           </a:xfrm>
           <a:prstGeom prst="rect">
             <a:avLst/>
           </a:prstGeom>
           <a:solidFill>
-            <a:srgbClr val="143475"/>
+            <a:srgbClr val="070F1E"/>
           </a:solidFill>
           <a:ln>
             <a:noFill/>
@@ -6189,14 +6255,57 @@
       </p:sp>
       <p:sp>
         <p:nvSpPr>
-          <p:cNvPr id="3" name="TextBox 2"/>
+          <p:cNvPr id="4" name="Rectangle 3"/>
+          <p:cNvSpPr/>
+          <p:nvPr/>
+        </p:nvSpPr>
+        <p:spPr>
+          <a:xfrm>
+            <a:off x="0" y="0"/>
+            <a:ext cx="12191695" cy="621792"/>
+          </a:xfrm>
+          <a:prstGeom prst="rect">
+            <a:avLst/>
+          </a:prstGeom>
+          <a:solidFill>
+            <a:srgbClr val="133271"/>
+          </a:solidFill>
+          <a:ln>
+            <a:noFill/>
+          </a:ln>
+        </p:spPr>
+        <p:style>
+          <a:lnRef idx="1">
+            <a:schemeClr val="accent1"/>
+          </a:lnRef>
+          <a:fillRef idx="3">
+            <a:schemeClr val="accent1"/>
+          </a:fillRef>
+          <a:effectRef idx="2">
+            <a:schemeClr val="accent1"/>
+          </a:effectRef>
+          <a:fontRef idx="minor">
+            <a:schemeClr val="lt1"/>
+          </a:fontRef>
+        </p:style>
+        <p:txBody>
+          <a:bodyPr rtlCol="0" anchor="ctr"/>
+          <a:lstStyle/>
+          <a:p>
+            <a:pPr algn="ctr"/>
+          </a:p>
+        </p:txBody>
+      </p:sp>
+      <p:sp>
+        <p:nvSpPr>
+          <p:cNvPr id="5" name="TextBox 4"/>
           <p:cNvSpPr txBox="1"/>
           <p:nvPr/>
         </p:nvSpPr>
         <p:spPr>
           <a:xfrm>
             <a:off x="457200" y="109728"/>
-            <a:ext cx="6858000" cy="320040"/>
+            <a:ext cx="7132320" cy="320040"/>
           </a:xfrm>
           <a:prstGeom prst="rect">
             <a:avLst/>
@@ -6225,14 +6334,14 @@
       </p:sp>
       <p:sp>
         <p:nvSpPr>
-          <p:cNvPr id="4" name="TextBox 3"/>
+          <p:cNvPr id="6" name="TextBox 5"/>
           <p:cNvSpPr txBox="1"/>
           <p:nvPr/>
         </p:nvSpPr>
         <p:spPr>
           <a:xfrm>
-            <a:off x="731520" y="914400"/>
-            <a:ext cx="10789920" cy="1280160"/>
+            <a:off x="685800" y="868680"/>
+            <a:ext cx="10972800" cy="1234440"/>
           </a:xfrm>
           <a:prstGeom prst="rect">
             <a:avLst/>
@@ -6248,7 +6357,7 @@
             <a:pPr algn="l">
               <a:defRPr sz="3400" b="1" u="none">
                 <a:solidFill>
-                  <a:srgbClr val="143475"/>
+                  <a:srgbClr val="FFFFFF"/>
                 </a:solidFill>
                 <a:latin typeface="Calibri"/>
               </a:defRPr>
@@ -6261,27 +6370,27 @@
             <a:pPr algn="l">
               <a:defRPr sz="1800" b="0" u="none">
                 <a:solidFill>
-                  <a:srgbClr val="566177"/>
-                </a:solidFill>
-                <a:latin typeface="Calibri"/>
-              </a:defRPr>
-            </a:pPr>
-            <a:r>
-              <a:t>Referencia para 800 a 1000 consultas mensuales. Valores orientativos sujetos a uso y país.</a:t>
-            </a:r>
-          </a:p>
-        </p:txBody>
-      </p:sp>
-      <p:sp>
-        <p:nvSpPr>
-          <p:cNvPr id="5" name="Rounded Rectangle 4"/>
+                  <a:srgbClr val="E6ECF8"/>
+                </a:solidFill>
+                <a:latin typeface="Calibri"/>
+              </a:defRPr>
+            </a:pPr>
+            <a:r>
+              <a:t>Escenario de referencia: 800 a 1000 consultas mensuales.</a:t>
+            </a:r>
+          </a:p>
+        </p:txBody>
+      </p:sp>
+      <p:sp>
+        <p:nvSpPr>
+          <p:cNvPr id="7" name="Rounded Rectangle 6"/>
           <p:cNvSpPr/>
           <p:nvPr/>
         </p:nvSpPr>
         <p:spPr>
           <a:xfrm>
-            <a:off x="731520" y="2011680"/>
-            <a:ext cx="3429000" cy="3474720"/>
+            <a:off x="731520" y="1920240"/>
+            <a:ext cx="3429000" cy="3246120"/>
           </a:xfrm>
           <a:prstGeom prst="roundRect">
             <a:avLst/>
@@ -6291,7 +6400,7 @@
           </a:solidFill>
           <a:ln>
             <a:solidFill>
-              <a:srgbClr val="D8E2F3"/>
+              <a:srgbClr val="D2DDF0"/>
             </a:solidFill>
           </a:ln>
         </p:spPr>
@@ -6313,82 +6422,69 @@
           <a:bodyPr rtlCol="0" anchor="ctr" wrap="square"/>
           <a:lstStyle/>
           <a:p>
-            <a:pPr algn="ctr">
-              <a:defRPr sz="1800" b="1" u="none">
-                <a:solidFill>
-                  <a:srgbClr val="2D63D6"/>
-                </a:solidFill>
-                <a:latin typeface="Calibri"/>
-              </a:defRPr>
-            </a:pPr>
-            <a:r>
-              <a:t>Escenario base</a:t>
-            </a:r>
-          </a:p>
-          <a:p>
-            <a:pPr algn="ctr">
-              <a:defRPr sz="2200" b="1" u="none">
-                <a:solidFill>
-                  <a:srgbClr val="16213A"/>
-                </a:solidFill>
-                <a:latin typeface="Calibri"/>
-              </a:defRPr>
-            </a:pPr>
-            <a:r>
-              <a:t>USD 120 - 220 / mes</a:t>
-            </a:r>
-          </a:p>
-          <a:p>
-            <a:pPr algn="l">
-              <a:defRPr sz="1400" b="0" u="none">
-                <a:solidFill>
-                  <a:srgbClr val="16213A"/>
-                </a:solidFill>
-                <a:latin typeface="Calibri"/>
-              </a:defRPr>
-            </a:pPr>
-            <a:r>
-              <a:t>• Piloto controlado</a:t>
-            </a:r>
-          </a:p>
-          <a:p>
-            <a:pPr algn="l">
-              <a:defRPr sz="1400" b="0" u="none">
-                <a:solidFill>
-                  <a:srgbClr val="16213A"/>
-                </a:solidFill>
-                <a:latin typeface="Calibri"/>
-              </a:defRPr>
-            </a:pPr>
-            <a:r>
-              <a:t>• Volumen moderado</a:t>
-            </a:r>
-          </a:p>
-          <a:p>
-            <a:pPr algn="l">
-              <a:defRPr sz="1400" b="0" u="none">
-                <a:solidFill>
-                  <a:srgbClr val="16213A"/>
-                </a:solidFill>
-                <a:latin typeface="Calibri"/>
-              </a:defRPr>
-            </a:pPr>
-            <a:r>
-              <a:t>• Uso inicial de WhatsApp</a:t>
-            </a:r>
-          </a:p>
-        </p:txBody>
-      </p:sp>
-      <p:sp>
-        <p:nvSpPr>
-          <p:cNvPr id="6" name="Rounded Rectangle 5"/>
+            <a:pPr algn="l">
+              <a:defRPr sz="2000" b="1" u="none">
+                <a:solidFill>
+                  <a:srgbClr val="3168DA"/>
+                </a:solidFill>
+                <a:latin typeface="Calibri"/>
+              </a:defRPr>
+            </a:pPr>
+            <a:r>
+              <a:t>Infraestructura + datos</a:t>
+            </a:r>
+          </a:p>
+          <a:p>
+            <a:pPr algn="l">
+              <a:defRPr sz="1600" b="0" u="none">
+                <a:solidFill>
+                  <a:srgbClr val="1C263C"/>
+                </a:solidFill>
+                <a:latin typeface="Calibri"/>
+              </a:defRPr>
+            </a:pPr>
+            <a:r>
+              <a:t>• USD 30 - 90 / mes</a:t>
+            </a:r>
+          </a:p>
+          <a:p>
+            <a:pPr algn="l">
+              <a:defRPr sz="1600" b="0" u="none">
+                <a:solidFill>
+                  <a:srgbClr val="1C263C"/>
+                </a:solidFill>
+                <a:latin typeface="Calibri"/>
+              </a:defRPr>
+            </a:pPr>
+            <a:r>
+              <a:t>• Servidor cloud</a:t>
+            </a:r>
+          </a:p>
+          <a:p>
+            <a:pPr algn="l">
+              <a:defRPr sz="1600" b="0" u="none">
+                <a:solidFill>
+                  <a:srgbClr val="1C263C"/>
+                </a:solidFill>
+                <a:latin typeface="Calibri"/>
+              </a:defRPr>
+            </a:pPr>
+            <a:r>
+              <a:t>• Base de datos Firestore</a:t>
+            </a:r>
+          </a:p>
+        </p:txBody>
+      </p:sp>
+      <p:sp>
+        <p:nvSpPr>
+          <p:cNvPr id="8" name="Rounded Rectangle 7"/>
           <p:cNvSpPr/>
           <p:nvPr/>
         </p:nvSpPr>
         <p:spPr>
           <a:xfrm>
-            <a:off x="4389120" y="2011680"/>
-            <a:ext cx="3429000" cy="3474720"/>
+            <a:off x="4389120" y="1920240"/>
+            <a:ext cx="3429000" cy="3246120"/>
           </a:xfrm>
           <a:prstGeom prst="roundRect">
             <a:avLst/>
@@ -6398,7 +6494,7 @@
           </a:solidFill>
           <a:ln>
             <a:solidFill>
-              <a:srgbClr val="D8E2F3"/>
+              <a:srgbClr val="D2DDF0"/>
             </a:solidFill>
           </a:ln>
         </p:spPr>
@@ -6420,82 +6516,69 @@
           <a:bodyPr rtlCol="0" anchor="ctr" wrap="square"/>
           <a:lstStyle/>
           <a:p>
-            <a:pPr algn="ctr">
-              <a:defRPr sz="1800" b="1" u="none">
-                <a:solidFill>
-                  <a:srgbClr val="15946E"/>
-                </a:solidFill>
-                <a:latin typeface="Calibri"/>
-              </a:defRPr>
-            </a:pPr>
-            <a:r>
-              <a:t>Escenario objetivo</a:t>
-            </a:r>
-          </a:p>
-          <a:p>
-            <a:pPr algn="ctr">
-              <a:defRPr sz="2200" b="1" u="none">
-                <a:solidFill>
-                  <a:srgbClr val="16213A"/>
-                </a:solidFill>
-                <a:latin typeface="Calibri"/>
-              </a:defRPr>
-            </a:pPr>
-            <a:r>
-              <a:t>USD 220 - 380 / mes</a:t>
-            </a:r>
-          </a:p>
-          <a:p>
-            <a:pPr algn="l">
-              <a:defRPr sz="1400" b="0" u="none">
-                <a:solidFill>
-                  <a:srgbClr val="16213A"/>
-                </a:solidFill>
-                <a:latin typeface="Calibri"/>
-              </a:defRPr>
-            </a:pPr>
-            <a:r>
-              <a:t>• 800-1000 consultas/mes</a:t>
-            </a:r>
-          </a:p>
-          <a:p>
-            <a:pPr algn="l">
-              <a:defRPr sz="1400" b="0" u="none">
-                <a:solidFill>
-                  <a:srgbClr val="16213A"/>
-                </a:solidFill>
-                <a:latin typeface="Calibri"/>
-              </a:defRPr>
-            </a:pPr>
-            <a:r>
-              <a:t>• Operación continua</a:t>
-            </a:r>
-          </a:p>
-          <a:p>
-            <a:pPr algn="l">
-              <a:defRPr sz="1400" b="0" u="none">
-                <a:solidFill>
-                  <a:srgbClr val="16213A"/>
-                </a:solidFill>
-                <a:latin typeface="Calibri"/>
-              </a:defRPr>
-            </a:pPr>
-            <a:r>
-              <a:t>• RRHH + métricas completas</a:t>
-            </a:r>
-          </a:p>
-        </p:txBody>
-      </p:sp>
-      <p:sp>
-        <p:nvSpPr>
-          <p:cNvPr id="7" name="Rounded Rectangle 6"/>
+            <a:pPr algn="l">
+              <a:defRPr sz="2000" b="1" u="none">
+                <a:solidFill>
+                  <a:srgbClr val="189D75"/>
+                </a:solidFill>
+                <a:latin typeface="Calibri"/>
+              </a:defRPr>
+            </a:pPr>
+            <a:r>
+              <a:t>IA (Google)</a:t>
+            </a:r>
+          </a:p>
+          <a:p>
+            <a:pPr algn="l">
+              <a:defRPr sz="1600" b="0" u="none">
+                <a:solidFill>
+                  <a:srgbClr val="1C263C"/>
+                </a:solidFill>
+                <a:latin typeface="Calibri"/>
+              </a:defRPr>
+            </a:pPr>
+            <a:r>
+              <a:t>• USD 60 - 180 / mes</a:t>
+            </a:r>
+          </a:p>
+          <a:p>
+            <a:pPr algn="l">
+              <a:defRPr sz="1600" b="0" u="none">
+                <a:solidFill>
+                  <a:srgbClr val="1C263C"/>
+                </a:solidFill>
+                <a:latin typeface="Calibri"/>
+              </a:defRPr>
+            </a:pPr>
+            <a:r>
+              <a:t>• Uso de Gemini API</a:t>
+            </a:r>
+          </a:p>
+          <a:p>
+            <a:pPr algn="l">
+              <a:defRPr sz="1600" b="0" u="none">
+                <a:solidFill>
+                  <a:srgbClr val="1C263C"/>
+                </a:solidFill>
+                <a:latin typeface="Calibri"/>
+              </a:defRPr>
+            </a:pPr>
+            <a:r>
+              <a:t>• Varía por cantidad de consultas</a:t>
+            </a:r>
+          </a:p>
+        </p:txBody>
+      </p:sp>
+      <p:sp>
+        <p:nvSpPr>
+          <p:cNvPr id="9" name="Rounded Rectangle 8"/>
           <p:cNvSpPr/>
           <p:nvPr/>
         </p:nvSpPr>
         <p:spPr>
           <a:xfrm>
-            <a:off x="8046720" y="2011680"/>
-            <a:ext cx="3429000" cy="3474720"/>
+            <a:off x="8046720" y="1920240"/>
+            <a:ext cx="3429000" cy="3246120"/>
           </a:xfrm>
           <a:prstGeom prst="roundRect">
             <a:avLst/>
@@ -6505,7 +6588,7 @@
           </a:solidFill>
           <a:ln>
             <a:solidFill>
-              <a:srgbClr val="D8E2F3"/>
+              <a:srgbClr val="D2DDF0"/>
             </a:solidFill>
           </a:ln>
         </p:spPr>
@@ -6527,82 +6610,122 @@
           <a:bodyPr rtlCol="0" anchor="ctr" wrap="square"/>
           <a:lstStyle/>
           <a:p>
+            <a:pPr algn="l">
+              <a:defRPr sz="2000" b="1" u="none">
+                <a:solidFill>
+                  <a:srgbClr val="E89420"/>
+                </a:solidFill>
+                <a:latin typeface="Calibri"/>
+              </a:defRPr>
+            </a:pPr>
+            <a:r>
+              <a:t>WhatsApp Business</a:t>
+            </a:r>
+          </a:p>
+          <a:p>
+            <a:pPr algn="l">
+              <a:defRPr sz="1600" b="0" u="none">
+                <a:solidFill>
+                  <a:srgbClr val="1C263C"/>
+                </a:solidFill>
+                <a:latin typeface="Calibri"/>
+              </a:defRPr>
+            </a:pPr>
+            <a:r>
+              <a:t>• USD 80 - 250 / mes</a:t>
+            </a:r>
+          </a:p>
+          <a:p>
+            <a:pPr algn="l">
+              <a:defRPr sz="1600" b="0" u="none">
+                <a:solidFill>
+                  <a:srgbClr val="1C263C"/>
+                </a:solidFill>
+                <a:latin typeface="Calibri"/>
+              </a:defRPr>
+            </a:pPr>
+            <a:r>
+              <a:t>• Depende de conversaciones y país</a:t>
+            </a:r>
+          </a:p>
+          <a:p>
+            <a:pPr algn="l">
+              <a:defRPr sz="1600" b="0" u="none">
+                <a:solidFill>
+                  <a:srgbClr val="1C263C"/>
+                </a:solidFill>
+                <a:latin typeface="Calibri"/>
+              </a:defRPr>
+            </a:pPr>
+            <a:r>
+              <a:t>• Incluye proveedor oficial de canal</a:t>
+            </a:r>
+          </a:p>
+        </p:txBody>
+      </p:sp>
+      <p:sp>
+        <p:nvSpPr>
+          <p:cNvPr id="10" name="Rounded Rectangle 9"/>
+          <p:cNvSpPr/>
+          <p:nvPr/>
+        </p:nvSpPr>
+        <p:spPr>
+          <a:xfrm>
+            <a:off x="822960" y="5349240"/>
+            <a:ext cx="4754880" cy="566928"/>
+          </a:xfrm>
+          <a:prstGeom prst="roundRect">
+            <a:avLst/>
+          </a:prstGeom>
+          <a:solidFill>
+            <a:srgbClr val="133271"/>
+          </a:solidFill>
+          <a:ln>
+            <a:noFill/>
+          </a:ln>
+        </p:spPr>
+        <p:style>
+          <a:lnRef idx="1">
+            <a:schemeClr val="accent1"/>
+          </a:lnRef>
+          <a:fillRef idx="3">
+            <a:schemeClr val="accent1"/>
+          </a:fillRef>
+          <a:effectRef idx="2">
+            <a:schemeClr val="accent1"/>
+          </a:effectRef>
+          <a:fontRef idx="minor">
+            <a:schemeClr val="lt1"/>
+          </a:fontRef>
+        </p:style>
+        <p:txBody>
+          <a:bodyPr rtlCol="0" anchor="ctr" wrap="square"/>
+          <a:lstStyle/>
+          <a:p>
             <a:pPr algn="ctr">
-              <a:defRPr sz="1800" b="1" u="none">
-                <a:solidFill>
-                  <a:srgbClr val="E8931F"/>
-                </a:solidFill>
-                <a:latin typeface="Calibri"/>
-              </a:defRPr>
-            </a:pPr>
-            <a:r>
-              <a:t>Escenario escalado</a:t>
-            </a:r>
-          </a:p>
-          <a:p>
-            <a:pPr algn="ctr">
-              <a:defRPr sz="2200" b="1" u="none">
-                <a:solidFill>
-                  <a:srgbClr val="16213A"/>
-                </a:solidFill>
-                <a:latin typeface="Calibri"/>
-              </a:defRPr>
-            </a:pPr>
-            <a:r>
-              <a:t>USD 380 - 650 / mes</a:t>
-            </a:r>
-          </a:p>
-          <a:p>
-            <a:pPr algn="l">
-              <a:defRPr sz="1400" b="0" u="none">
-                <a:solidFill>
-                  <a:srgbClr val="16213A"/>
-                </a:solidFill>
-                <a:latin typeface="Calibri"/>
-              </a:defRPr>
-            </a:pPr>
-            <a:r>
-              <a:t>• Más empresas/sucursales</a:t>
-            </a:r>
-          </a:p>
-          <a:p>
-            <a:pPr algn="l">
-              <a:defRPr sz="1400" b="0" u="none">
-                <a:solidFill>
-                  <a:srgbClr val="16213A"/>
-                </a:solidFill>
-                <a:latin typeface="Calibri"/>
-              </a:defRPr>
-            </a:pPr>
-            <a:r>
-              <a:t>• Mayor tráfico</a:t>
-            </a:r>
-          </a:p>
-          <a:p>
-            <a:pPr algn="l">
-              <a:defRPr sz="1400" b="0" u="none">
-                <a:solidFill>
-                  <a:srgbClr val="16213A"/>
-                </a:solidFill>
-                <a:latin typeface="Calibri"/>
-              </a:defRPr>
-            </a:pPr>
-            <a:r>
-              <a:t>• Campañas y plantillas WhatsApp</a:t>
-            </a:r>
-          </a:p>
-        </p:txBody>
-      </p:sp>
-      <p:sp>
-        <p:nvSpPr>
-          <p:cNvPr id="8" name="TextBox 7"/>
+              <a:defRPr sz="1500" b="1" u="none">
+                <a:solidFill>
+                  <a:srgbClr val="FFFFFF"/>
+                </a:solidFill>
+                <a:latin typeface="Calibri"/>
+              </a:defRPr>
+            </a:pPr>
+            <a:r>
+              <a:t>Total estimado objetivo: USD 220 - 420 / mes | Recomendación inicial: USD 300 + 20% contingencia</a:t>
+            </a:r>
+          </a:p>
+        </p:txBody>
+      </p:sp>
+      <p:sp>
+        <p:nvSpPr>
+          <p:cNvPr id="11" name="TextBox 10"/>
           <p:cNvSpPr txBox="1"/>
           <p:nvPr/>
         </p:nvSpPr>
         <p:spPr>
           <a:xfrm>
-            <a:off x="822960" y="5669280"/>
-            <a:ext cx="10607040" cy="502920"/>
+            <a:off x="822960" y="5989320"/>
+            <a:ext cx="10607040" cy="411480"/>
           </a:xfrm>
           <a:prstGeom prst="rect">
             <a:avLst/>
@@ -6616,15 +6739,15 @@
           <a:lstStyle/>
           <a:p>
             <a:pPr algn="ctr">
-              <a:defRPr sz="1500" b="1" u="none">
-                <a:solidFill>
-                  <a:srgbClr val="143475"/>
-                </a:solidFill>
-                <a:latin typeface="Calibri"/>
-              </a:defRPr>
-            </a:pPr>
-            <a:r>
-              <a:t>Sugerencia de presupuesto inicial al comité: USD 300/mes + 20% de contingencia durante los primeros 90 días.</a:t>
+              <a:defRPr sz="1300" b="0" u="none">
+                <a:solidFill>
+                  <a:srgbClr val="FFFFFF"/>
+                </a:solidFill>
+                <a:latin typeface="Calibri"/>
+              </a:defRPr>
+            </a:pPr>
+            <a:r>
+              <a:t>Base del cálculo: tarifarios públicos de Meta/Google + estimación de consumo del piloto.</a:t>
             </a:r>
           </a:p>
         </p:txBody>
@@ -6640,14 +6763,6 @@
 <file path=ppt/slides/slide9.xml><?xml version="1.0" encoding="utf-8"?>
 <p:sld xmlns:a="http://schemas.openxmlformats.org/drawingml/2006/main" xmlns:p="http://schemas.openxmlformats.org/presentationml/2006/main" xmlns:r="http://schemas.openxmlformats.org/officeDocument/2006/relationships">
   <p:cSld>
-    <p:bg>
-      <p:bgPr>
-        <a:solidFill>
-          <a:srgbClr val="F5F8FE"/>
-        </a:solidFill>
-        <a:effectLst/>
-      </p:bgPr>
-    </p:bg>
     <p:spTree>
       <p:nvGrpSpPr>
         <p:cNvPr id="1" name=""/>
@@ -6655,22 +6770,46 @@
         <p:nvPr/>
       </p:nvGrpSpPr>
       <p:grpSpPr/>
-      <p:sp>
-        <p:nvSpPr>
-          <p:cNvPr id="2" name="Rectangle 1"/>
+      <p:pic>
+        <p:nvPicPr>
+          <p:cNvPr id="2" name="Picture 1" descr="chatbot-bg-3.jpg"/>
+          <p:cNvPicPr>
+            <a:picLocks noChangeAspect="1"/>
+          </p:cNvPicPr>
+          <p:nvPr/>
+        </p:nvPicPr>
+        <p:blipFill>
+          <a:blip r:embed="rId2"/>
+          <a:stretch>
+            <a:fillRect/>
+          </a:stretch>
+        </p:blipFill>
+        <p:spPr>
+          <a:xfrm>
+            <a:off x="0" y="0"/>
+            <a:ext cx="12191695" cy="6858000"/>
+          </a:xfrm>
+          <a:prstGeom prst="rect">
+            <a:avLst/>
+          </a:prstGeom>
+        </p:spPr>
+      </p:pic>
+      <p:sp>
+        <p:nvSpPr>
+          <p:cNvPr id="3" name="Rectangle 2"/>
           <p:cNvSpPr/>
           <p:nvPr/>
         </p:nvSpPr>
         <p:spPr>
           <a:xfrm>
             <a:off x="0" y="0"/>
-            <a:ext cx="12191695" cy="640080"/>
+            <a:ext cx="12191695" cy="6858000"/>
           </a:xfrm>
           <a:prstGeom prst="rect">
             <a:avLst/>
           </a:prstGeom>
           <a:solidFill>
-            <a:srgbClr val="143475"/>
+            <a:srgbClr val="070F1E"/>
           </a:solidFill>
           <a:ln>
             <a:noFill/>
@@ -6700,14 +6839,57 @@
       </p:sp>
       <p:sp>
         <p:nvSpPr>
-          <p:cNvPr id="3" name="TextBox 2"/>
+          <p:cNvPr id="4" name="Rectangle 3"/>
+          <p:cNvSpPr/>
+          <p:nvPr/>
+        </p:nvSpPr>
+        <p:spPr>
+          <a:xfrm>
+            <a:off x="0" y="0"/>
+            <a:ext cx="12191695" cy="621792"/>
+          </a:xfrm>
+          <a:prstGeom prst="rect">
+            <a:avLst/>
+          </a:prstGeom>
+          <a:solidFill>
+            <a:srgbClr val="133271"/>
+          </a:solidFill>
+          <a:ln>
+            <a:noFill/>
+          </a:ln>
+        </p:spPr>
+        <p:style>
+          <a:lnRef idx="1">
+            <a:schemeClr val="accent1"/>
+          </a:lnRef>
+          <a:fillRef idx="3">
+            <a:schemeClr val="accent1"/>
+          </a:fillRef>
+          <a:effectRef idx="2">
+            <a:schemeClr val="accent1"/>
+          </a:effectRef>
+          <a:fontRef idx="minor">
+            <a:schemeClr val="lt1"/>
+          </a:fontRef>
+        </p:style>
+        <p:txBody>
+          <a:bodyPr rtlCol="0" anchor="ctr"/>
+          <a:lstStyle/>
+          <a:p>
+            <a:pPr algn="ctr"/>
+          </a:p>
+        </p:txBody>
+      </p:sp>
+      <p:sp>
+        <p:nvSpPr>
+          <p:cNvPr id="5" name="TextBox 4"/>
           <p:cNvSpPr txBox="1"/>
           <p:nvPr/>
         </p:nvSpPr>
         <p:spPr>
           <a:xfrm>
             <a:off x="457200" y="109728"/>
-            <a:ext cx="6858000" cy="320040"/>
+            <a:ext cx="7132320" cy="320040"/>
           </a:xfrm>
           <a:prstGeom prst="rect">
             <a:avLst/>
@@ -6736,14 +6918,14 @@
       </p:sp>
       <p:sp>
         <p:nvSpPr>
-          <p:cNvPr id="4" name="TextBox 3"/>
+          <p:cNvPr id="6" name="TextBox 5"/>
           <p:cNvSpPr txBox="1"/>
           <p:nvPr/>
         </p:nvSpPr>
         <p:spPr>
           <a:xfrm>
-            <a:off x="731520" y="914400"/>
-            <a:ext cx="10789920" cy="1280160"/>
+            <a:off x="685800" y="868680"/>
+            <a:ext cx="10972800" cy="1234440"/>
           </a:xfrm>
           <a:prstGeom prst="rect">
             <a:avLst/>
@@ -6759,40 +6941,27 @@
             <a:pPr algn="l">
               <a:defRPr sz="3400" b="1" u="none">
                 <a:solidFill>
-                  <a:srgbClr val="143475"/>
-                </a:solidFill>
-                <a:latin typeface="Calibri"/>
-              </a:defRPr>
-            </a:pPr>
-            <a:r>
-              <a:t>Plan de implementación (90 días)</a:t>
-            </a:r>
-          </a:p>
-          <a:p>
-            <a:pPr algn="l">
-              <a:defRPr sz="1800" b="0" u="none">
-                <a:solidFill>
-                  <a:srgbClr val="566177"/>
-                </a:solidFill>
-                <a:latin typeface="Calibri"/>
-              </a:defRPr>
-            </a:pPr>
-            <a:r>
-              <a:t>Ejecución por etapas con hitos de negocio.</a:t>
-            </a:r>
-          </a:p>
-        </p:txBody>
-      </p:sp>
-      <p:sp>
-        <p:nvSpPr>
-          <p:cNvPr id="5" name="Rounded Rectangle 4"/>
+                  <a:srgbClr val="FFFFFF"/>
+                </a:solidFill>
+                <a:latin typeface="Calibri"/>
+              </a:defRPr>
+            </a:pPr>
+            <a:r>
+              <a:t>Decisión solicitada al Comité Ejecutivo</a:t>
+            </a:r>
+          </a:p>
+        </p:txBody>
+      </p:sp>
+      <p:sp>
+        <p:nvSpPr>
+          <p:cNvPr id="7" name="Rounded Rectangle 6"/>
           <p:cNvSpPr/>
           <p:nvPr/>
         </p:nvSpPr>
         <p:spPr>
           <a:xfrm>
-            <a:off x="777240" y="2011680"/>
-            <a:ext cx="3749039" cy="3566160"/>
+            <a:off x="731520" y="2011680"/>
+            <a:ext cx="5349240" cy="3657600"/>
           </a:xfrm>
           <a:prstGeom prst="roundRect">
             <a:avLst/>
@@ -6802,7 +6971,7 @@
           </a:solidFill>
           <a:ln>
             <a:solidFill>
-              <a:srgbClr val="D8E2F3"/>
+              <a:srgbClr val="D2DDF0"/>
             </a:solidFill>
           </a:ln>
         </p:spPr>
@@ -6827,66 +6996,79 @@
             <a:pPr algn="l">
               <a:defRPr sz="2000" b="1" u="none">
                 <a:solidFill>
-                  <a:srgbClr val="2D63D6"/>
-                </a:solidFill>
-                <a:latin typeface="Calibri"/>
-              </a:defRPr>
-            </a:pPr>
-            <a:r>
-              <a:t>Fase 1 (0-30 días)</a:t>
+                  <a:srgbClr val="E89420"/>
+                </a:solidFill>
+                <a:latin typeface="Calibri"/>
+              </a:defRPr>
+            </a:pPr>
+            <a:r>
+              <a:t>Aprobaciones requeridas</a:t>
             </a:r>
           </a:p>
           <a:p>
             <a:pPr algn="l">
               <a:defRPr sz="1600" b="0" u="none">
                 <a:solidFill>
-                  <a:srgbClr val="16213A"/>
-                </a:solidFill>
-                <a:latin typeface="Calibri"/>
-              </a:defRPr>
-            </a:pPr>
-            <a:r>
-              <a:t>• Ajustes finales del chatbot</a:t>
+                  <a:srgbClr val="1C263C"/>
+                </a:solidFill>
+                <a:latin typeface="Calibri"/>
+              </a:defRPr>
+            </a:pPr>
+            <a:r>
+              <a:t>• Presupuesto mensual inicial para operación.</a:t>
             </a:r>
           </a:p>
           <a:p>
             <a:pPr algn="l">
               <a:defRPr sz="1600" b="0" u="none">
                 <a:solidFill>
-                  <a:srgbClr val="16213A"/>
-                </a:solidFill>
-                <a:latin typeface="Calibri"/>
-              </a:defRPr>
-            </a:pPr>
-            <a:r>
-              <a:t>• Validación de métricas</a:t>
+                  <a:srgbClr val="1C263C"/>
+                </a:solidFill>
+                <a:latin typeface="Calibri"/>
+              </a:defRPr>
+            </a:pPr>
+            <a:r>
+              <a:t>• Habilitación de cuentas Google para base de datos e IA.</a:t>
             </a:r>
           </a:p>
           <a:p>
             <a:pPr algn="l">
               <a:defRPr sz="1600" b="0" u="none">
                 <a:solidFill>
-                  <a:srgbClr val="16213A"/>
-                </a:solidFill>
-                <a:latin typeface="Calibri"/>
-              </a:defRPr>
-            </a:pPr>
-            <a:r>
-              <a:t>• Prueba controlada</a:t>
-            </a:r>
-          </a:p>
-        </p:txBody>
-      </p:sp>
-      <p:sp>
-        <p:nvSpPr>
-          <p:cNvPr id="6" name="Rounded Rectangle 5"/>
+                  <a:srgbClr val="1C263C"/>
+                </a:solidFill>
+                <a:latin typeface="Calibri"/>
+              </a:defRPr>
+            </a:pPr>
+            <a:r>
+              <a:t>• Alta del canal oficial de WhatsApp Business.</a:t>
+            </a:r>
+          </a:p>
+          <a:p>
+            <a:pPr algn="l">
+              <a:defRPr sz="1600" b="0" u="none">
+                <a:solidFill>
+                  <a:srgbClr val="1C263C"/>
+                </a:solidFill>
+                <a:latin typeface="Calibri"/>
+              </a:defRPr>
+            </a:pPr>
+            <a:r>
+              <a:t>• Asignación de responsable interno (RRHH + IT).</a:t>
+            </a:r>
+          </a:p>
+        </p:txBody>
+      </p:sp>
+      <p:sp>
+        <p:nvSpPr>
+          <p:cNvPr id="8" name="Rounded Rectangle 7"/>
           <p:cNvSpPr/>
           <p:nvPr/>
         </p:nvSpPr>
         <p:spPr>
           <a:xfrm>
-            <a:off x="4617720" y="2011680"/>
-            <a:ext cx="3749039" cy="3566160"/>
+            <a:off x="6126480" y="2011680"/>
+            <a:ext cx="5349240" cy="3657600"/>
           </a:xfrm>
           <a:prstGeom prst="roundRect">
             <a:avLst/>
@@ -6896,7 +7078,7 @@
           </a:solidFill>
           <a:ln>
             <a:solidFill>
-              <a:srgbClr val="D8E2F3"/>
+              <a:srgbClr val="D2DDF0"/>
             </a:solidFill>
           </a:ln>
         </p:spPr>
@@ -6921,146 +7103,65 @@
             <a:pPr algn="l">
               <a:defRPr sz="2000" b="1" u="none">
                 <a:solidFill>
-                  <a:srgbClr val="2D63D6"/>
-                </a:solidFill>
-                <a:latin typeface="Calibri"/>
-              </a:defRPr>
-            </a:pPr>
-            <a:r>
-              <a:t>Fase 2 (31-60 días)</a:t>
+                  <a:srgbClr val="189D75"/>
+                </a:solidFill>
+                <a:latin typeface="Calibri"/>
+              </a:defRPr>
+            </a:pPr>
+            <a:r>
+              <a:t>Resultado esperado</a:t>
             </a:r>
           </a:p>
           <a:p>
             <a:pPr algn="l">
               <a:defRPr sz="1600" b="0" u="none">
                 <a:solidFill>
-                  <a:srgbClr val="16213A"/>
-                </a:solidFill>
-                <a:latin typeface="Calibri"/>
-              </a:defRPr>
-            </a:pPr>
-            <a:r>
-              <a:t>• Integración WhatsApp</a:t>
+                  <a:srgbClr val="1C263C"/>
+                </a:solidFill>
+                <a:latin typeface="Calibri"/>
+              </a:defRPr>
+            </a:pPr>
+            <a:r>
+              <a:t>• Mejor experiencia del colaborador.</a:t>
             </a:r>
           </a:p>
           <a:p>
             <a:pPr algn="l">
               <a:defRPr sz="1600" b="0" u="none">
                 <a:solidFill>
-                  <a:srgbClr val="16213A"/>
-                </a:solidFill>
-                <a:latin typeface="Calibri"/>
-              </a:defRPr>
-            </a:pPr>
-            <a:r>
-              <a:t>• Capacitación de RRHH</a:t>
+                  <a:srgbClr val="1C263C"/>
+                </a:solidFill>
+                <a:latin typeface="Calibri"/>
+              </a:defRPr>
+            </a:pPr>
+            <a:r>
+              <a:t>• Reducción de carga operativa de RRHH.</a:t>
             </a:r>
           </a:p>
           <a:p>
             <a:pPr algn="l">
               <a:defRPr sz="1600" b="0" u="none">
                 <a:solidFill>
-                  <a:srgbClr val="16213A"/>
-                </a:solidFill>
-                <a:latin typeface="Calibri"/>
-              </a:defRPr>
-            </a:pPr>
-            <a:r>
-              <a:t>• Inicio operación asistida</a:t>
-            </a:r>
-          </a:p>
-        </p:txBody>
-      </p:sp>
-      <p:sp>
-        <p:nvSpPr>
-          <p:cNvPr id="7" name="Rounded Rectangle 6"/>
-          <p:cNvSpPr/>
-          <p:nvPr/>
-        </p:nvSpPr>
-        <p:spPr>
-          <a:xfrm>
-            <a:off x="8458200" y="2011680"/>
-            <a:ext cx="3749039" cy="3566160"/>
-          </a:xfrm>
-          <a:prstGeom prst="roundRect">
-            <a:avLst/>
-          </a:prstGeom>
-          <a:solidFill>
-            <a:srgbClr val="FFFFFF"/>
-          </a:solidFill>
-          <a:ln>
-            <a:solidFill>
-              <a:srgbClr val="D8E2F3"/>
-            </a:solidFill>
-          </a:ln>
-        </p:spPr>
-        <p:style>
-          <a:lnRef idx="1">
-            <a:schemeClr val="accent1"/>
-          </a:lnRef>
-          <a:fillRef idx="3">
-            <a:schemeClr val="accent1"/>
-          </a:fillRef>
-          <a:effectRef idx="2">
-            <a:schemeClr val="accent1"/>
-          </a:effectRef>
-          <a:fontRef idx="minor">
-            <a:schemeClr val="lt1"/>
-          </a:fontRef>
-        </p:style>
-        <p:txBody>
-          <a:bodyPr rtlCol="0" anchor="ctr" wrap="square"/>
-          <a:lstStyle/>
-          <a:p>
-            <a:pPr algn="l">
-              <a:defRPr sz="2000" b="1" u="none">
-                <a:solidFill>
-                  <a:srgbClr val="2D63D6"/>
-                </a:solidFill>
-                <a:latin typeface="Calibri"/>
-              </a:defRPr>
-            </a:pPr>
-            <a:r>
-              <a:t>Fase 3 (61-90 días)</a:t>
+                  <a:srgbClr val="1C263C"/>
+                </a:solidFill>
+                <a:latin typeface="Calibri"/>
+              </a:defRPr>
+            </a:pPr>
+            <a:r>
+              <a:t>• Mayor trazabilidad y control de gestión.</a:t>
             </a:r>
           </a:p>
           <a:p>
             <a:pPr algn="l">
               <a:defRPr sz="1600" b="0" u="none">
                 <a:solidFill>
-                  <a:srgbClr val="16213A"/>
-                </a:solidFill>
-                <a:latin typeface="Calibri"/>
-              </a:defRPr>
-            </a:pPr>
-            <a:r>
-              <a:t>• Escalado por empresa/sucursal</a:t>
-            </a:r>
-          </a:p>
-          <a:p>
-            <a:pPr algn="l">
-              <a:defRPr sz="1600" b="0" u="none">
-                <a:solidFill>
-                  <a:srgbClr val="16213A"/>
-                </a:solidFill>
-                <a:latin typeface="Calibri"/>
-              </a:defRPr>
-            </a:pPr>
-            <a:r>
-              <a:t>• Optimización de costos</a:t>
-            </a:r>
-          </a:p>
-          <a:p>
-            <a:pPr algn="l">
-              <a:defRPr sz="1600" b="0" u="none">
-                <a:solidFill>
-                  <a:srgbClr val="16213A"/>
-                </a:solidFill>
-                <a:latin typeface="Calibri"/>
-              </a:defRPr>
-            </a:pPr>
-            <a:r>
-              <a:t>• KPIs para comité</a:t>
+                  <a:srgbClr val="1C263C"/>
+                </a:solidFill>
+                <a:latin typeface="Calibri"/>
+              </a:defRPr>
+            </a:pPr>
+            <a:r>
+              <a:t>• Escalabilidad a nuevas empresas/sucursales.</a:t>
             </a:r>
           </a:p>
         </p:txBody>

</xml_diff>

<commit_message>
docs: expand cost breakdown and clarify production needs in deck
Co-authored-by: deboraq <deboraq@users.noreply.github.com>
</commit_message>
<xml_diff>
--- a/docs/Presentacion_Chatbot_RRHH_Bacar.pptx
+++ b/docs/Presentacion_Chatbot_RRHH_Bacar.pptx
@@ -6363,7 +6363,7 @@
               </a:defRPr>
             </a:pPr>
             <a:r>
-              <a:t>Inversión mensual estimada (USD)</a:t>
+              <a:t>Detalle de costos mensuales estimados (USD)</a:t>
             </a:r>
           </a:p>
           <a:p>
@@ -6376,7 +6376,7 @@
               </a:defRPr>
             </a:pPr>
             <a:r>
-              <a:t>Escenario de referencia: 800 a 1000 consultas mensuales.</a:t>
+              <a:t>Referencia: 800 a 1000 consultas/mes en Argentina.</a:t>
             </a:r>
           </a:p>
         </p:txBody>
@@ -6389,8 +6389,8 @@
         </p:nvSpPr>
         <p:spPr>
           <a:xfrm>
-            <a:off x="731520" y="1920240"/>
-            <a:ext cx="3429000" cy="3246120"/>
+            <a:off x="731520" y="1828800"/>
+            <a:ext cx="3429000" cy="3429000"/>
           </a:xfrm>
           <a:prstGeom prst="roundRect">
             <a:avLst/>
@@ -6457,7 +6457,7 @@
               </a:defRPr>
             </a:pPr>
             <a:r>
-              <a:t>• Servidor cloud</a:t>
+              <a:t>• Servidor cloud 24/7</a:t>
             </a:r>
           </a:p>
           <a:p>
@@ -6471,6 +6471,19 @@
             </a:pPr>
             <a:r>
               <a:t>• Base de datos Firestore</a:t>
+            </a:r>
+          </a:p>
+          <a:p>
+            <a:pPr algn="l">
+              <a:defRPr sz="1600" b="0" u="none">
+                <a:solidFill>
+                  <a:srgbClr val="1C263C"/>
+                </a:solidFill>
+                <a:latin typeface="Calibri"/>
+              </a:defRPr>
+            </a:pPr>
+            <a:r>
+              <a:t>• Operación base del backend</a:t>
             </a:r>
           </a:p>
         </p:txBody>
@@ -6483,8 +6496,8 @@
         </p:nvSpPr>
         <p:spPr>
           <a:xfrm>
-            <a:off x="4389120" y="1920240"/>
-            <a:ext cx="3429000" cy="3246120"/>
+            <a:off x="4389120" y="1828800"/>
+            <a:ext cx="3429000" cy="3429000"/>
           </a:xfrm>
           <a:prstGeom prst="roundRect">
             <a:avLst/>
@@ -6551,7 +6564,7 @@
               </a:defRPr>
             </a:pPr>
             <a:r>
-              <a:t>• Uso de Gemini API</a:t>
+              <a:t>• AI Studio para pruebas</a:t>
             </a:r>
           </a:p>
           <a:p>
@@ -6564,7 +6577,20 @@
               </a:defRPr>
             </a:pPr>
             <a:r>
-              <a:t>• Varía por cantidad de consultas</a:t>
+              <a:t>• Gemini API para producción</a:t>
+            </a:r>
+          </a:p>
+          <a:p>
+            <a:pPr algn="l">
+              <a:defRPr sz="1600" b="0" u="none">
+                <a:solidFill>
+                  <a:srgbClr val="1C263C"/>
+                </a:solidFill>
+                <a:latin typeface="Calibri"/>
+              </a:defRPr>
+            </a:pPr>
+            <a:r>
+              <a:t>• Costo según consumo real</a:t>
             </a:r>
           </a:p>
         </p:txBody>
@@ -6577,8 +6603,8 @@
         </p:nvSpPr>
         <p:spPr>
           <a:xfrm>
-            <a:off x="8046720" y="1920240"/>
-            <a:ext cx="3429000" cy="3246120"/>
+            <a:off x="8046720" y="1828800"/>
+            <a:ext cx="3429000" cy="3429000"/>
           </a:xfrm>
           <a:prstGeom prst="roundRect">
             <a:avLst/>
@@ -6619,7 +6645,7 @@
               </a:defRPr>
             </a:pPr>
             <a:r>
-              <a:t>WhatsApp Business</a:t>
+              <a:t>WhatsApp Business (AR)</a:t>
             </a:r>
           </a:p>
           <a:p>
@@ -6645,7 +6671,7 @@
               </a:defRPr>
             </a:pPr>
             <a:r>
-              <a:t>• Depende de conversaciones y país</a:t>
+              <a:t>• Meta cobra por conversación</a:t>
             </a:r>
           </a:p>
           <a:p>
@@ -6658,7 +6684,20 @@
               </a:defRPr>
             </a:pPr>
             <a:r>
-              <a:t>• Incluye proveedor oficial de canal</a:t>
+              <a:t>• Se suma proveedor oficial</a:t>
+            </a:r>
+          </a:p>
+          <a:p>
+            <a:pPr algn="l">
+              <a:defRPr sz="1600" b="0" u="none">
+                <a:solidFill>
+                  <a:srgbClr val="1C263C"/>
+                </a:solidFill>
+                <a:latin typeface="Calibri"/>
+              </a:defRPr>
+            </a:pPr>
+            <a:r>
+              <a:t>• Puede incluir impuestos locales</a:t>
             </a:r>
           </a:p>
         </p:txBody>
@@ -6671,7 +6710,75 @@
         </p:nvSpPr>
         <p:spPr>
           <a:xfrm>
-            <a:off x="822960" y="5349240"/>
+            <a:off x="731520" y="5440680"/>
+            <a:ext cx="3931920" cy="1097280"/>
+          </a:xfrm>
+          <a:prstGeom prst="roundRect">
+            <a:avLst/>
+          </a:prstGeom>
+          <a:solidFill>
+            <a:srgbClr val="FFFFFF"/>
+          </a:solidFill>
+          <a:ln>
+            <a:solidFill>
+              <a:srgbClr val="D2DDF0"/>
+            </a:solidFill>
+          </a:ln>
+        </p:spPr>
+        <p:style>
+          <a:lnRef idx="1">
+            <a:schemeClr val="accent1"/>
+          </a:lnRef>
+          <a:fillRef idx="3">
+            <a:schemeClr val="accent1"/>
+          </a:fillRef>
+          <a:effectRef idx="2">
+            <a:schemeClr val="accent1"/>
+          </a:effectRef>
+          <a:fontRef idx="minor">
+            <a:schemeClr val="lt1"/>
+          </a:fontRef>
+        </p:style>
+        <p:txBody>
+          <a:bodyPr rtlCol="0" anchor="ctr" wrap="square"/>
+          <a:lstStyle/>
+          <a:p>
+            <a:pPr algn="l">
+              <a:defRPr sz="2000" b="1" u="none">
+                <a:solidFill>
+                  <a:srgbClr val="3168DA"/>
+                </a:solidFill>
+                <a:latin typeface="Calibri"/>
+              </a:defRPr>
+            </a:pPr>
+            <a:r>
+              <a:t>Monitoreo y alertas</a:t>
+            </a:r>
+          </a:p>
+          <a:p>
+            <a:pPr algn="l">
+              <a:defRPr sz="1600" b="0" u="none">
+                <a:solidFill>
+                  <a:srgbClr val="1C263C"/>
+                </a:solidFill>
+                <a:latin typeface="Calibri"/>
+              </a:defRPr>
+            </a:pPr>
+            <a:r>
+              <a:t>• USD 0 - 20 / mes | logs, alertas y salud del servicio</a:t>
+            </a:r>
+          </a:p>
+        </p:txBody>
+      </p:sp>
+      <p:sp>
+        <p:nvSpPr>
+          <p:cNvPr id="11" name="Rounded Rectangle 10"/>
+          <p:cNvSpPr/>
+          <p:nvPr/>
+        </p:nvSpPr>
+        <p:spPr>
+          <a:xfrm>
+            <a:off x="4892040" y="5669280"/>
             <a:ext cx="4754880" cy="566928"/>
           </a:xfrm>
           <a:prstGeom prst="roundRect">
@@ -6711,21 +6818,21 @@
               </a:defRPr>
             </a:pPr>
             <a:r>
-              <a:t>Total estimado objetivo: USD 220 - 420 / mes | Recomendación inicial: USD 300 + 20% contingencia</a:t>
-            </a:r>
-          </a:p>
-        </p:txBody>
-      </p:sp>
-      <p:sp>
-        <p:nvSpPr>
-          <p:cNvPr id="11" name="TextBox 10"/>
+              <a:t>Total objetivo: USD 220 - 420 / mes | Presupuesto sugerido: USD 300 + 20% contingencia</a:t>
+            </a:r>
+          </a:p>
+        </p:txBody>
+      </p:sp>
+      <p:sp>
+        <p:nvSpPr>
+          <p:cNvPr id="12" name="TextBox 11"/>
           <p:cNvSpPr txBox="1"/>
           <p:nvPr/>
         </p:nvSpPr>
         <p:spPr>
           <a:xfrm>
-            <a:off x="822960" y="5989320"/>
-            <a:ext cx="10607040" cy="411480"/>
+            <a:off x="822960" y="6400800"/>
+            <a:ext cx="10607040" cy="274320"/>
           </a:xfrm>
           <a:prstGeom prst="rect">
             <a:avLst/>
@@ -6739,7 +6846,7 @@
           <a:lstStyle/>
           <a:p>
             <a:pPr algn="ctr">
-              <a:defRPr sz="1300" b="0" u="none">
+              <a:defRPr sz="1200" b="0" u="none">
                 <a:solidFill>
                   <a:srgbClr val="FFFFFF"/>
                 </a:solidFill>
@@ -6747,7 +6854,7 @@
               </a:defRPr>
             </a:pPr>
             <a:r>
-              <a:t>Base del cálculo: tarifarios públicos de Meta/Google + estimación de consumo del piloto.</a:t>
+              <a:t>Base: tarifarios públicos Meta/Google + estimación de consumo esperado del piloto.</a:t>
             </a:r>
           </a:p>
         </p:txBody>
@@ -6960,7 +7067,7 @@
         </p:nvSpPr>
         <p:spPr>
           <a:xfrm>
-            <a:off x="731520" y="2011680"/>
+            <a:off x="822960" y="2011680"/>
             <a:ext cx="5349240" cy="3657600"/>
           </a:xfrm>
           <a:prstGeom prst="roundRect">

</xml_diff>

<commit_message>
docs: make cover image prominent and lighten slide backgrounds
Co-authored-by: deboraq <deboraq@users.noreply.github.com>
</commit_message>
<xml_diff>
--- a/docs/Presentacion_Chatbot_RRHH_Bacar.pptx
+++ b/docs/Presentacion_Chatbot_RRHH_Bacar.pptx
@@ -3242,16 +3242,83 @@
           </a:p>
         </p:txBody>
       </p:sp>
-      <p:sp>
-        <p:nvSpPr>
-          <p:cNvPr id="6" name="TextBox 5"/>
+      <p:pic>
+        <p:nvPicPr>
+          <p:cNvPr id="6" name="Picture 5" descr="chatbot-bg-1.jpg"/>
+          <p:cNvPicPr>
+            <a:picLocks noChangeAspect="1"/>
+          </p:cNvPicPr>
+          <p:nvPr/>
+        </p:nvPicPr>
+        <p:blipFill>
+          <a:blip r:embed="rId2"/>
+          <a:stretch>
+            <a:fillRect/>
+          </a:stretch>
+        </p:blipFill>
+        <p:spPr>
+          <a:xfrm>
+            <a:off x="6492240" y="1051560"/>
+            <a:ext cx="5212080" cy="5394960"/>
+          </a:xfrm>
+          <a:prstGeom prst="rect">
+            <a:avLst/>
+          </a:prstGeom>
+        </p:spPr>
+      </p:pic>
+      <p:sp>
+        <p:nvSpPr>
+          <p:cNvPr id="7" name="Rounded Rectangle 6"/>
+          <p:cNvSpPr/>
+          <p:nvPr/>
+        </p:nvSpPr>
+        <p:spPr>
+          <a:xfrm>
+            <a:off x="6492240" y="1051560"/>
+            <a:ext cx="5212080" cy="5394960"/>
+          </a:xfrm>
+          <a:prstGeom prst="roundRect">
+            <a:avLst/>
+          </a:prstGeom>
+          <a:noFill/>
+          <a:ln w="17780">
+            <a:solidFill>
+              <a:srgbClr val="FFFFFF"/>
+            </a:solidFill>
+          </a:ln>
+        </p:spPr>
+        <p:style>
+          <a:lnRef idx="1">
+            <a:schemeClr val="accent1"/>
+          </a:lnRef>
+          <a:fillRef idx="3">
+            <a:schemeClr val="accent1"/>
+          </a:fillRef>
+          <a:effectRef idx="2">
+            <a:schemeClr val="accent1"/>
+          </a:effectRef>
+          <a:fontRef idx="minor">
+            <a:schemeClr val="lt1"/>
+          </a:fontRef>
+        </p:style>
+        <p:txBody>
+          <a:bodyPr rtlCol="0" anchor="ctr"/>
+          <a:lstStyle/>
+          <a:p>
+            <a:pPr algn="ctr"/>
+          </a:p>
+        </p:txBody>
+      </p:sp>
+      <p:sp>
+        <p:nvSpPr>
+          <p:cNvPr id="8" name="TextBox 7"/>
           <p:cNvSpPr txBox="1"/>
           <p:nvPr/>
         </p:nvSpPr>
         <p:spPr>
           <a:xfrm>
-            <a:off x="685800" y="1280160"/>
-            <a:ext cx="10972800" cy="1234440"/>
+            <a:off x="777240" y="1234440"/>
+            <a:ext cx="5486400" cy="1234440"/>
           </a:xfrm>
           <a:prstGeom prst="rect">
             <a:avLst/>
@@ -3293,14 +3360,14 @@
       </p:sp>
       <p:sp>
         <p:nvSpPr>
-          <p:cNvPr id="7" name="Rounded Rectangle 6"/>
+          <p:cNvPr id="9" name="Rounded Rectangle 8"/>
           <p:cNvSpPr/>
           <p:nvPr/>
         </p:nvSpPr>
         <p:spPr>
           <a:xfrm>
-            <a:off x="777240" y="2651760"/>
-            <a:ext cx="10652760" cy="1828800"/>
+            <a:off x="777240" y="2514600"/>
+            <a:ext cx="5486400" cy="2148840"/>
           </a:xfrm>
           <a:prstGeom prst="roundRect">
             <a:avLst/>
@@ -3387,13 +3454,13 @@
       </p:sp>
       <p:sp>
         <p:nvSpPr>
-          <p:cNvPr id="8" name="Rounded Rectangle 7"/>
+          <p:cNvPr id="10" name="Rounded Rectangle 9"/>
           <p:cNvSpPr/>
           <p:nvPr/>
         </p:nvSpPr>
         <p:spPr>
           <a:xfrm>
-            <a:off x="822960" y="4892040"/>
+            <a:off x="822960" y="5074920"/>
             <a:ext cx="4754880" cy="566928"/>
           </a:xfrm>
           <a:prstGeom prst="roundRect">

</xml_diff>

<commit_message>
Mejoras: panel RRHH (empresa/sucursal/area), recuperar contraseña por email, SMTP, login sin sucursales, sidebar modulos, estilos y docs
Made-with: Cursor
</commit_message>
<xml_diff>
--- a/docs/Presentacion_Chatbot_RRHH_Bacar.pptx
+++ b/docs/Presentacion_Chatbot_RRHH_Bacar.pptx
@@ -5,17 +5,17 @@
     <p:sldMasterId id="2147483648" r:id="rId1"/>
   </p:sldMasterIdLst>
   <p:sldIdLst>
-    <p:sldId id="256" r:id="rId7"/>
-    <p:sldId id="257" r:id="rId8"/>
-    <p:sldId id="258" r:id="rId9"/>
-    <p:sldId id="259" r:id="rId10"/>
-    <p:sldId id="260" r:id="rId11"/>
-    <p:sldId id="261" r:id="rId12"/>
-    <p:sldId id="262" r:id="rId13"/>
-    <p:sldId id="263" r:id="rId14"/>
-    <p:sldId id="264" r:id="rId15"/>
+    <p:sldId id="256" r:id="rId2"/>
+    <p:sldId id="257" r:id="rId3"/>
+    <p:sldId id="258" r:id="rId4"/>
+    <p:sldId id="259" r:id="rId5"/>
+    <p:sldId id="260" r:id="rId6"/>
+    <p:sldId id="261" r:id="rId7"/>
+    <p:sldId id="262" r:id="rId8"/>
+    <p:sldId id="263" r:id="rId9"/>
+    <p:sldId id="264" r:id="rId10"/>
   </p:sldIdLst>
-  <p:sldSz cx="12191695" cy="6858000" type="screen4x3"/>
+  <p:sldSz cx="12192000" cy="6858000"/>
   <p:notesSz cx="6858000" cy="9144000"/>
   <p:defaultTextStyle>
     <a:defPPr>
@@ -112,6 +112,22 @@
       </a:defRPr>
     </a:lvl9pPr>
   </p:defaultTextStyle>
+  <p:extLst>
+    <p:ext uri="{EFAFB233-063F-42B5-8137-9DF3F51BA10A}">
+      <p15:sldGuideLst xmlns:p15="http://schemas.microsoft.com/office/powerpoint/2012/main">
+        <p15:guide id="1" orient="horz" pos="2160">
+          <p15:clr>
+            <a:srgbClr val="A4A3A4"/>
+          </p15:clr>
+        </p15:guide>
+        <p15:guide id="2" pos="2880">
+          <p15:clr>
+            <a:srgbClr val="A4A3A4"/>
+          </p15:clr>
+        </p15:guide>
+      </p15:sldGuideLst>
+    </p:ext>
+  </p:extLst>
 </p:presentation>
 </file>
 
@@ -296,7 +312,7 @@
           <a:p>
             <a:fld id="{5BCAD085-E8A6-8845-BD4E-CB4CCA059FC4}" type="datetimeFigureOut">
               <a:rPr lang="en-US" smtClean="0"/>
-              <a:t>1/27/13</a:t>
+              <a:t>2/20/2026</a:t>
             </a:fld>
             <a:endParaRPr lang="en-US"/>
           </a:p>
@@ -338,7 +354,7 @@
           <a:p>
             <a:fld id="{C1FF6DA9-008F-8B48-92A6-B652298478BF}" type="slidenum">
               <a:rPr lang="en-US" smtClean="0"/>
-              <a:t>‹#›</a:t>
+              <a:t>‹Nº›</a:t>
             </a:fld>
             <a:endParaRPr lang="en-US"/>
           </a:p>
@@ -466,7 +482,7 @@
           <a:p>
             <a:fld id="{5BCAD085-E8A6-8845-BD4E-CB4CCA059FC4}" type="datetimeFigureOut">
               <a:rPr lang="en-US" smtClean="0"/>
-              <a:t>1/27/13</a:t>
+              <a:t>2/20/2026</a:t>
             </a:fld>
             <a:endParaRPr lang="en-US"/>
           </a:p>
@@ -508,7 +524,7 @@
           <a:p>
             <a:fld id="{C1FF6DA9-008F-8B48-92A6-B652298478BF}" type="slidenum">
               <a:rPr lang="en-US" smtClean="0"/>
-              <a:t>‹#›</a:t>
+              <a:t>‹Nº›</a:t>
             </a:fld>
             <a:endParaRPr lang="en-US"/>
           </a:p>
@@ -646,7 +662,7 @@
           <a:p>
             <a:fld id="{5BCAD085-E8A6-8845-BD4E-CB4CCA059FC4}" type="datetimeFigureOut">
               <a:rPr lang="en-US" smtClean="0"/>
-              <a:t>1/27/13</a:t>
+              <a:t>2/20/2026</a:t>
             </a:fld>
             <a:endParaRPr lang="en-US"/>
           </a:p>
@@ -688,7 +704,7 @@
           <a:p>
             <a:fld id="{C1FF6DA9-008F-8B48-92A6-B652298478BF}" type="slidenum">
               <a:rPr lang="en-US" smtClean="0"/>
-              <a:t>‹#›</a:t>
+              <a:t>‹Nº›</a:t>
             </a:fld>
             <a:endParaRPr lang="en-US"/>
           </a:p>
@@ -816,7 +832,7 @@
           <a:p>
             <a:fld id="{5BCAD085-E8A6-8845-BD4E-CB4CCA059FC4}" type="datetimeFigureOut">
               <a:rPr lang="en-US" smtClean="0"/>
-              <a:t>1/27/13</a:t>
+              <a:t>2/20/2026</a:t>
             </a:fld>
             <a:endParaRPr lang="en-US"/>
           </a:p>
@@ -858,7 +874,7 @@
           <a:p>
             <a:fld id="{C1FF6DA9-008F-8B48-92A6-B652298478BF}" type="slidenum">
               <a:rPr lang="en-US" smtClean="0"/>
-              <a:t>‹#›</a:t>
+              <a:t>‹Nº›</a:t>
             </a:fld>
             <a:endParaRPr lang="en-US"/>
           </a:p>
@@ -1062,7 +1078,7 @@
           <a:p>
             <a:fld id="{5BCAD085-E8A6-8845-BD4E-CB4CCA059FC4}" type="datetimeFigureOut">
               <a:rPr lang="en-US" smtClean="0"/>
-              <a:t>1/27/13</a:t>
+              <a:t>2/20/2026</a:t>
             </a:fld>
             <a:endParaRPr lang="en-US"/>
           </a:p>
@@ -1104,7 +1120,7 @@
           <a:p>
             <a:fld id="{C1FF6DA9-008F-8B48-92A6-B652298478BF}" type="slidenum">
               <a:rPr lang="en-US" smtClean="0"/>
-              <a:t>‹#›</a:t>
+              <a:t>‹Nº›</a:t>
             </a:fld>
             <a:endParaRPr lang="en-US"/>
           </a:p>
@@ -1350,7 +1366,7 @@
           <a:p>
             <a:fld id="{5BCAD085-E8A6-8845-BD4E-CB4CCA059FC4}" type="datetimeFigureOut">
               <a:rPr lang="en-US" smtClean="0"/>
-              <a:t>1/27/13</a:t>
+              <a:t>2/20/2026</a:t>
             </a:fld>
             <a:endParaRPr lang="en-US"/>
           </a:p>
@@ -1392,7 +1408,7 @@
           <a:p>
             <a:fld id="{C1FF6DA9-008F-8B48-92A6-B652298478BF}" type="slidenum">
               <a:rPr lang="en-US" smtClean="0"/>
-              <a:t>‹#›</a:t>
+              <a:t>‹Nº›</a:t>
             </a:fld>
             <a:endParaRPr lang="en-US"/>
           </a:p>
@@ -1772,7 +1788,7 @@
           <a:p>
             <a:fld id="{5BCAD085-E8A6-8845-BD4E-CB4CCA059FC4}" type="datetimeFigureOut">
               <a:rPr lang="en-US" smtClean="0"/>
-              <a:t>1/27/13</a:t>
+              <a:t>2/20/2026</a:t>
             </a:fld>
             <a:endParaRPr lang="en-US"/>
           </a:p>
@@ -1814,7 +1830,7 @@
           <a:p>
             <a:fld id="{C1FF6DA9-008F-8B48-92A6-B652298478BF}" type="slidenum">
               <a:rPr lang="en-US" smtClean="0"/>
-              <a:t>‹#›</a:t>
+              <a:t>‹Nº›</a:t>
             </a:fld>
             <a:endParaRPr lang="en-US"/>
           </a:p>
@@ -1890,7 +1906,7 @@
           <a:p>
             <a:fld id="{5BCAD085-E8A6-8845-BD4E-CB4CCA059FC4}" type="datetimeFigureOut">
               <a:rPr lang="en-US" smtClean="0"/>
-              <a:t>1/27/13</a:t>
+              <a:t>2/20/2026</a:t>
             </a:fld>
             <a:endParaRPr lang="en-US"/>
           </a:p>
@@ -1932,7 +1948,7 @@
           <a:p>
             <a:fld id="{C1FF6DA9-008F-8B48-92A6-B652298478BF}" type="slidenum">
               <a:rPr lang="en-US" smtClean="0"/>
-              <a:t>‹#›</a:t>
+              <a:t>‹Nº›</a:t>
             </a:fld>
             <a:endParaRPr lang="en-US"/>
           </a:p>
@@ -1985,7 +2001,7 @@
           <a:p>
             <a:fld id="{5BCAD085-E8A6-8845-BD4E-CB4CCA059FC4}" type="datetimeFigureOut">
               <a:rPr lang="en-US" smtClean="0"/>
-              <a:t>1/27/13</a:t>
+              <a:t>2/20/2026</a:t>
             </a:fld>
             <a:endParaRPr lang="en-US"/>
           </a:p>
@@ -2027,7 +2043,7 @@
           <a:p>
             <a:fld id="{C1FF6DA9-008F-8B48-92A6-B652298478BF}" type="slidenum">
               <a:rPr lang="en-US" smtClean="0"/>
-              <a:t>‹#›</a:t>
+              <a:t>‹Nº›</a:t>
             </a:fld>
             <a:endParaRPr lang="en-US"/>
           </a:p>
@@ -2262,7 +2278,7 @@
           <a:p>
             <a:fld id="{5BCAD085-E8A6-8845-BD4E-CB4CCA059FC4}" type="datetimeFigureOut">
               <a:rPr lang="en-US" smtClean="0"/>
-              <a:t>1/27/13</a:t>
+              <a:t>2/20/2026</a:t>
             </a:fld>
             <a:endParaRPr lang="en-US"/>
           </a:p>
@@ -2304,7 +2320,7 @@
           <a:p>
             <a:fld id="{C1FF6DA9-008F-8B48-92A6-B652298478BF}" type="slidenum">
               <a:rPr lang="en-US" smtClean="0"/>
-              <a:t>‹#›</a:t>
+              <a:t>‹Nº›</a:t>
             </a:fld>
             <a:endParaRPr lang="en-US"/>
           </a:p>
@@ -2515,7 +2531,7 @@
           <a:p>
             <a:fld id="{5BCAD085-E8A6-8845-BD4E-CB4CCA059FC4}" type="datetimeFigureOut">
               <a:rPr lang="en-US" smtClean="0"/>
-              <a:t>1/27/13</a:t>
+              <a:t>2/20/2026</a:t>
             </a:fld>
             <a:endParaRPr lang="en-US"/>
           </a:p>
@@ -2557,7 +2573,7 @@
           <a:p>
             <a:fld id="{C1FF6DA9-008F-8B48-92A6-B652298478BF}" type="slidenum">
               <a:rPr lang="en-US" smtClean="0"/>
-              <a:t>‹#›</a:t>
+              <a:t>‹Nº›</a:t>
             </a:fld>
             <a:endParaRPr lang="en-US"/>
           </a:p>
@@ -2728,7 +2744,7 @@
           <a:p>
             <a:fld id="{5BCAD085-E8A6-8845-BD4E-CB4CCA059FC4}" type="datetimeFigureOut">
               <a:rPr lang="en-US" smtClean="0"/>
-              <a:t>1/27/13</a:t>
+              <a:t>2/20/2026</a:t>
             </a:fld>
             <a:endParaRPr lang="en-US"/>
           </a:p>
@@ -2806,7 +2822,7 @@
           <a:p>
             <a:fld id="{C1FF6DA9-008F-8B48-92A6-B652298478BF}" type="slidenum">
               <a:rPr lang="en-US" smtClean="0"/>
-              <a:t>‹#›</a:t>
+              <a:t>‹Nº›</a:t>
             </a:fld>
             <a:endParaRPr lang="en-US"/>
           </a:p>
@@ -3087,7 +3103,7 @@
 </file>
 
 <file path=ppt/slides/slide1.xml><?xml version="1.0" encoding="utf-8"?>
-<p:sld xmlns:a="http://schemas.openxmlformats.org/drawingml/2006/main" xmlns:p="http://schemas.openxmlformats.org/presentationml/2006/main" xmlns:r="http://schemas.openxmlformats.org/officeDocument/2006/relationships">
+<p:sld xmlns:a="http://schemas.openxmlformats.org/drawingml/2006/main" xmlns:r="http://schemas.openxmlformats.org/officeDocument/2006/relationships" xmlns:p="http://schemas.openxmlformats.org/presentationml/2006/main">
   <p:cSld>
     <p:spTree>
       <p:nvGrpSpPr>
@@ -3095,7 +3111,14 @@
         <p:cNvGrpSpPr/>
         <p:nvPr/>
       </p:nvGrpSpPr>
-      <p:grpSpPr/>
+      <p:grpSpPr>
+        <a:xfrm>
+          <a:off x="0" y="0"/>
+          <a:ext cx="0" cy="0"/>
+          <a:chOff x="0" y="0"/>
+          <a:chExt cx="0" cy="0"/>
+        </a:xfrm>
+      </p:grpSpPr>
       <p:pic>
         <p:nvPicPr>
           <p:cNvPr id="2" name="Picture 1" descr="chatbot-bg-1.jpg"/>
@@ -3160,6 +3183,7 @@
           <a:lstStyle/>
           <a:p>
             <a:pPr algn="ctr"/>
+            <a:endParaRPr/>
           </a:p>
         </p:txBody>
       </p:sp>
@@ -3203,6 +3227,7 @@
           <a:lstStyle/>
           <a:p>
             <a:pPr algn="ctr"/>
+            <a:endParaRPr/>
           </a:p>
         </p:txBody>
       </p:sp>
@@ -3242,73 +3267,6 @@
           </a:p>
         </p:txBody>
       </p:sp>
-      <p:pic>
-        <p:nvPicPr>
-          <p:cNvPr id="6" name="Picture 5" descr="chatbot-bg-1.jpg"/>
-          <p:cNvPicPr>
-            <a:picLocks noChangeAspect="1"/>
-          </p:cNvPicPr>
-          <p:nvPr/>
-        </p:nvPicPr>
-        <p:blipFill>
-          <a:blip r:embed="rId2"/>
-          <a:stretch>
-            <a:fillRect/>
-          </a:stretch>
-        </p:blipFill>
-        <p:spPr>
-          <a:xfrm>
-            <a:off x="6492240" y="1051560"/>
-            <a:ext cx="5212080" cy="5394960"/>
-          </a:xfrm>
-          <a:prstGeom prst="rect">
-            <a:avLst/>
-          </a:prstGeom>
-        </p:spPr>
-      </p:pic>
-      <p:sp>
-        <p:nvSpPr>
-          <p:cNvPr id="7" name="Rounded Rectangle 6"/>
-          <p:cNvSpPr/>
-          <p:nvPr/>
-        </p:nvSpPr>
-        <p:spPr>
-          <a:xfrm>
-            <a:off x="6492240" y="1051560"/>
-            <a:ext cx="5212080" cy="5394960"/>
-          </a:xfrm>
-          <a:prstGeom prst="roundRect">
-            <a:avLst/>
-          </a:prstGeom>
-          <a:noFill/>
-          <a:ln w="17780">
-            <a:solidFill>
-              <a:srgbClr val="FFFFFF"/>
-            </a:solidFill>
-          </a:ln>
-        </p:spPr>
-        <p:style>
-          <a:lnRef idx="1">
-            <a:schemeClr val="accent1"/>
-          </a:lnRef>
-          <a:fillRef idx="3">
-            <a:schemeClr val="accent1"/>
-          </a:fillRef>
-          <a:effectRef idx="2">
-            <a:schemeClr val="accent1"/>
-          </a:effectRef>
-          <a:fontRef idx="minor">
-            <a:schemeClr val="lt1"/>
-          </a:fontRef>
-        </p:style>
-        <p:txBody>
-          <a:bodyPr rtlCol="0" anchor="ctr"/>
-          <a:lstStyle/>
-          <a:p>
-            <a:pPr algn="ctr"/>
-          </a:p>
-        </p:txBody>
-      </p:sp>
       <p:sp>
         <p:nvSpPr>
           <p:cNvPr id="8" name="TextBox 7"/>
@@ -3317,7 +3275,7 @@
         </p:nvSpPr>
         <p:spPr>
           <a:xfrm>
-            <a:off x="777240" y="1234440"/>
+            <a:off x="447436" y="1210600"/>
             <a:ext cx="5486400" cy="1234440"/>
           </a:xfrm>
           <a:prstGeom prst="rect">
@@ -3340,6 +3298,7 @@
               </a:defRPr>
             </a:pPr>
             <a:r>
+              <a:rPr dirty="0"/>
               <a:t>CHATBOT RRHH</a:t>
             </a:r>
           </a:p>
@@ -3353,7 +3312,52 @@
               </a:defRPr>
             </a:pPr>
             <a:r>
-              <a:t>Propuesta ejecutiva para mejorar la experiencia del colaborador y la productividad de RRHH</a:t>
+              <a:rPr dirty="0" err="1"/>
+              <a:t>Propuesta</a:t>
+            </a:r>
+            <a:r>
+              <a:rPr dirty="0"/>
+              <a:t> </a:t>
+            </a:r>
+            <a:r>
+              <a:rPr dirty="0" err="1"/>
+              <a:t>ejecutiva</a:t>
+            </a:r>
+            <a:r>
+              <a:rPr dirty="0"/>
+              <a:t> para </a:t>
+            </a:r>
+            <a:r>
+              <a:rPr dirty="0" err="1"/>
+              <a:t>mejorar</a:t>
+            </a:r>
+            <a:r>
+              <a:rPr dirty="0"/>
+              <a:t> la </a:t>
+            </a:r>
+            <a:r>
+              <a:rPr dirty="0" err="1"/>
+              <a:t>experiencia</a:t>
+            </a:r>
+            <a:r>
+              <a:rPr dirty="0"/>
+              <a:t> del </a:t>
+            </a:r>
+            <a:r>
+              <a:rPr dirty="0" err="1"/>
+              <a:t>colaborador</a:t>
+            </a:r>
+            <a:r>
+              <a:rPr dirty="0"/>
+              <a:t> y la </a:t>
+            </a:r>
+            <a:r>
+              <a:rPr dirty="0" err="1"/>
+              <a:t>productividad</a:t>
+            </a:r>
+            <a:r>
+              <a:rPr dirty="0"/>
+              <a:t> de RRHH</a:t>
             </a:r>
           </a:p>
         </p:txBody>
@@ -3366,7 +3370,7 @@
         </p:nvSpPr>
         <p:spPr>
           <a:xfrm>
-            <a:off x="777240" y="2514600"/>
+            <a:off x="447436" y="3429653"/>
             <a:ext cx="5486400" cy="2148840"/>
           </a:xfrm>
           <a:prstGeom prst="roundRect">
@@ -3396,7 +3400,7 @@
           </a:fontRef>
         </p:style>
         <p:txBody>
-          <a:bodyPr rtlCol="0" anchor="ctr" wrap="square"/>
+          <a:bodyPr wrap="square" rtlCol="0" anchor="ctr"/>
           <a:lstStyle/>
           <a:p>
             <a:pPr algn="l">
@@ -3408,8 +3412,18 @@
               </a:defRPr>
             </a:pPr>
             <a:r>
-              <a:t>Resumen ejecutivo</a:t>
-            </a:r>
+              <a:rPr dirty="0" err="1"/>
+              <a:t>Resumen</a:t>
+            </a:r>
+            <a:r>
+              <a:rPr dirty="0"/>
+              <a:t> </a:t>
+            </a:r>
+            <a:r>
+              <a:rPr dirty="0" err="1"/>
+              <a:t>ejecutivo</a:t>
+            </a:r>
+            <a:endParaRPr dirty="0"/>
           </a:p>
           <a:p>
             <a:pPr algn="l">
@@ -3421,7 +3435,48 @@
               </a:defRPr>
             </a:pPr>
             <a:r>
-              <a:t>• Atención rápida y uniforme para consultas frecuentes.</a:t>
+              <a:rPr dirty="0"/>
+              <a:t>• </a:t>
+            </a:r>
+            <a:r>
+              <a:rPr dirty="0" err="1"/>
+              <a:t>Atención</a:t>
+            </a:r>
+            <a:r>
+              <a:rPr dirty="0"/>
+              <a:t> </a:t>
+            </a:r>
+            <a:r>
+              <a:rPr dirty="0" err="1"/>
+              <a:t>rápida</a:t>
+            </a:r>
+            <a:r>
+              <a:rPr dirty="0"/>
+              <a:t> y </a:t>
+            </a:r>
+            <a:r>
+              <a:rPr dirty="0" err="1"/>
+              <a:t>uniforme</a:t>
+            </a:r>
+            <a:r>
+              <a:rPr dirty="0"/>
+              <a:t> para </a:t>
+            </a:r>
+            <a:r>
+              <a:rPr dirty="0" err="1"/>
+              <a:t>consultas</a:t>
+            </a:r>
+            <a:r>
+              <a:rPr dirty="0"/>
+              <a:t> </a:t>
+            </a:r>
+            <a:r>
+              <a:rPr dirty="0" err="1"/>
+              <a:t>frecuentes</a:t>
+            </a:r>
+            <a:r>
+              <a:rPr dirty="0"/>
+              <a:t>.</a:t>
             </a:r>
           </a:p>
           <a:p>
@@ -3434,7 +3489,64 @@
               </a:defRPr>
             </a:pPr>
             <a:r>
-              <a:t>• Derivación directa a RRHH cuando el caso requiere intervención humana.</a:t>
+              <a:rPr dirty="0"/>
+              <a:t>• </a:t>
+            </a:r>
+            <a:r>
+              <a:rPr dirty="0" err="1"/>
+              <a:t>Derivación</a:t>
+            </a:r>
+            <a:r>
+              <a:rPr dirty="0"/>
+              <a:t> </a:t>
+            </a:r>
+            <a:r>
+              <a:rPr dirty="0" err="1"/>
+              <a:t>directa</a:t>
+            </a:r>
+            <a:r>
+              <a:rPr dirty="0"/>
+              <a:t> a RRHH </a:t>
+            </a:r>
+            <a:r>
+              <a:rPr dirty="0" err="1"/>
+              <a:t>cuando</a:t>
+            </a:r>
+            <a:r>
+              <a:rPr dirty="0"/>
+              <a:t> el </a:t>
+            </a:r>
+            <a:r>
+              <a:rPr dirty="0" err="1"/>
+              <a:t>caso</a:t>
+            </a:r>
+            <a:r>
+              <a:rPr dirty="0"/>
+              <a:t> </a:t>
+            </a:r>
+            <a:r>
+              <a:rPr dirty="0" err="1"/>
+              <a:t>requiere</a:t>
+            </a:r>
+            <a:r>
+              <a:rPr dirty="0"/>
+              <a:t> </a:t>
+            </a:r>
+            <a:r>
+              <a:rPr dirty="0" err="1"/>
+              <a:t>intervención</a:t>
+            </a:r>
+            <a:r>
+              <a:rPr dirty="0"/>
+              <a:t> </a:t>
+            </a:r>
+            <a:r>
+              <a:rPr dirty="0" err="1"/>
+              <a:t>humana</a:t>
+            </a:r>
+            <a:r>
+              <a:rPr dirty="0"/>
+              <a:t>.</a:t>
             </a:r>
           </a:p>
           <a:p>
@@ -3447,64 +3559,98 @@
               </a:defRPr>
             </a:pPr>
             <a:r>
-              <a:t>• Gestión por empresa/sucursal con trazabilidad y métricas de operación.</a:t>
-            </a:r>
-          </a:p>
-        </p:txBody>
-      </p:sp>
-      <p:sp>
-        <p:nvSpPr>
-          <p:cNvPr id="10" name="Rounded Rectangle 9"/>
-          <p:cNvSpPr/>
+              <a:rPr dirty="0"/>
+              <a:t>• </a:t>
+            </a:r>
+            <a:r>
+              <a:rPr dirty="0" err="1"/>
+              <a:t>Gestión</a:t>
+            </a:r>
+            <a:r>
+              <a:rPr dirty="0"/>
+              <a:t> </a:t>
+            </a:r>
+            <a:r>
+              <a:rPr dirty="0" err="1"/>
+              <a:t>por</a:t>
+            </a:r>
+            <a:r>
+              <a:rPr dirty="0"/>
+              <a:t> </a:t>
+            </a:r>
+            <a:r>
+              <a:rPr dirty="0" err="1"/>
+              <a:t>empresa</a:t>
+            </a:r>
+            <a:r>
+              <a:rPr dirty="0"/>
+              <a:t>/</a:t>
+            </a:r>
+            <a:r>
+              <a:rPr dirty="0" err="1"/>
+              <a:t>sucursal</a:t>
+            </a:r>
+            <a:r>
+              <a:rPr dirty="0"/>
+              <a:t> con </a:t>
+            </a:r>
+            <a:r>
+              <a:rPr dirty="0" err="1"/>
+              <a:t>trazabilidad</a:t>
+            </a:r>
+            <a:r>
+              <a:rPr dirty="0"/>
+              <a:t> y </a:t>
+            </a:r>
+            <a:r>
+              <a:rPr dirty="0" err="1"/>
+              <a:t>métricas</a:t>
+            </a:r>
+            <a:r>
+              <a:rPr dirty="0"/>
+              <a:t> de </a:t>
+            </a:r>
+            <a:r>
+              <a:rPr dirty="0" err="1"/>
+              <a:t>operación</a:t>
+            </a:r>
+            <a:r>
+              <a:rPr dirty="0"/>
+              <a:t>.</a:t>
+            </a:r>
+          </a:p>
+        </p:txBody>
+      </p:sp>
+      <p:pic>
+        <p:nvPicPr>
+          <p:cNvPr id="11" name="Imagen 10"/>
+          <p:cNvPicPr>
+            <a:picLocks noChangeAspect="1"/>
+          </p:cNvPicPr>
           <p:nvPr/>
-        </p:nvSpPr>
-        <p:spPr>
-          <a:xfrm>
-            <a:off x="822960" y="5074920"/>
-            <a:ext cx="4754880" cy="566928"/>
-          </a:xfrm>
-          <a:prstGeom prst="roundRect">
+        </p:nvPicPr>
+        <p:blipFill>
+          <a:blip r:embed="rId3">
+            <a:extLst>
+              <a:ext uri="{28A0092B-C50C-407E-A947-70E740481C1C}">
+                <a14:useLocalDpi xmlns:a14="http://schemas.microsoft.com/office/drawing/2010/main" val="0"/>
+              </a:ext>
+            </a:extLst>
+          </a:blip>
+          <a:stretch>
+            <a:fillRect/>
+          </a:stretch>
+        </p:blipFill>
+        <p:spPr>
+          <a:xfrm>
+            <a:off x="6400800" y="1036864"/>
+            <a:ext cx="5323931" cy="4604984"/>
+          </a:xfrm>
+          <a:prstGeom prst="rect">
             <a:avLst/>
           </a:prstGeom>
-          <a:solidFill>
-            <a:srgbClr val="189D75"/>
-          </a:solidFill>
-          <a:ln>
-            <a:noFill/>
-          </a:ln>
-        </p:spPr>
-        <p:style>
-          <a:lnRef idx="1">
-            <a:schemeClr val="accent1"/>
-          </a:lnRef>
-          <a:fillRef idx="3">
-            <a:schemeClr val="accent1"/>
-          </a:fillRef>
-          <a:effectRef idx="2">
-            <a:schemeClr val="accent1"/>
-          </a:effectRef>
-          <a:fontRef idx="minor">
-            <a:schemeClr val="lt1"/>
-          </a:fontRef>
-        </p:style>
-        <p:txBody>
-          <a:bodyPr rtlCol="0" anchor="ctr" wrap="square"/>
-          <a:lstStyle/>
-          <a:p>
-            <a:pPr algn="ctr">
-              <a:defRPr sz="1500" b="1" u="none">
-                <a:solidFill>
-                  <a:srgbClr val="FFFFFF"/>
-                </a:solidFill>
-                <a:latin typeface="Calibri"/>
-              </a:defRPr>
-            </a:pPr>
-            <a:r>
-              <a:t>Objetivo del comité: validar presupuesto y salida productiva</a:t>
-            </a:r>
-          </a:p>
-        </p:txBody>
-      </p:sp>
+        </p:spPr>
+      </p:pic>
     </p:spTree>
   </p:cSld>
   <p:clrMapOvr>
@@ -3514,7 +3660,7 @@
 </file>
 
 <file path=ppt/slides/slide2.xml><?xml version="1.0" encoding="utf-8"?>
-<p:sld xmlns:a="http://schemas.openxmlformats.org/drawingml/2006/main" xmlns:p="http://schemas.openxmlformats.org/presentationml/2006/main" xmlns:r="http://schemas.openxmlformats.org/officeDocument/2006/relationships">
+<p:sld xmlns:a="http://schemas.openxmlformats.org/drawingml/2006/main" xmlns:r="http://schemas.openxmlformats.org/officeDocument/2006/relationships" xmlns:p="http://schemas.openxmlformats.org/presentationml/2006/main">
   <p:cSld>
     <p:spTree>
       <p:nvGrpSpPr>
@@ -3522,7 +3668,14 @@
         <p:cNvGrpSpPr/>
         <p:nvPr/>
       </p:nvGrpSpPr>
-      <p:grpSpPr/>
+      <p:grpSpPr>
+        <a:xfrm>
+          <a:off x="0" y="0"/>
+          <a:ext cx="0" cy="0"/>
+          <a:chOff x="0" y="0"/>
+          <a:chExt cx="0" cy="0"/>
+        </a:xfrm>
+      </p:grpSpPr>
       <p:pic>
         <p:nvPicPr>
           <p:cNvPr id="2" name="Picture 1" descr="chatbot-bg-2.jpg"/>
@@ -3587,6 +3740,7 @@
           <a:lstStyle/>
           <a:p>
             <a:pPr algn="ctr"/>
+            <a:endParaRPr/>
           </a:p>
         </p:txBody>
       </p:sp>
@@ -3630,6 +3784,7 @@
           <a:lstStyle/>
           <a:p>
             <a:pPr algn="ctr"/>
+            <a:endParaRPr/>
           </a:p>
         </p:txBody>
       </p:sp>
@@ -3756,7 +3911,7 @@
           </a:fontRef>
         </p:style>
         <p:txBody>
-          <a:bodyPr rtlCol="0" anchor="ctr" wrap="square"/>
+          <a:bodyPr wrap="square" rtlCol="0" anchor="ctr"/>
           <a:lstStyle/>
           <a:p>
             <a:pPr algn="l">
@@ -3863,7 +4018,7 @@
           </a:fontRef>
         </p:style>
         <p:txBody>
-          <a:bodyPr rtlCol="0" anchor="ctr" wrap="square"/>
+          <a:bodyPr wrap="square" rtlCol="0" anchor="ctr"/>
           <a:lstStyle/>
           <a:p>
             <a:pPr algn="l">
@@ -3941,7 +4096,7 @@
 </file>
 
 <file path=ppt/slides/slide3.xml><?xml version="1.0" encoding="utf-8"?>
-<p:sld xmlns:a="http://schemas.openxmlformats.org/drawingml/2006/main" xmlns:p="http://schemas.openxmlformats.org/presentationml/2006/main" xmlns:r="http://schemas.openxmlformats.org/officeDocument/2006/relationships">
+<p:sld xmlns:a="http://schemas.openxmlformats.org/drawingml/2006/main" xmlns:r="http://schemas.openxmlformats.org/officeDocument/2006/relationships" xmlns:p="http://schemas.openxmlformats.org/presentationml/2006/main">
   <p:cSld>
     <p:spTree>
       <p:nvGrpSpPr>
@@ -3949,7 +4104,14 @@
         <p:cNvGrpSpPr/>
         <p:nvPr/>
       </p:nvGrpSpPr>
-      <p:grpSpPr/>
+      <p:grpSpPr>
+        <a:xfrm>
+          <a:off x="0" y="0"/>
+          <a:ext cx="0" cy="0"/>
+          <a:chOff x="0" y="0"/>
+          <a:chExt cx="0" cy="0"/>
+        </a:xfrm>
+      </p:grpSpPr>
       <p:pic>
         <p:nvPicPr>
           <p:cNvPr id="2" name="Picture 1" descr="chatbot-bg-3.jpg"/>
@@ -4014,6 +4176,7 @@
           <a:lstStyle/>
           <a:p>
             <a:pPr algn="ctr"/>
+            <a:endParaRPr/>
           </a:p>
         </p:txBody>
       </p:sp>
@@ -4057,6 +4220,7 @@
           <a:lstStyle/>
           <a:p>
             <a:pPr algn="ctr"/>
+            <a:endParaRPr/>
           </a:p>
         </p:txBody>
       </p:sp>
@@ -4183,7 +4347,7 @@
           </a:fontRef>
         </p:style>
         <p:txBody>
-          <a:bodyPr rtlCol="0" anchor="ctr" wrap="square"/>
+          <a:bodyPr wrap="square" rtlCol="0" anchor="ctr"/>
           <a:lstStyle/>
           <a:p>
             <a:pPr algn="l">
@@ -4264,7 +4428,7 @@
           </a:fontRef>
         </p:style>
         <p:txBody>
-          <a:bodyPr rtlCol="0" anchor="ctr" wrap="square"/>
+          <a:bodyPr wrap="square" rtlCol="0" anchor="ctr"/>
           <a:lstStyle/>
           <a:p>
             <a:pPr algn="l">
@@ -4358,7 +4522,7 @@
           </a:fontRef>
         </p:style>
         <p:txBody>
-          <a:bodyPr rtlCol="0" anchor="ctr" wrap="square"/>
+          <a:bodyPr wrap="square" rtlCol="0" anchor="ctr"/>
           <a:lstStyle/>
           <a:p>
             <a:pPr algn="l">
@@ -4452,7 +4616,7 @@
           </a:fontRef>
         </p:style>
         <p:txBody>
-          <a:bodyPr rtlCol="0" anchor="ctr" wrap="square"/>
+          <a:bodyPr wrap="square" rtlCol="0" anchor="ctr"/>
           <a:lstStyle/>
           <a:p>
             <a:pPr algn="l">
@@ -4517,7 +4681,7 @@
 </file>
 
 <file path=ppt/slides/slide4.xml><?xml version="1.0" encoding="utf-8"?>
-<p:sld xmlns:a="http://schemas.openxmlformats.org/drawingml/2006/main" xmlns:p="http://schemas.openxmlformats.org/presentationml/2006/main" xmlns:r="http://schemas.openxmlformats.org/officeDocument/2006/relationships">
+<p:sld xmlns:a="http://schemas.openxmlformats.org/drawingml/2006/main" xmlns:r="http://schemas.openxmlformats.org/officeDocument/2006/relationships" xmlns:p="http://schemas.openxmlformats.org/presentationml/2006/main">
   <p:cSld>
     <p:spTree>
       <p:nvGrpSpPr>
@@ -4525,7 +4689,14 @@
         <p:cNvGrpSpPr/>
         <p:nvPr/>
       </p:nvGrpSpPr>
-      <p:grpSpPr/>
+      <p:grpSpPr>
+        <a:xfrm>
+          <a:off x="0" y="0"/>
+          <a:ext cx="0" cy="0"/>
+          <a:chOff x="0" y="0"/>
+          <a:chExt cx="0" cy="0"/>
+        </a:xfrm>
+      </p:grpSpPr>
       <p:pic>
         <p:nvPicPr>
           <p:cNvPr id="2" name="Picture 1" descr="chatbot-bg-1.jpg"/>
@@ -4590,6 +4761,7 @@
           <a:lstStyle/>
           <a:p>
             <a:pPr algn="ctr"/>
+            <a:endParaRPr/>
           </a:p>
         </p:txBody>
       </p:sp>
@@ -4633,6 +4805,7 @@
           <a:lstStyle/>
           <a:p>
             <a:pPr algn="ctr"/>
+            <a:endParaRPr/>
           </a:p>
         </p:txBody>
       </p:sp>
@@ -4729,7 +4902,7 @@
         </p:nvSpPr>
         <p:spPr>
           <a:xfrm>
-            <a:off x="777240" y="2148840"/>
+            <a:off x="289278" y="2155371"/>
             <a:ext cx="2816352" cy="3291840"/>
           </a:xfrm>
           <a:prstGeom prst="roundRect">
@@ -4759,7 +4932,7 @@
           </a:fontRef>
         </p:style>
         <p:txBody>
-          <a:bodyPr rtlCol="0" anchor="ctr" wrap="square"/>
+          <a:bodyPr wrap="square" rtlCol="0" anchor="ctr"/>
           <a:lstStyle/>
           <a:p>
             <a:pPr algn="l">
@@ -4797,7 +4970,7 @@
         </p:nvSpPr>
         <p:spPr>
           <a:xfrm>
-            <a:off x="3657600" y="2148840"/>
+            <a:off x="3236976" y="2155371"/>
             <a:ext cx="2816352" cy="3291840"/>
           </a:xfrm>
           <a:prstGeom prst="roundRect">
@@ -4827,7 +5000,7 @@
           </a:fontRef>
         </p:style>
         <p:txBody>
-          <a:bodyPr rtlCol="0" anchor="ctr" wrap="square"/>
+          <a:bodyPr wrap="square" rtlCol="0" anchor="ctr"/>
           <a:lstStyle/>
           <a:p>
             <a:pPr algn="l">
@@ -4865,7 +5038,7 @@
         </p:nvSpPr>
         <p:spPr>
           <a:xfrm>
-            <a:off x="6537960" y="2148840"/>
+            <a:off x="6172200" y="2155371"/>
             <a:ext cx="2816352" cy="3291840"/>
           </a:xfrm>
           <a:prstGeom prst="roundRect">
@@ -4895,7 +5068,7 @@
           </a:fontRef>
         </p:style>
         <p:txBody>
-          <a:bodyPr rtlCol="0" anchor="ctr" wrap="square"/>
+          <a:bodyPr wrap="square" rtlCol="0" anchor="ctr"/>
           <a:lstStyle/>
           <a:p>
             <a:pPr algn="l">
@@ -4933,7 +5106,7 @@
         </p:nvSpPr>
         <p:spPr>
           <a:xfrm>
-            <a:off x="9418320" y="2148840"/>
+            <a:off x="9107424" y="2155371"/>
             <a:ext cx="2816352" cy="3291840"/>
           </a:xfrm>
           <a:prstGeom prst="roundRect">
@@ -4963,7 +5136,7 @@
           </a:fontRef>
         </p:style>
         <p:txBody>
-          <a:bodyPr rtlCol="0" anchor="ctr" wrap="square"/>
+          <a:bodyPr wrap="square" rtlCol="0" anchor="ctr"/>
           <a:lstStyle/>
           <a:p>
             <a:pPr algn="l">
@@ -5002,7 +5175,7 @@
 </file>
 
 <file path=ppt/slides/slide5.xml><?xml version="1.0" encoding="utf-8"?>
-<p:sld xmlns:a="http://schemas.openxmlformats.org/drawingml/2006/main" xmlns:p="http://schemas.openxmlformats.org/presentationml/2006/main" xmlns:r="http://schemas.openxmlformats.org/officeDocument/2006/relationships">
+<p:sld xmlns:a="http://schemas.openxmlformats.org/drawingml/2006/main" xmlns:r="http://schemas.openxmlformats.org/officeDocument/2006/relationships" xmlns:p="http://schemas.openxmlformats.org/presentationml/2006/main">
   <p:cSld>
     <p:spTree>
       <p:nvGrpSpPr>
@@ -5010,7 +5183,14 @@
         <p:cNvGrpSpPr/>
         <p:nvPr/>
       </p:nvGrpSpPr>
-      <p:grpSpPr/>
+      <p:grpSpPr>
+        <a:xfrm>
+          <a:off x="0" y="0"/>
+          <a:ext cx="0" cy="0"/>
+          <a:chOff x="0" y="0"/>
+          <a:chExt cx="0" cy="0"/>
+        </a:xfrm>
+      </p:grpSpPr>
       <p:pic>
         <p:nvPicPr>
           <p:cNvPr id="2" name="Picture 1" descr="chatbot-bg-2.jpg"/>
@@ -5075,6 +5255,7 @@
           <a:lstStyle/>
           <a:p>
             <a:pPr algn="ctr"/>
+            <a:endParaRPr/>
           </a:p>
         </p:txBody>
       </p:sp>
@@ -5118,6 +5299,7 @@
           <a:lstStyle/>
           <a:p>
             <a:pPr algn="ctr"/>
+            <a:endParaRPr/>
           </a:p>
         </p:txBody>
       </p:sp>
@@ -5244,7 +5426,7 @@
           </a:fontRef>
         </p:style>
         <p:txBody>
-          <a:bodyPr rtlCol="0" anchor="ctr" wrap="square"/>
+          <a:bodyPr wrap="square" rtlCol="0" anchor="ctr"/>
           <a:lstStyle/>
           <a:p>
             <a:pPr algn="l">
@@ -5335,7 +5517,7 @@
 </file>
 
 <file path=ppt/slides/slide6.xml><?xml version="1.0" encoding="utf-8"?>
-<p:sld xmlns:a="http://schemas.openxmlformats.org/drawingml/2006/main" xmlns:p="http://schemas.openxmlformats.org/presentationml/2006/main" xmlns:r="http://schemas.openxmlformats.org/officeDocument/2006/relationships">
+<p:sld xmlns:a="http://schemas.openxmlformats.org/drawingml/2006/main" xmlns:r="http://schemas.openxmlformats.org/officeDocument/2006/relationships" xmlns:p="http://schemas.openxmlformats.org/presentationml/2006/main">
   <p:cSld>
     <p:spTree>
       <p:nvGrpSpPr>
@@ -5343,7 +5525,14 @@
         <p:cNvGrpSpPr/>
         <p:nvPr/>
       </p:nvGrpSpPr>
-      <p:grpSpPr/>
+      <p:grpSpPr>
+        <a:xfrm>
+          <a:off x="0" y="0"/>
+          <a:ext cx="0" cy="0"/>
+          <a:chOff x="0" y="0"/>
+          <a:chExt cx="0" cy="0"/>
+        </a:xfrm>
+      </p:grpSpPr>
       <p:pic>
         <p:nvPicPr>
           <p:cNvPr id="2" name="Picture 1" descr="chatbot-bg-3.jpg"/>
@@ -5408,6 +5597,7 @@
           <a:lstStyle/>
           <a:p>
             <a:pPr algn="ctr"/>
+            <a:endParaRPr/>
           </a:p>
         </p:txBody>
       </p:sp>
@@ -5451,6 +5641,7 @@
           <a:lstStyle/>
           <a:p>
             <a:pPr algn="ctr"/>
+            <a:endParaRPr/>
           </a:p>
         </p:txBody>
       </p:sp>
@@ -5564,7 +5755,7 @@
           </a:fontRef>
         </p:style>
         <p:txBody>
-          <a:bodyPr rtlCol="0" anchor="ctr" wrap="square"/>
+          <a:bodyPr wrap="square" rtlCol="0" anchor="ctr"/>
           <a:lstStyle/>
           <a:p>
             <a:pPr algn="l">
@@ -5671,7 +5862,7 @@
           </a:fontRef>
         </p:style>
         <p:txBody>
-          <a:bodyPr rtlCol="0" anchor="ctr" wrap="square"/>
+          <a:bodyPr wrap="square" rtlCol="0" anchor="ctr"/>
           <a:lstStyle/>
           <a:p>
             <a:pPr algn="l">
@@ -5749,7 +5940,7 @@
 </file>
 
 <file path=ppt/slides/slide7.xml><?xml version="1.0" encoding="utf-8"?>
-<p:sld xmlns:a="http://schemas.openxmlformats.org/drawingml/2006/main" xmlns:p="http://schemas.openxmlformats.org/presentationml/2006/main" xmlns:r="http://schemas.openxmlformats.org/officeDocument/2006/relationships">
+<p:sld xmlns:a="http://schemas.openxmlformats.org/drawingml/2006/main" xmlns:r="http://schemas.openxmlformats.org/officeDocument/2006/relationships" xmlns:p="http://schemas.openxmlformats.org/presentationml/2006/main">
   <p:cSld>
     <p:spTree>
       <p:nvGrpSpPr>
@@ -5757,7 +5948,14 @@
         <p:cNvGrpSpPr/>
         <p:nvPr/>
       </p:nvGrpSpPr>
-      <p:grpSpPr/>
+      <p:grpSpPr>
+        <a:xfrm>
+          <a:off x="0" y="0"/>
+          <a:ext cx="0" cy="0"/>
+          <a:chOff x="0" y="0"/>
+          <a:chExt cx="0" cy="0"/>
+        </a:xfrm>
+      </p:grpSpPr>
       <p:pic>
         <p:nvPicPr>
           <p:cNvPr id="2" name="Picture 1" descr="chatbot-bg-1.jpg"/>
@@ -5822,6 +6020,7 @@
           <a:lstStyle/>
           <a:p>
             <a:pPr algn="ctr"/>
+            <a:endParaRPr/>
           </a:p>
         </p:txBody>
       </p:sp>
@@ -5865,6 +6064,7 @@
           <a:lstStyle/>
           <a:p>
             <a:pPr algn="ctr"/>
+            <a:endParaRPr/>
           </a:p>
         </p:txBody>
       </p:sp>
@@ -5991,7 +6191,7 @@
           </a:fontRef>
         </p:style>
         <p:txBody>
-          <a:bodyPr rtlCol="0" anchor="ctr" wrap="square"/>
+          <a:bodyPr wrap="square" rtlCol="0" anchor="ctr"/>
           <a:lstStyle/>
           <a:p>
             <a:pPr algn="l">
@@ -6085,7 +6285,7 @@
           </a:fontRef>
         </p:style>
         <p:txBody>
-          <a:bodyPr rtlCol="0" anchor="ctr" wrap="square"/>
+          <a:bodyPr wrap="square" rtlCol="0" anchor="ctr"/>
           <a:lstStyle/>
           <a:p>
             <a:pPr algn="l">
@@ -6179,7 +6379,7 @@
           </a:fontRef>
         </p:style>
         <p:txBody>
-          <a:bodyPr rtlCol="0" anchor="ctr" wrap="square"/>
+          <a:bodyPr wrap="square" rtlCol="0" anchor="ctr"/>
           <a:lstStyle/>
           <a:p>
             <a:pPr algn="l">
@@ -6244,7 +6444,7 @@
 </file>
 
 <file path=ppt/slides/slide8.xml><?xml version="1.0" encoding="utf-8"?>
-<p:sld xmlns:a="http://schemas.openxmlformats.org/drawingml/2006/main" xmlns:p="http://schemas.openxmlformats.org/presentationml/2006/main" xmlns:r="http://schemas.openxmlformats.org/officeDocument/2006/relationships">
+<p:sld xmlns:a="http://schemas.openxmlformats.org/drawingml/2006/main" xmlns:r="http://schemas.openxmlformats.org/officeDocument/2006/relationships" xmlns:p="http://schemas.openxmlformats.org/presentationml/2006/main">
   <p:cSld>
     <p:spTree>
       <p:nvGrpSpPr>
@@ -6252,7 +6452,14 @@
         <p:cNvGrpSpPr/>
         <p:nvPr/>
       </p:nvGrpSpPr>
-      <p:grpSpPr/>
+      <p:grpSpPr>
+        <a:xfrm>
+          <a:off x="0" y="0"/>
+          <a:ext cx="0" cy="0"/>
+          <a:chOff x="0" y="0"/>
+          <a:chExt cx="0" cy="0"/>
+        </a:xfrm>
+      </p:grpSpPr>
       <p:pic>
         <p:nvPicPr>
           <p:cNvPr id="2" name="Picture 1" descr="chatbot-bg-2.jpg"/>
@@ -6317,6 +6524,7 @@
           <a:lstStyle/>
           <a:p>
             <a:pPr algn="ctr"/>
+            <a:endParaRPr/>
           </a:p>
         </p:txBody>
       </p:sp>
@@ -6360,6 +6568,7 @@
           <a:lstStyle/>
           <a:p>
             <a:pPr algn="ctr"/>
+            <a:endParaRPr/>
           </a:p>
         </p:txBody>
       </p:sp>
@@ -6486,7 +6695,7 @@
           </a:fontRef>
         </p:style>
         <p:txBody>
-          <a:bodyPr rtlCol="0" anchor="ctr" wrap="square"/>
+          <a:bodyPr wrap="square" rtlCol="0" anchor="ctr"/>
           <a:lstStyle/>
           <a:p>
             <a:pPr algn="l">
@@ -6593,7 +6802,7 @@
           </a:fontRef>
         </p:style>
         <p:txBody>
-          <a:bodyPr rtlCol="0" anchor="ctr" wrap="square"/>
+          <a:bodyPr wrap="square" rtlCol="0" anchor="ctr"/>
           <a:lstStyle/>
           <a:p>
             <a:pPr algn="l">
@@ -6605,6 +6814,7 @@
               </a:defRPr>
             </a:pPr>
             <a:r>
+              <a:rPr dirty="0"/>
               <a:t>IA (Google)</a:t>
             </a:r>
           </a:p>
@@ -6618,8 +6828,22 @@
               </a:defRPr>
             </a:pPr>
             <a:r>
-              <a:t>• USD 60 - 180 / mes</a:t>
-            </a:r>
+              <a:rPr dirty="0"/>
+              <a:t>• USD 60 - </a:t>
+            </a:r>
+            <a:r>
+              <a:rPr dirty="0" smtClean="0"/>
+              <a:t>180 </a:t>
+            </a:r>
+            <a:r>
+              <a:rPr dirty="0"/>
+              <a:t>/ </a:t>
+            </a:r>
+            <a:r>
+              <a:rPr dirty="0" err="1"/>
+              <a:t>mes</a:t>
+            </a:r>
+            <a:endParaRPr dirty="0"/>
           </a:p>
           <a:p>
             <a:pPr algn="l">
@@ -6631,8 +6855,14 @@
               </a:defRPr>
             </a:pPr>
             <a:r>
-              <a:t>• AI Studio para pruebas</a:t>
-            </a:r>
+              <a:rPr dirty="0"/>
+              <a:t>• AI Studio para </a:t>
+            </a:r>
+            <a:r>
+              <a:rPr dirty="0" err="1"/>
+              <a:t>pruebas</a:t>
+            </a:r>
+            <a:endParaRPr dirty="0"/>
           </a:p>
           <a:p>
             <a:pPr algn="l">
@@ -6644,8 +6874,14 @@
               </a:defRPr>
             </a:pPr>
             <a:r>
-              <a:t>• Gemini API para producción</a:t>
-            </a:r>
+              <a:rPr dirty="0"/>
+              <a:t>• Gemini API para </a:t>
+            </a:r>
+            <a:r>
+              <a:rPr dirty="0" err="1"/>
+              <a:t>producción</a:t>
+            </a:r>
+            <a:endParaRPr dirty="0"/>
           </a:p>
           <a:p>
             <a:pPr algn="l">
@@ -6657,7 +6893,32 @@
               </a:defRPr>
             </a:pPr>
             <a:r>
-              <a:t>• Costo según consumo real</a:t>
+              <a:rPr dirty="0"/>
+              <a:t>• </a:t>
+            </a:r>
+            <a:r>
+              <a:rPr dirty="0" err="1"/>
+              <a:t>Costo</a:t>
+            </a:r>
+            <a:r>
+              <a:rPr dirty="0"/>
+              <a:t> </a:t>
+            </a:r>
+            <a:r>
+              <a:rPr dirty="0" err="1"/>
+              <a:t>según</a:t>
+            </a:r>
+            <a:r>
+              <a:rPr dirty="0"/>
+              <a:t> </a:t>
+            </a:r>
+            <a:r>
+              <a:rPr dirty="0" err="1"/>
+              <a:t>consumo</a:t>
+            </a:r>
+            <a:r>
+              <a:rPr dirty="0"/>
+              <a:t> real</a:t>
             </a:r>
           </a:p>
         </p:txBody>
@@ -6700,7 +6961,7 @@
           </a:fontRef>
         </p:style>
         <p:txBody>
-          <a:bodyPr rtlCol="0" anchor="ctr" wrap="square"/>
+          <a:bodyPr wrap="square" rtlCol="0" anchor="ctr"/>
           <a:lstStyle/>
           <a:p>
             <a:pPr algn="l">
@@ -6712,6 +6973,7 @@
               </a:defRPr>
             </a:pPr>
             <a:r>
+              <a:rPr dirty="0"/>
               <a:t>WhatsApp Business (AR)</a:t>
             </a:r>
           </a:p>
@@ -6725,8 +6987,14 @@
               </a:defRPr>
             </a:pPr>
             <a:r>
-              <a:t>• USD 80 - 250 / mes</a:t>
-            </a:r>
+              <a:rPr dirty="0"/>
+              <a:t>• USD 80 - 250 / </a:t>
+            </a:r>
+            <a:r>
+              <a:rPr dirty="0" err="1"/>
+              <a:t>mes</a:t>
+            </a:r>
+            <a:endParaRPr dirty="0"/>
           </a:p>
           <a:p>
             <a:pPr algn="l">
@@ -6738,8 +7006,22 @@
               </a:defRPr>
             </a:pPr>
             <a:r>
-              <a:t>• Meta cobra por conversación</a:t>
-            </a:r>
+              <a:rPr dirty="0"/>
+              <a:t>• Meta cobra </a:t>
+            </a:r>
+            <a:r>
+              <a:rPr dirty="0" err="1"/>
+              <a:t>por</a:t>
+            </a:r>
+            <a:r>
+              <a:rPr dirty="0"/>
+              <a:t> </a:t>
+            </a:r>
+            <a:r>
+              <a:rPr dirty="0" err="1"/>
+              <a:t>conversación</a:t>
+            </a:r>
+            <a:endParaRPr dirty="0"/>
           </a:p>
           <a:p>
             <a:pPr algn="l">
@@ -6751,8 +7033,30 @@
               </a:defRPr>
             </a:pPr>
             <a:r>
-              <a:t>• Se suma proveedor oficial</a:t>
-            </a:r>
+              <a:rPr dirty="0"/>
+              <a:t>• Se </a:t>
+            </a:r>
+            <a:r>
+              <a:rPr dirty="0" err="1"/>
+              <a:t>suma</a:t>
+            </a:r>
+            <a:r>
+              <a:rPr dirty="0"/>
+              <a:t> </a:t>
+            </a:r>
+            <a:r>
+              <a:rPr dirty="0" err="1"/>
+              <a:t>proveedor</a:t>
+            </a:r>
+            <a:r>
+              <a:rPr dirty="0"/>
+              <a:t> </a:t>
+            </a:r>
+            <a:r>
+              <a:rPr dirty="0" err="1"/>
+              <a:t>oficial</a:t>
+            </a:r>
+            <a:endParaRPr dirty="0"/>
           </a:p>
           <a:p>
             <a:pPr algn="l">
@@ -6764,75 +7068,32 @@
               </a:defRPr>
             </a:pPr>
             <a:r>
-              <a:t>• Puede incluir impuestos locales</a:t>
-            </a:r>
-          </a:p>
-        </p:txBody>
-      </p:sp>
-      <p:sp>
-        <p:nvSpPr>
-          <p:cNvPr id="10" name="Rounded Rectangle 9"/>
-          <p:cNvSpPr/>
-          <p:nvPr/>
-        </p:nvSpPr>
-        <p:spPr>
-          <a:xfrm>
-            <a:off x="731520" y="5440680"/>
-            <a:ext cx="3931920" cy="1097280"/>
-          </a:xfrm>
-          <a:prstGeom prst="roundRect">
-            <a:avLst/>
-          </a:prstGeom>
-          <a:solidFill>
-            <a:srgbClr val="FFFFFF"/>
-          </a:solidFill>
-          <a:ln>
-            <a:solidFill>
-              <a:srgbClr val="D2DDF0"/>
-            </a:solidFill>
-          </a:ln>
-        </p:spPr>
-        <p:style>
-          <a:lnRef idx="1">
-            <a:schemeClr val="accent1"/>
-          </a:lnRef>
-          <a:fillRef idx="3">
-            <a:schemeClr val="accent1"/>
-          </a:fillRef>
-          <a:effectRef idx="2">
-            <a:schemeClr val="accent1"/>
-          </a:effectRef>
-          <a:fontRef idx="minor">
-            <a:schemeClr val="lt1"/>
-          </a:fontRef>
-        </p:style>
-        <p:txBody>
-          <a:bodyPr rtlCol="0" anchor="ctr" wrap="square"/>
-          <a:lstStyle/>
-          <a:p>
-            <a:pPr algn="l">
-              <a:defRPr sz="2000" b="1" u="none">
-                <a:solidFill>
-                  <a:srgbClr val="3168DA"/>
-                </a:solidFill>
-                <a:latin typeface="Calibri"/>
-              </a:defRPr>
-            </a:pPr>
-            <a:r>
-              <a:t>Monitoreo y alertas</a:t>
-            </a:r>
-          </a:p>
-          <a:p>
-            <a:pPr algn="l">
-              <a:defRPr sz="1600" b="0" u="none">
-                <a:solidFill>
-                  <a:srgbClr val="1C263C"/>
-                </a:solidFill>
-                <a:latin typeface="Calibri"/>
-              </a:defRPr>
-            </a:pPr>
-            <a:r>
-              <a:t>• USD 0 - 20 / mes | logs, alertas y salud del servicio</a:t>
+              <a:rPr dirty="0"/>
+              <a:t>• </a:t>
+            </a:r>
+            <a:r>
+              <a:rPr dirty="0" err="1"/>
+              <a:t>Puede</a:t>
+            </a:r>
+            <a:r>
+              <a:rPr dirty="0"/>
+              <a:t> </a:t>
+            </a:r>
+            <a:r>
+              <a:rPr dirty="0" err="1"/>
+              <a:t>incluir</a:t>
+            </a:r>
+            <a:r>
+              <a:rPr dirty="0"/>
+              <a:t> </a:t>
+            </a:r>
+            <a:r>
+              <a:rPr dirty="0" err="1"/>
+              <a:t>impuestos</a:t>
+            </a:r>
+            <a:r>
+              <a:rPr dirty="0"/>
+              <a:t> locales</a:t>
             </a:r>
           </a:p>
         </p:txBody>
@@ -6845,7 +7106,7 @@
         </p:nvSpPr>
         <p:spPr>
           <a:xfrm>
-            <a:off x="4892040" y="5669280"/>
+            <a:off x="3718407" y="5669280"/>
             <a:ext cx="4754880" cy="566928"/>
           </a:xfrm>
           <a:prstGeom prst="roundRect">
@@ -6873,7 +7134,7 @@
           </a:fontRef>
         </p:style>
         <p:txBody>
-          <a:bodyPr rtlCol="0" anchor="ctr" wrap="square"/>
+          <a:bodyPr wrap="square" rtlCol="0" anchor="ctr"/>
           <a:lstStyle/>
           <a:p>
             <a:pPr algn="ctr">
@@ -6885,8 +7146,46 @@
               </a:defRPr>
             </a:pPr>
             <a:r>
-              <a:t>Total objetivo: USD 220 - 420 / mes | Presupuesto sugerido: USD 300 + 20% contingencia</a:t>
-            </a:r>
+              <a:rPr dirty="0"/>
+              <a:t>Total </a:t>
+            </a:r>
+            <a:r>
+              <a:rPr dirty="0" err="1"/>
+              <a:t>objetivo</a:t>
+            </a:r>
+            <a:r>
+              <a:rPr dirty="0"/>
+              <a:t>: USD 220 - 420 / </a:t>
+            </a:r>
+            <a:r>
+              <a:rPr dirty="0" err="1"/>
+              <a:t>mes</a:t>
+            </a:r>
+            <a:r>
+              <a:rPr dirty="0"/>
+              <a:t> | </a:t>
+            </a:r>
+            <a:r>
+              <a:rPr dirty="0" err="1"/>
+              <a:t>Presupuesto</a:t>
+            </a:r>
+            <a:r>
+              <a:rPr dirty="0"/>
+              <a:t> </a:t>
+            </a:r>
+            <a:r>
+              <a:rPr dirty="0" err="1"/>
+              <a:t>sugerido</a:t>
+            </a:r>
+            <a:r>
+              <a:rPr dirty="0"/>
+              <a:t>: USD 300 + 20% </a:t>
+            </a:r>
+            <a:r>
+              <a:rPr dirty="0" err="1"/>
+              <a:t>contingencia</a:t>
+            </a:r>
+            <a:endParaRPr dirty="0"/>
           </a:p>
         </p:txBody>
       </p:sp>
@@ -6935,7 +7234,7 @@
 </file>
 
 <file path=ppt/slides/slide9.xml><?xml version="1.0" encoding="utf-8"?>
-<p:sld xmlns:a="http://schemas.openxmlformats.org/drawingml/2006/main" xmlns:p="http://schemas.openxmlformats.org/presentationml/2006/main" xmlns:r="http://schemas.openxmlformats.org/officeDocument/2006/relationships">
+<p:sld xmlns:a="http://schemas.openxmlformats.org/drawingml/2006/main" xmlns:r="http://schemas.openxmlformats.org/officeDocument/2006/relationships" xmlns:p="http://schemas.openxmlformats.org/presentationml/2006/main">
   <p:cSld>
     <p:spTree>
       <p:nvGrpSpPr>
@@ -6943,7 +7242,14 @@
         <p:cNvGrpSpPr/>
         <p:nvPr/>
       </p:nvGrpSpPr>
-      <p:grpSpPr/>
+      <p:grpSpPr>
+        <a:xfrm>
+          <a:off x="0" y="0"/>
+          <a:ext cx="0" cy="0"/>
+          <a:chOff x="0" y="0"/>
+          <a:chExt cx="0" cy="0"/>
+        </a:xfrm>
+      </p:grpSpPr>
       <p:pic>
         <p:nvPicPr>
           <p:cNvPr id="2" name="Picture 1" descr="chatbot-bg-3.jpg"/>
@@ -7008,6 +7314,7 @@
           <a:lstStyle/>
           <a:p>
             <a:pPr algn="ctr"/>
+            <a:endParaRPr/>
           </a:p>
         </p:txBody>
       </p:sp>
@@ -7051,6 +7358,7 @@
           <a:lstStyle/>
           <a:p>
             <a:pPr algn="ctr"/>
+            <a:endParaRPr/>
           </a:p>
         </p:txBody>
       </p:sp>
@@ -7135,7 +7443,7 @@
         <p:spPr>
           <a:xfrm>
             <a:off x="822960" y="2011680"/>
-            <a:ext cx="5349240" cy="3657600"/>
+            <a:ext cx="5120640" cy="3657600"/>
           </a:xfrm>
           <a:prstGeom prst="roundRect">
             <a:avLst/>
@@ -7164,7 +7472,7 @@
           </a:fontRef>
         </p:style>
         <p:txBody>
-          <a:bodyPr rtlCol="0" anchor="ctr" wrap="square"/>
+          <a:bodyPr wrap="square" rtlCol="0" anchor="ctr"/>
           <a:lstStyle/>
           <a:p>
             <a:pPr algn="l">
@@ -7271,7 +7579,7 @@
           </a:fontRef>
         </p:style>
         <p:txBody>
-          <a:bodyPr rtlCol="0" anchor="ctr" wrap="square"/>
+          <a:bodyPr wrap="square" rtlCol="0" anchor="ctr"/>
           <a:lstStyle/>
           <a:p>
             <a:pPr algn="l">
@@ -7283,8 +7591,18 @@
               </a:defRPr>
             </a:pPr>
             <a:r>
-              <a:t>Resultado esperado</a:t>
-            </a:r>
+              <a:rPr dirty="0" err="1"/>
+              <a:t>Resultado</a:t>
+            </a:r>
+            <a:r>
+              <a:rPr dirty="0"/>
+              <a:t> </a:t>
+            </a:r>
+            <a:r>
+              <a:rPr dirty="0" err="1"/>
+              <a:t>esperado</a:t>
+            </a:r>
+            <a:endParaRPr dirty="0"/>
           </a:p>
           <a:p>
             <a:pPr algn="l">
@@ -7296,7 +7614,32 @@
               </a:defRPr>
             </a:pPr>
             <a:r>
-              <a:t>• Mejor experiencia del colaborador.</a:t>
+              <a:rPr dirty="0"/>
+              <a:t>• </a:t>
+            </a:r>
+            <a:r>
+              <a:rPr dirty="0" err="1"/>
+              <a:t>Mejor</a:t>
+            </a:r>
+            <a:r>
+              <a:rPr dirty="0"/>
+              <a:t> </a:t>
+            </a:r>
+            <a:r>
+              <a:rPr dirty="0" err="1"/>
+              <a:t>experiencia</a:t>
+            </a:r>
+            <a:r>
+              <a:rPr dirty="0"/>
+              <a:t> del </a:t>
+            </a:r>
+            <a:r>
+              <a:rPr dirty="0" err="1"/>
+              <a:t>colaborador</a:t>
+            </a:r>
+            <a:r>
+              <a:rPr dirty="0"/>
+              <a:t>.</a:t>
             </a:r>
           </a:p>
           <a:p>
@@ -7309,7 +7652,32 @@
               </a:defRPr>
             </a:pPr>
             <a:r>
-              <a:t>• Reducción de carga operativa de RRHH.</a:t>
+              <a:rPr dirty="0"/>
+              <a:t>• </a:t>
+            </a:r>
+            <a:r>
+              <a:rPr dirty="0" err="1"/>
+              <a:t>Reducción</a:t>
+            </a:r>
+            <a:r>
+              <a:rPr dirty="0"/>
+              <a:t> de </a:t>
+            </a:r>
+            <a:r>
+              <a:rPr dirty="0" err="1"/>
+              <a:t>carga</a:t>
+            </a:r>
+            <a:r>
+              <a:rPr dirty="0"/>
+              <a:t> </a:t>
+            </a:r>
+            <a:r>
+              <a:rPr dirty="0" err="1"/>
+              <a:t>operativa</a:t>
+            </a:r>
+            <a:r>
+              <a:rPr dirty="0"/>
+              <a:t> de RRHH.</a:t>
             </a:r>
           </a:p>
           <a:p>
@@ -7322,7 +7690,24 @@
               </a:defRPr>
             </a:pPr>
             <a:r>
-              <a:t>• Mayor trazabilidad y control de gestión.</a:t>
+              <a:rPr dirty="0"/>
+              <a:t>• Mayor </a:t>
+            </a:r>
+            <a:r>
+              <a:rPr dirty="0" err="1"/>
+              <a:t>trazabilidad</a:t>
+            </a:r>
+            <a:r>
+              <a:rPr dirty="0"/>
+              <a:t> y control de </a:t>
+            </a:r>
+            <a:r>
+              <a:rPr dirty="0" err="1"/>
+              <a:t>gestión</a:t>
+            </a:r>
+            <a:r>
+              <a:rPr dirty="0"/>
+              <a:t>.</a:t>
             </a:r>
           </a:p>
           <a:p>
@@ -7335,7 +7720,40 @@
               </a:defRPr>
             </a:pPr>
             <a:r>
-              <a:t>• Escalabilidad a nuevas empresas/sucursales.</a:t>
+              <a:rPr dirty="0"/>
+              <a:t>• </a:t>
+            </a:r>
+            <a:r>
+              <a:rPr dirty="0" err="1"/>
+              <a:t>Escalabilidad</a:t>
+            </a:r>
+            <a:r>
+              <a:rPr dirty="0"/>
+              <a:t> a </a:t>
+            </a:r>
+            <a:r>
+              <a:rPr dirty="0" err="1"/>
+              <a:t>nuevas</a:t>
+            </a:r>
+            <a:r>
+              <a:rPr dirty="0"/>
+              <a:t> </a:t>
+            </a:r>
+            <a:r>
+              <a:rPr dirty="0" err="1"/>
+              <a:t>empresas</a:t>
+            </a:r>
+            <a:r>
+              <a:rPr dirty="0"/>
+              <a:t>/</a:t>
+            </a:r>
+            <a:r>
+              <a:rPr dirty="0" err="1"/>
+              <a:t>sucursales</a:t>
+            </a:r>
+            <a:r>
+              <a:rPr dirty="0"/>
+              <a:t>.</a:t>
             </a:r>
           </a:p>
         </p:txBody>

</xml_diff>